<commit_message>
UPDATE reprise de partie à la demande au lancement du serveur
</commit_message>
<xml_diff>
--- a/livrables/Workshop2025-26-M1gX-pres.pptx
+++ b/livrables/Workshop2025-26-M1gX-pres.pptx
@@ -118,13 +118,13 @@
   <p:extLst>
     <p:ext uri="{521415D9-36F7-43E2-AB2F-B90AF26B5E84}">
       <p14:sectionLst xmlns:p14="http://schemas.microsoft.com/office/powerpoint/2010/main">
-        <p14:section name="Introduction" id="{de740325-4b49-7c29-150d-7286c2693f4f}">
+        <p14:section name="Introduction" id="{974c8b78-1b18-8dd5-15ee-16a4368251ce}">
           <p14:sldIdLst>
             <p14:sldId id="256"/>
             <p14:sldId id="257"/>
           </p14:sldIdLst>
         </p14:section>
-        <p14:section name="Le jeu" id="{6cbbe960-f4a8-fa9a-f102-82ca35423785}">
+        <p14:section name="Le jeu" id="{5e9220e4-0de0-73f0-1518-2c7d5d67ca31}">
           <p14:sldIdLst>
             <p14:sldId id="258"/>
             <p14:sldId id="259"/>
@@ -133,14 +133,14 @@
             <p14:sldId id="262"/>
           </p14:sldIdLst>
         </p14:section>
-        <p14:section name="Technique" id="{c7377ee5-b6a0-faf7-2413-7eafbaf54940}">
+        <p14:section name="Technique" id="{8f3327cf-747d-94de-77a9-5f1e5d304990}">
           <p14:sldIdLst>
             <p14:sldId id="263"/>
             <p14:sldId id="264"/>
             <p14:sldId id="265"/>
           </p14:sldIdLst>
         </p14:section>
-        <p14:section name="Projet" id="{b85f3532-e8c6-5376-2b11-93a05790dfd5}">
+        <p14:section name="Projet" id="{d62de006-cb9f-f0ee-49c1-e2d23d858af2}">
           <p14:sldIdLst>
             <p14:sldId id="266"/>
             <p14:sldId id="267"/>
@@ -1590,7 +1590,7 @@
               <a:t>Qui parle : Membre 1 (protocole) puis Membre 2 · Durée : 40 s
 1. Protocole : l'Arduino envoie par exemple « KNOB 19 » quand on tourne la molette, le Pi répond « LED 3 OK » pour allumer une LED en vert. Une ligne de texte par message : on peut tout tester dans le moniteur série.
 2. Validation : les écrans reçoivent seulement ce qu'ils doivent afficher. Les réponses attendues restent dans le serveur.
-3. Reprise : l'état de la partie est écrit chaque seconde dans un fichier, de façon atomique (pas de fichier à moitié écrit). Le chrono n'avance que quand le serveur tourne : une coupure ne fait pas perdre de temps. Testé en coupant le serveur en pleine partie.
+3. Reprise : l'état de la partie est écrit chaque seconde dans un fichier, de façon atomique (pas de fichier à moitié écrit). Le chrono n'avance que quand le serveur tourne : une coupure ne fait pas perdre de temps. Au redémarrage, on ne relance pas la partie d'office : l'accueil affiche « Partie interrompue » avec un bouton Reprendre (même salle, même chrono), ou Nouvelle partie. Testé en coupant le serveur en pleine partie.
 4. Score : il récompense la vitesse et pénalise les erreurs ; il est proportionnel au temps restant, donc comparable entre une partie de 20 minutes et une démo courte.
 Si le jury demande : la liste complète des commandes est en tête du sketch Arduino et dans le dossier.</a:t>
             </a:r>
@@ -11118,7 +11118,7 @@
                   <a:schemeClr val="tx1"/>
                 </a:solidFill>
               </a:rPr>
-              <a:t>État écrit chaque seconde (écriture atomique). Après une coupure, la partie reprend au même chrono.</a:t>
+              <a:t>État écrit chaque seconde (écriture atomique). Après une coupure, l'accueil propose de la reprendre au même chrono.</a:t>
             </a:r>
             <a:endParaRPr lang="en-US" sz="1400" dirty="0"/>
           </a:p>

</xml_diff>

<commit_message>
UPDATE présentation : noms et groupe de l'équipe
</commit_message>
<xml_diff>
--- a/livrables/Workshop2025-26-M1gX-pres.pptx
+++ b/livrables/Workshop2025-26-M1gX-pres.pptx
@@ -4,6 +4,9 @@
   <p:sldMasterIdLst>
     <p:sldMasterId id="2147483648" r:id="rId1"/>
   </p:sldMasterIdLst>
+  <p:notesMasterIdLst>
+    <p:notesMasterId r:id="rId14"/>
+  </p:notesMasterIdLst>
   <p:sldIdLst>
     <p:sldId id="256" r:id="rId2"/>
     <p:sldId id="257" r:id="rId3"/>
@@ -18,10 +21,7 @@
     <p:sldId id="266" r:id="rId12"/>
     <p:sldId id="267" r:id="rId13"/>
   </p:sldIdLst>
-  <p:notesMasterIdLst>
-    <p:notesMasterId r:id="rId14"/>
-  </p:notesMasterIdLst>
-  <p:sldSz cx="9144000" cy="5143500"/>
+  <p:sldSz cx="9144000" cy="5143500" type="screen16x9"/>
   <p:notesSz cx="5143500" cy="9144000"/>
   <p:defaultTextStyle>
     <a:lvl1pPr marL="0" algn="l" defTabSz="914400" rtl="0" eaLnBrk="1" latinLnBrk="0" hangingPunct="1">
@@ -118,13 +118,13 @@
   <p:extLst>
     <p:ext uri="{521415D9-36F7-43E2-AB2F-B90AF26B5E84}">
       <p14:sectionLst xmlns:p14="http://schemas.microsoft.com/office/powerpoint/2010/main">
-        <p14:section name="Introduction" id="{974c8b78-1b18-8dd5-15ee-16a4368251ce}">
+        <p14:section name="Introduction" id="{974C8B78-1B18-8DD5-15EE-16A4368251CE}">
           <p14:sldIdLst>
             <p14:sldId id="256"/>
             <p14:sldId id="257"/>
           </p14:sldIdLst>
         </p14:section>
-        <p14:section name="Le jeu" id="{5e9220e4-0de0-73f0-1518-2c7d5d67ca31}">
+        <p14:section name="Le jeu" id="{5E9220E4-0DE0-73F0-1518-2C7D5D67CA31}">
           <p14:sldIdLst>
             <p14:sldId id="258"/>
             <p14:sldId id="259"/>
@@ -133,14 +133,14 @@
             <p14:sldId id="262"/>
           </p14:sldIdLst>
         </p14:section>
-        <p14:section name="Technique" id="{8f3327cf-747d-94de-77a9-5f1e5d304990}">
+        <p14:section name="Technique" id="{8F3327CF-747D-94DE-77A9-5F1E5D304990}">
           <p14:sldIdLst>
             <p14:sldId id="263"/>
             <p14:sldId id="264"/>
             <p14:sldId id="265"/>
           </p14:sldIdLst>
         </p14:section>
-        <p14:section name="Projet" id="{d62de006-cb9f-f0ee-49c1-e2d23d858af2}">
+        <p14:section name="Projet" id="{D62DE006-CB9F-F0EE-49C1-E2D23D858AF2}">
           <p14:sldIdLst>
             <p14:sldId id="266"/>
             <p14:sldId id="267"/>
@@ -177,234 +177,10 @@
           <a:chExt cx="0" cy="0"/>
         </a:xfrm>
       </p:grpSpPr>
-      <p:sp>
-        <p:nvSpPr>
-          <p:cNvPr id="2" name="Header Placeholder 1"/>
-          <p:cNvSpPr>
-            <a:spLocks noGrp="1"/>
-          </p:cNvSpPr>
-          <p:nvPr>
-            <p:ph type="hdr" sz="quarter"/>
-          </p:nvPr>
-        </p:nvSpPr>
-        <p:spPr>
-          <a:xfrm>
-            <a:off x="0" y="0"/>
-            <a:ext cx="2971800" cy="458788"/>
-          </a:xfrm>
-          <a:prstGeom prst="rect">
-            <a:avLst/>
-          </a:prstGeom>
-        </p:spPr>
-        <p:txBody>
-          <a:bodyPr vert="horz" lIns="91440" tIns="45720" rIns="91440" bIns="45720" rtlCol="0"/>
-          <a:lstStyle>
-            <a:lvl1pPr algn="l">
-              <a:defRPr sz="1200"/>
-            </a:lvl1pPr>
-          </a:lstStyle>
-          <a:p>
-            <a:endParaRPr lang="en-US"/>
-          </a:p>
-        </p:txBody>
-      </p:sp>
-      <p:sp>
-        <p:nvSpPr>
-          <p:cNvPr id="3" name="Date Placeholder 2"/>
-          <p:cNvSpPr>
-            <a:spLocks noGrp="1"/>
-          </p:cNvSpPr>
-          <p:nvPr>
-            <p:ph type="dt" idx="1"/>
-          </p:nvPr>
-        </p:nvSpPr>
-        <p:spPr>
-          <a:xfrm>
-            <a:off x="3884613" y="0"/>
-            <a:ext cx="2971800" cy="458788"/>
-          </a:xfrm>
-          <a:prstGeom prst="rect">
-            <a:avLst/>
-          </a:prstGeom>
-        </p:spPr>
-        <p:txBody>
-          <a:bodyPr vert="horz" lIns="91440" tIns="45720" rIns="91440" bIns="45720" rtlCol="0"/>
-          <a:lstStyle>
-            <a:lvl1pPr algn="r">
-              <a:defRPr sz="1200"/>
-            </a:lvl1pPr>
-          </a:lstStyle>
-          <a:p>
-            <a:fld id="{5282F153-3F37-0F45-9E97-73ACFA13230C}" type="datetimeFigureOut">
-              <a:rPr lang="en-US"/>
-              <a:t>7/23/19</a:t>
-            </a:fld>
-            <a:endParaRPr lang="en-US"/>
-          </a:p>
-        </p:txBody>
-      </p:sp>
-      <p:sp>
-        <p:nvSpPr>
-          <p:cNvPr id="4" name="Slide Image Placeholder 3"/>
-          <p:cNvSpPr>
-            <a:spLocks noGrp="1" noRot="1" noChangeAspect="1"/>
-          </p:cNvSpPr>
-          <p:nvPr>
-            <p:ph type="sldImg" idx="2"/>
-          </p:nvPr>
-        </p:nvSpPr>
-        <p:spPr>
-          <a:xfrm>
-            <a:off x="685800" y="1143000"/>
-            <a:ext cx="5486400" cy="3086100"/>
-          </a:xfrm>
-          <a:prstGeom prst="rect">
-            <a:avLst/>
-          </a:prstGeom>
-          <a:noFill/>
-          <a:ln w="12700">
-            <a:solidFill>
-              <a:prstClr val="black"/>
-            </a:solidFill>
-          </a:ln>
-        </p:spPr>
-        <p:txBody>
-          <a:bodyPr vert="horz" lIns="91440" tIns="45720" rIns="91440" bIns="45720" rtlCol="0" anchor="ctr"/>
-          <a:lstStyle/>
-          <a:p>
-            <a:endParaRPr lang="en-US"/>
-          </a:p>
-        </p:txBody>
-      </p:sp>
-      <p:sp>
-        <p:nvSpPr>
-          <p:cNvPr id="5" name="Notes Placeholder 4"/>
-          <p:cNvSpPr>
-            <a:spLocks noGrp="1"/>
-          </p:cNvSpPr>
-          <p:nvPr>
-            <p:ph type="body" sz="quarter" idx="3"/>
-          </p:nvPr>
-        </p:nvSpPr>
-        <p:spPr>
-          <a:xfrm>
-            <a:off x="685800" y="4400550"/>
-            <a:ext cx="5486400" cy="3600450"/>
-          </a:xfrm>
-          <a:prstGeom prst="rect">
-            <a:avLst/>
-          </a:prstGeom>
-        </p:spPr>
-        <p:txBody>
-          <a:bodyPr vert="horz" lIns="91440" tIns="45720" rIns="91440" bIns="45720" rtlCol="0"/>
-          <a:lstStyle/>
-          <a:p>
-            <a:pPr lvl="0"/>
-            <a:r>
-              <a:rPr lang="en-US"/>
-              <a:t>Click to edit Master text styles</a:t>
-            </a:r>
-          </a:p>
-          <a:p>
-            <a:pPr lvl="1"/>
-            <a:r>
-              <a:rPr lang="en-US"/>
-              <a:t>Second level</a:t>
-            </a:r>
-          </a:p>
-          <a:p>
-            <a:pPr lvl="2"/>
-            <a:r>
-              <a:rPr lang="en-US"/>
-              <a:t>Third level</a:t>
-            </a:r>
-          </a:p>
-          <a:p>
-            <a:pPr lvl="3"/>
-            <a:r>
-              <a:rPr lang="en-US"/>
-              <a:t>Fourth level</a:t>
-            </a:r>
-          </a:p>
-          <a:p>
-            <a:pPr lvl="4"/>
-            <a:r>
-              <a:rPr lang="en-US"/>
-              <a:t>Fifth level</a:t>
-            </a:r>
-          </a:p>
-        </p:txBody>
-      </p:sp>
-      <p:sp>
-        <p:nvSpPr>
-          <p:cNvPr id="6" name="Footer Placeholder 5"/>
-          <p:cNvSpPr>
-            <a:spLocks noGrp="1"/>
-          </p:cNvSpPr>
-          <p:nvPr>
-            <p:ph type="ftr" sz="quarter" idx="4"/>
-          </p:nvPr>
-        </p:nvSpPr>
-        <p:spPr>
-          <a:xfrm>
-            <a:off x="0" y="8685213"/>
-            <a:ext cx="2971800" cy="458787"/>
-          </a:xfrm>
-          <a:prstGeom prst="rect">
-            <a:avLst/>
-          </a:prstGeom>
-        </p:spPr>
-        <p:txBody>
-          <a:bodyPr vert="horz" lIns="91440" tIns="45720" rIns="91440" bIns="45720" rtlCol="0" anchor="b"/>
-          <a:lstStyle>
-            <a:lvl1pPr algn="l">
-              <a:defRPr sz="1200"/>
-            </a:lvl1pPr>
-          </a:lstStyle>
-          <a:p>
-            <a:endParaRPr lang="en-US"/>
-          </a:p>
-        </p:txBody>
-      </p:sp>
-      <p:sp>
-        <p:nvSpPr>
-          <p:cNvPr id="7" name="Slide Number Placeholder 6"/>
-          <p:cNvSpPr>
-            <a:spLocks noGrp="1"/>
-          </p:cNvSpPr>
-          <p:nvPr>
-            <p:ph type="sldNum" sz="quarter" idx="5"/>
-          </p:nvPr>
-        </p:nvSpPr>
-        <p:spPr>
-          <a:xfrm>
-            <a:off x="3884613" y="8685213"/>
-            <a:ext cx="2971800" cy="458787"/>
-          </a:xfrm>
-          <a:prstGeom prst="rect">
-            <a:avLst/>
-          </a:prstGeom>
-        </p:spPr>
-        <p:txBody>
-          <a:bodyPr vert="horz" lIns="91440" tIns="45720" rIns="91440" bIns="45720" rtlCol="0" anchor="b"/>
-          <a:lstStyle>
-            <a:lvl1pPr algn="r">
-              <a:defRPr sz="1200"/>
-            </a:lvl1pPr>
-          </a:lstStyle>
-          <a:p>
-            <a:fld id="{CE5E9CC1-C706-0F49-92D6-E571CC5EEA8F}" type="slidenum">
-              <a:rPr lang="en-US"/>
-              <a:t>‹#›</a:t>
-            </a:fld>
-            <a:endParaRPr lang="en-US"/>
-          </a:p>
-        </p:txBody>
-      </p:sp>
     </p:spTree>
     <p:extLst>
       <p:ext uri="{BB962C8B-B14F-4D97-AF65-F5344CB8AC3E}">
-        <p14:creationId xmlns:p14="http://schemas.microsoft.com/office/powerpoint/2010/main" val="1024086991"/>
+        <p14:creationId xmlns:p14="http://schemas.microsoft.com/office/powerpoint/2010/main" val="722869013"/>
       </p:ext>
     </p:extLst>
   </p:cSld>
@@ -556,7 +332,6 @@
 On enchaîne tout de suite sur la présentation de l'équipe, en anglais.
 Version 5 minutes : gardez les slides 1, 2, 3, 4, 6, 8, 10 et 12 (les autres servent pour les questions ou la version longue). Version 8 à 10 minutes : toutes les slides, environ 45 s chacune.</a:t>
             </a:r>
-            <a:endParaRPr lang="en-US" dirty="0"/>
           </a:p>
         </p:txBody>
       </p:sp>
@@ -651,7 +426,6 @@
 - Fiabilité : sauvegarde chaque seconde, le serveur ne plante pas si l'Arduino est débranché (il réessaie toutes les 2 s), et le jeu marche même si MySQL est absent.
 - Plan de secours : image de la carte SD, enveloppes en double, et le jeu tourne aussi sur un PC portable.</a:t>
             </a:r>
-            <a:endParaRPr lang="en-US" dirty="0"/>
           </a:p>
         </p:txBody>
       </p:sp>
@@ -743,7 +517,6 @@
 - GitHub : une issue par tâche, rangée par étape, et un jalon par jour ; le journal de bord nourrit directement le dossier technique.
 - À ADAPTER : citez une difficulté réelle et comment vous l'avez réglée (par exemple la configuration Git multi-comptes, le Sensor Kit sur la R4, ou le plantage EPERM sous Windows).</a:t>
             </a:r>
-            <a:endParaRPr lang="en-US" dirty="0"/>
           </a:p>
         </p:txBody>
       </p:sp>
@@ -836,7 +609,6 @@
 Démo courte : MODULES=chauffage,eclairage DURATION=420 npm start (ou lancer une partie depuis l'écran du Pi).
 Questions probables à préparer : pourquoi pas de HTTPS (ou comment), que se passe-t-il si le Pi plante, comment ajouter une salle, comment rejouer avec d'autres valeurs, combien coûte le matériel, accessibilité (daltonisme, lecture).</a:t>
             </a:r>
-            <a:endParaRPr lang="en-US" dirty="0"/>
           </a:p>
         </p:txBody>
       </p:sp>
@@ -934,7 +706,6 @@
 - Member 5: "I set up the Raspberry Pi, the network, the database and our documentation."
 Transition (last speaker, back to French): « Et maintenant, place au jeu. »</a:t>
             </a:r>
-            <a:endParaRPr lang="en-US" dirty="0"/>
           </a:p>
         </p:txBody>
       </p:sp>
@@ -1028,7 +799,6 @@
 - Les règles en une phrase : 5 salles, 20 minutes, 3 erreurs maximum, et deux équipes qui ne peuvent pas gagner l'une sans l'autre.
 Transition : « Comment ça se joue concrètement ? »</a:t>
             </a:r>
-            <a:endParaRPr lang="en-US" dirty="0"/>
           </a:p>
         </p:txBody>
       </p:sp>
@@ -1123,7 +893,6 @@
 - Chaque salle réussie : animation, LEDs arc-en-ciel et mélodie. Chaque erreur : bip et une barre rouge. 3 erreurs ou fin du chrono : black-out.
 Transition : « Voyons les cinq salles. »</a:t>
             </a:r>
-            <a:endParaRPr lang="en-US" dirty="0"/>
           </a:p>
         </p:txBody>
       </p:sp>
@@ -1218,7 +987,6 @@
 5. Compteur : deux index, une soustraction, puis une conversion en CO₂ avec le chiffre réel de RTE.
 La difficulté monte progressivement, et le QG a une aide au calcul à l'écran (les formules, pas les valeurs).</a:t>
             </a:r>
-            <a:endParaRPr lang="en-US" dirty="0"/>
           </a:p>
         </p:txBody>
       </p:sp>
@@ -1312,7 +1080,6 @@
 - Message clé : la sobriété énergétique, ce sont des gestes simples qui se calculent.
 Transition : « Côté technique, voici ce que voient les joueurs. »</a:t>
             </a:r>
-            <a:endParaRPr lang="en-US" dirty="0"/>
           </a:p>
         </p:txBody>
       </p:sp>
@@ -1407,7 +1174,6 @@
 - Les couleurs reprennent la charte de la CCI : rose pour les actions et les alertes, turquoise pour la réussite.
 - À la fin : un score qui récompense la rapidité, un générique aux couleurs du campus CCI Eure-et-Loir (« Vous avez déjoué le blocus ! »), et une page historique des meilleurs scores.</a:t>
             </a:r>
-            <a:endParaRPr lang="en-US" dirty="0"/>
           </a:p>
         </p:txBody>
       </p:sp>
@@ -1501,7 +1267,6 @@
 - MySQL garde l'historique des parties et les scores ; le jeu fonctionne même si la base est absente.
 - Choix assumé : pas de MQTT ni de cloud, un seul serveur, moins de pièces à faire tomber en panne pendant une partie.</a:t>
             </a:r>
-            <a:endParaRPr lang="en-US" dirty="0"/>
           </a:p>
         </p:txBody>
       </p:sp>
@@ -1594,7 +1359,6 @@
 4. Score : il récompense la vitesse et pénalise les erreurs ; il est proportionnel au temps restant, donc comparable entre une partie de 20 minutes et une démo courte.
 Si le jury demande : la liste complète des commandes est en tête du sketch Arduino et dans le dossier.</a:t>
             </a:r>
-            <a:endParaRPr lang="en-US" dirty="0"/>
           </a:p>
         </p:txBody>
       </p:sp>
@@ -1672,6 +1436,7 @@
         <a:solidFill>
           <a:srgbClr val="061428"/>
         </a:solidFill>
+        <a:effectLst/>
       </p:bgPr>
     </p:bg>
     <p:spTree>
@@ -1704,6 +1469,7 @@
         <a:solidFill>
           <a:srgbClr val="FFFFFF"/>
         </a:solidFill>
+        <a:effectLst/>
       </p:bgPr>
     </p:bg>
     <p:spTree>
@@ -1741,7 +1507,7 @@
           <a:bodyPr wrap="square" lIns="0" tIns="0" rIns="0" bIns="0" rtlCol="0" anchor="ctr"/>
           <a:lstStyle/>
           <a:p>
-            <a:pPr indent="0" marL="0">
+            <a:pPr marL="0" indent="0">
               <a:buNone/>
             </a:pPr>
             <a:r>
@@ -1759,9 +1525,11 @@
       <p:sp>
         <p:nvSpPr>
           <p:cNvPr id="3" name="Text 1"/>
-          <p:cNvSpPr/>
+          <p:cNvSpPr>
+            <a:spLocks noGrp="1"/>
+          </p:cNvSpPr>
           <p:nvPr>
-            <p:ph idx="101" type="title" hasCustomPrompt="1"/>
+            <p:ph type="title" idx="101" hasCustomPrompt="1"/>
           </p:nvPr>
         </p:nvSpPr>
         <p:spPr>
@@ -1778,7 +1546,7 @@
         <p:txBody>
           <a:bodyPr wrap="square" rtlCol="0"/>
           <a:lstStyle>
-            <a:lvl1pPr indent="0" marL="0">
+            <a:lvl1pPr marL="0" indent="0">
               <a:buNone/>
               <a:defRPr lang="en-US" sz="2800" b="1" dirty="0">
                 <a:solidFill>
@@ -1791,7 +1559,7 @@
             </a:lvl1pPr>
           </a:lstStyle>
           <a:p>
-            <a:pPr indent="0" marL="0">
+            <a:pPr marL="0" indent="0">
               <a:buNone/>
             </a:pPr>
             <a:endParaRPr lang="en-US" sz="2800" dirty="0"/>
@@ -1818,7 +1586,7 @@
           </a:prstGeom>
           <a:extLst>
             <a:ext uri="{C572A759-6A51-4108-AA02-DFA0A04FC94B}">
-              <ma14:wrappingTextBoxFlag xmlns:ma14="http://schemas.microsoft.com/office/mac/drawingml/2011/main" val="0"/>
+              <ma14:wrappingTextBoxFlag xmlns:ma14="http://schemas.microsoft.com/office/mac/drawingml/2011/main" xmlns="" val="0"/>
             </a:ext>
           </a:extLst>
         </p:spPr>
@@ -1836,8 +1604,8 @@
           <a:p>
             <a:pPr algn="r"/>
             <a:fld id="{F7021451-1387-4CA6-816F-3879F97B5CBC}" type="slidenum">
-              <a:rPr b="0" lang="en-US"/>
-              <a:t>1003</a:t>
+              <a:rPr lang="en-US" b="0"/>
+              <a:t>‹N°›</a:t>
             </a:fld>
             <a:endParaRPr lang="en-US"/>
           </a:p>
@@ -1859,6 +1627,7 @@
         <a:solidFill>
           <a:srgbClr val="061428"/>
         </a:solidFill>
+        <a:effectLst/>
       </p:bgPr>
     </p:bg>
     <p:spTree>
@@ -1896,7 +1665,7 @@
           <a:bodyPr wrap="square" lIns="0" tIns="0" rIns="0" bIns="0" rtlCol="0" anchor="ctr"/>
           <a:lstStyle/>
           <a:p>
-            <a:pPr indent="0" marL="0">
+            <a:pPr marL="0" indent="0">
               <a:buNone/>
             </a:pPr>
             <a:r>
@@ -1914,9 +1683,11 @@
       <p:sp>
         <p:nvSpPr>
           <p:cNvPr id="3" name="Text 1"/>
-          <p:cNvSpPr/>
+          <p:cNvSpPr>
+            <a:spLocks noGrp="1"/>
+          </p:cNvSpPr>
           <p:nvPr>
-            <p:ph idx="101" type="title" hasCustomPrompt="1"/>
+            <p:ph type="title" idx="101" hasCustomPrompt="1"/>
           </p:nvPr>
         </p:nvSpPr>
         <p:spPr>
@@ -1933,7 +1704,7 @@
         <p:txBody>
           <a:bodyPr wrap="square" rtlCol="0"/>
           <a:lstStyle>
-            <a:lvl1pPr indent="0" marL="0">
+            <a:lvl1pPr marL="0" indent="0">
               <a:buNone/>
               <a:defRPr lang="en-US" sz="2800" b="1" dirty="0">
                 <a:solidFill>
@@ -1946,7 +1717,7 @@
             </a:lvl1pPr>
           </a:lstStyle>
           <a:p>
-            <a:pPr indent="0" marL="0">
+            <a:pPr marL="0" indent="0">
               <a:buNone/>
             </a:pPr>
             <a:endParaRPr lang="en-US" sz="2800" dirty="0"/>
@@ -1973,7 +1744,7 @@
           </a:prstGeom>
           <a:extLst>
             <a:ext uri="{C572A759-6A51-4108-AA02-DFA0A04FC94B}">
-              <ma14:wrappingTextBoxFlag xmlns:ma14="http://schemas.microsoft.com/office/mac/drawingml/2011/main" val="0"/>
+              <ma14:wrappingTextBoxFlag xmlns:ma14="http://schemas.microsoft.com/office/mac/drawingml/2011/main" xmlns="" val="0"/>
             </a:ext>
           </a:extLst>
         </p:spPr>
@@ -1991,8 +1762,8 @@
           <a:p>
             <a:pPr algn="r"/>
             <a:fld id="{F7021451-1387-4CA6-816F-3879F97B5CBC}" type="slidenum">
-              <a:rPr b="0" lang="en-US"/>
-              <a:t>1004</a:t>
+              <a:rPr lang="en-US" b="0"/>
+              <a:t>‹N°›</a:t>
             </a:fld>
             <a:endParaRPr lang="en-US"/>
           </a:p>
@@ -2009,6 +1780,11 @@
 <file path=ppt/slideMasters/slideMaster1.xml><?xml version="1.0" encoding="utf-8"?>
 <p:sldMaster xmlns:a="http://schemas.openxmlformats.org/drawingml/2006/main" xmlns:r="http://schemas.openxmlformats.org/officeDocument/2006/relationships" xmlns:p="http://schemas.openxmlformats.org/presentationml/2006/main">
   <p:cSld>
+    <p:bg>
+      <p:bgRef idx="1001">
+        <a:schemeClr val="bg1"/>
+      </p:bgRef>
+    </p:bg>
     <p:spTree>
       <p:nvGrpSpPr>
         <p:cNvPr id="1" name=""/>
@@ -2043,7 +1819,7 @@
           </a:prstGeom>
           <a:extLst>
             <a:ext uri="{C572A759-6A51-4108-AA02-DFA0A04FC94B}">
-              <ma14:wrappingTextBoxFlag xmlns:ma14="http://schemas.microsoft.com/office/mac/drawingml/2011/main" val="0"/>
+              <ma14:wrappingTextBoxFlag xmlns:ma14="http://schemas.microsoft.com/office/mac/drawingml/2011/main" xmlns="" val="0"/>
             </a:ext>
           </a:extLst>
         </p:spPr>
@@ -2061,8 +1837,8 @@
           <a:p>
             <a:pPr algn="r"/>
             <a:fld id="{F7021451-1387-4CA6-816F-3879F97B5CBC}" type="slidenum">
-              <a:rPr b="0" lang="en-US"/>
-              <a:t>null</a:t>
+              <a:rPr lang="en-US" b="0"/>
+              <a:t>‹N°›</a:t>
             </a:fld>
             <a:endParaRPr lang="en-US"/>
           </a:p>
@@ -2369,11 +2145,11 @@
           <a:bodyPr wrap="square" lIns="0" tIns="0" rIns="0" bIns="0" rtlCol="0" anchor="ctr"/>
           <a:lstStyle/>
           <a:p>
-            <a:pPr indent="0" marL="0">
-              <a:buNone/>
-            </a:pPr>
-            <a:r>
-              <a:rPr lang="en-US" sz="1100" b="1" spc="100" kern="0" dirty="0">
+            <a:pPr marL="0" indent="0">
+              <a:buNone/>
+            </a:pPr>
+            <a:r>
+              <a:rPr lang="en-US" sz="1100" b="1" kern="0" spc="100" dirty="0">
                 <a:solidFill>
                   <a:schemeClr val="accent2"/>
                 </a:solidFill>
@@ -2405,7 +2181,7 @@
           <a:bodyPr wrap="none" lIns="0" tIns="0" rIns="0" bIns="0" rtlCol="0" anchor="t"/>
           <a:lstStyle/>
           <a:p>
-            <a:pPr indent="0" marL="0">
+            <a:pPr marL="0" indent="0">
               <a:buNone/>
             </a:pPr>
             <a:r>
@@ -2419,9 +2195,6 @@
               </a:rPr>
               <a:t>BLACK</a:t>
             </a:r>
-            <a:pPr indent="0" marL="0">
-              <a:buNone/>
-            </a:pPr>
             <a:r>
               <a:rPr lang="en-US" sz="4400" b="1" dirty="0">
                 <a:solidFill>
@@ -2433,9 +2206,6 @@
               </a:rPr>
               <a:t>-</a:t>
             </a:r>
-            <a:pPr indent="0" marL="0">
-              <a:buNone/>
-            </a:pPr>
             <a:r>
               <a:rPr lang="en-US" sz="4400" b="1" dirty="0">
                 <a:solidFill>
@@ -2472,7 +2242,7 @@
           <a:bodyPr wrap="square" lIns="0" tIns="0" rIns="0" bIns="0" rtlCol="0" anchor="t"/>
           <a:lstStyle/>
           <a:p>
-            <a:pPr indent="0" marL="0">
+            <a:pPr marL="0" indent="0">
               <a:buNone/>
             </a:pPr>
             <a:r>
@@ -2508,7 +2278,7 @@
           <a:bodyPr wrap="square" lIns="0" tIns="0" rIns="0" bIns="0" rtlCol="0" anchor="ctr"/>
           <a:lstStyle/>
           <a:p>
-            <a:pPr indent="0" marL="0">
+            <a:pPr marL="0" indent="0">
               <a:buNone/>
             </a:pPr>
             <a:r>
@@ -2549,24 +2319,31 @@
             <a:prstDash val="solid"/>
           </a:ln>
           <a:effectLst>
-            <a:outerShdw sx="100000" sy="100000" kx="0" ky="0" algn="bl" rotWithShape="0" blurRad="101600" dist="38100" dir="5400000">
+            <a:outerShdw blurRad="101600" dist="38100" dir="5400000" algn="bl" rotWithShape="0">
               <a:srgbClr val="000000">
                 <a:alpha val="30000"/>
               </a:srgbClr>
             </a:outerShdw>
           </a:effectLst>
         </p:spPr>
+        <p:txBody>
+          <a:bodyPr/>
+          <a:lstStyle/>
+          <a:p>
+            <a:endParaRPr lang="fr-FR"/>
+          </a:p>
+        </p:txBody>
       </p:sp>
       <p:pic>
         <p:nvPicPr>
-          <p:cNvPr id="7" name="Écran d'accueil du QG" descr="Écran d'accueil du QG">    </p:cNvPr>
+          <p:cNvPr id="7" name="Écran d'accueil du QG" descr="Écran d'accueil du QG"/>
           <p:cNvPicPr>
             <a:picLocks noChangeAspect="1"/>
           </p:cNvPicPr>
           <p:nvPr/>
         </p:nvPicPr>
         <p:blipFill>
-          <a:blip r:embed="rId1"/>
+          <a:blip r:embed="rId3"/>
           <a:stretch>
             <a:fillRect/>
           </a:stretch>
@@ -2602,7 +2379,7 @@
           <a:bodyPr wrap="square" lIns="0" tIns="0" rIns="0" bIns="0" rtlCol="0" anchor="ctr"/>
           <a:lstStyle/>
           <a:p>
-            <a:pPr algn="ctr" indent="0" marL="0">
+            <a:pPr marL="0" indent="0" algn="ctr">
               <a:buNone/>
             </a:pPr>
             <a:r>
@@ -2645,9 +2422,11 @@
       <p:sp>
         <p:nvSpPr>
           <p:cNvPr id="2" name="Text 1"/>
-          <p:cNvSpPr/>
+          <p:cNvSpPr>
+            <a:spLocks noGrp="1"/>
+          </p:cNvSpPr>
           <p:nvPr>
-            <p:ph idx="101" type="title" hasCustomPrompt="1"/>
+            <p:ph type="title" idx="101" hasCustomPrompt="1"/>
           </p:nvPr>
         </p:nvSpPr>
         <p:spPr>
@@ -2665,7 +2444,7 @@
           <a:bodyPr wrap="square" lIns="0" tIns="0" rIns="0" bIns="0" rtlCol="0" anchor="ctr"/>
           <a:lstStyle/>
           <a:p>
-            <a:pPr indent="0" marL="0">
+            <a:pPr marL="0" indent="0">
               <a:buNone/>
             </a:pPr>
             <a:r>
@@ -2707,17 +2486,24 @@
             <a:prstDash val="solid"/>
           </a:ln>
         </p:spPr>
+        <p:txBody>
+          <a:bodyPr/>
+          <a:lstStyle/>
+          <a:p>
+            <a:endParaRPr lang="fr-FR"/>
+          </a:p>
+        </p:txBody>
       </p:sp>
       <p:pic>
         <p:nvPicPr>
-          <p:cNvPr id="4" name="Icône Aucune donnée personnelle" descr="Aucune donnée personnelle">    </p:cNvPr>
+          <p:cNvPr id="4" name="Icône Aucune donnée personnelle" descr="Aucune donnée personnelle"/>
           <p:cNvPicPr>
             <a:picLocks noChangeAspect="1"/>
           </p:cNvPicPr>
           <p:nvPr/>
         </p:nvPicPr>
         <p:blipFill>
-          <a:blip r:embed="rId1"/>
+          <a:blip r:embed="rId3"/>
           <a:stretch>
             <a:fillRect/>
           </a:stretch>
@@ -2753,7 +2539,7 @@
           <a:bodyPr wrap="square" lIns="0" tIns="0" rIns="0" bIns="0" rtlCol="0" anchor="ctr"/>
           <a:lstStyle/>
           <a:p>
-            <a:pPr indent="0" marL="0">
+            <a:pPr marL="0" indent="0">
               <a:buNone/>
             </a:pPr>
             <a:r>
@@ -2767,7 +2553,7 @@
             <a:endParaRPr lang="en-US" sz="1500" dirty="0"/>
           </a:p>
           <a:p>
-            <a:pPr indent="0" marL="0">
+            <a:pPr marL="0" indent="0">
               <a:buNone/>
             </a:pPr>
             <a:r>
@@ -2806,17 +2592,24 @@
             <a:prstDash val="solid"/>
           </a:ln>
         </p:spPr>
+        <p:txBody>
+          <a:bodyPr/>
+          <a:lstStyle/>
+          <a:p>
+            <a:endParaRPr lang="fr-FR"/>
+          </a:p>
+        </p:txBody>
       </p:sp>
       <p:pic>
         <p:nvPicPr>
-          <p:cNvPr id="7" name="Icône Chat protégé" descr="Chat protégé">    </p:cNvPr>
+          <p:cNvPr id="7" name="Icône Chat protégé" descr="Chat protégé"/>
           <p:cNvPicPr>
             <a:picLocks noChangeAspect="1"/>
           </p:cNvPicPr>
           <p:nvPr/>
         </p:nvPicPr>
         <p:blipFill>
-          <a:blip r:embed="rId2"/>
+          <a:blip r:embed="rId4"/>
           <a:stretch>
             <a:fillRect/>
           </a:stretch>
@@ -2852,7 +2645,7 @@
           <a:bodyPr wrap="square" lIns="0" tIns="0" rIns="0" bIns="0" rtlCol="0" anchor="ctr"/>
           <a:lstStyle/>
           <a:p>
-            <a:pPr indent="0" marL="0">
+            <a:pPr marL="0" indent="0">
               <a:buNone/>
             </a:pPr>
             <a:r>
@@ -2866,7 +2659,7 @@
             <a:endParaRPr lang="en-US" sz="1500" dirty="0"/>
           </a:p>
           <a:p>
-            <a:pPr indent="0" marL="0">
+            <a:pPr marL="0" indent="0">
               <a:buNone/>
             </a:pPr>
             <a:r>
@@ -2905,17 +2698,24 @@
             <a:prstDash val="solid"/>
           </a:ln>
         </p:spPr>
+        <p:txBody>
+          <a:bodyPr/>
+          <a:lstStyle/>
+          <a:p>
+            <a:endParaRPr lang="fr-FR"/>
+          </a:p>
+        </p:txBody>
       </p:sp>
       <p:pic>
         <p:nvPicPr>
-          <p:cNvPr id="10" name="Icône Pilotage réservé au QG" descr="Pilotage réservé au QG">    </p:cNvPr>
+          <p:cNvPr id="10" name="Icône Pilotage réservé au QG" descr="Pilotage réservé au QG"/>
           <p:cNvPicPr>
             <a:picLocks noChangeAspect="1"/>
           </p:cNvPicPr>
           <p:nvPr/>
         </p:nvPicPr>
         <p:blipFill>
-          <a:blip r:embed="rId3"/>
+          <a:blip r:embed="rId5"/>
           <a:stretch>
             <a:fillRect/>
           </a:stretch>
@@ -2951,7 +2751,7 @@
           <a:bodyPr wrap="square" lIns="0" tIns="0" rIns="0" bIns="0" rtlCol="0" anchor="ctr"/>
           <a:lstStyle/>
           <a:p>
-            <a:pPr indent="0" marL="0">
+            <a:pPr marL="0" indent="0">
               <a:buNone/>
             </a:pPr>
             <a:r>
@@ -2965,7 +2765,7 @@
             <a:endParaRPr lang="en-US" sz="1500" dirty="0"/>
           </a:p>
           <a:p>
-            <a:pPr indent="0" marL="0">
+            <a:pPr marL="0" indent="0">
               <a:buNone/>
             </a:pPr>
             <a:r>
@@ -3004,17 +2804,24 @@
             <a:prstDash val="solid"/>
           </a:ln>
         </p:spPr>
+        <p:txBody>
+          <a:bodyPr/>
+          <a:lstStyle/>
+          <a:p>
+            <a:endParaRPr lang="fr-FR"/>
+          </a:p>
+        </p:txBody>
       </p:sp>
       <p:pic>
         <p:nvPicPr>
-          <p:cNvPr id="13" name="Icône Réseau Wi-Fi fermé" descr="Réseau Wi-Fi fermé">    </p:cNvPr>
+          <p:cNvPr id="13" name="Icône Réseau Wi-Fi fermé" descr="Réseau Wi-Fi fermé"/>
           <p:cNvPicPr>
             <a:picLocks noChangeAspect="1"/>
           </p:cNvPicPr>
           <p:nvPr/>
         </p:nvPicPr>
         <p:blipFill>
-          <a:blip r:embed="rId4"/>
+          <a:blip r:embed="rId6"/>
           <a:stretch>
             <a:fillRect/>
           </a:stretch>
@@ -3050,7 +2857,7 @@
           <a:bodyPr wrap="square" lIns="0" tIns="0" rIns="0" bIns="0" rtlCol="0" anchor="ctr"/>
           <a:lstStyle/>
           <a:p>
-            <a:pPr indent="0" marL="0">
+            <a:pPr marL="0" indent="0">
               <a:buNone/>
             </a:pPr>
             <a:r>
@@ -3064,7 +2871,7 @@
             <a:endParaRPr lang="en-US" sz="1500" dirty="0"/>
           </a:p>
           <a:p>
-            <a:pPr indent="0" marL="0">
+            <a:pPr marL="0" indent="0">
               <a:buNone/>
             </a:pPr>
             <a:r>
@@ -3103,17 +2910,24 @@
             <a:prstDash val="solid"/>
           </a:ln>
         </p:spPr>
+        <p:txBody>
+          <a:bodyPr/>
+          <a:lstStyle/>
+          <a:p>
+            <a:endParaRPr lang="fr-FR"/>
+          </a:p>
+        </p:txBody>
       </p:sp>
       <p:pic>
         <p:nvPicPr>
-          <p:cNvPr id="16" name="Icône Reprise après incident" descr="Reprise après incident">    </p:cNvPr>
+          <p:cNvPr id="16" name="Icône Reprise après incident" descr="Reprise après incident"/>
           <p:cNvPicPr>
             <a:picLocks noChangeAspect="1"/>
           </p:cNvPicPr>
           <p:nvPr/>
         </p:nvPicPr>
         <p:blipFill>
-          <a:blip r:embed="rId5"/>
+          <a:blip r:embed="rId7"/>
           <a:stretch>
             <a:fillRect/>
           </a:stretch>
@@ -3149,7 +2963,7 @@
           <a:bodyPr wrap="square" lIns="0" tIns="0" rIns="0" bIns="0" rtlCol="0" anchor="ctr"/>
           <a:lstStyle/>
           <a:p>
-            <a:pPr indent="0" marL="0">
+            <a:pPr marL="0" indent="0">
               <a:buNone/>
             </a:pPr>
             <a:r>
@@ -3163,7 +2977,7 @@
             <a:endParaRPr lang="en-US" sz="1500" dirty="0"/>
           </a:p>
           <a:p>
-            <a:pPr indent="0" marL="0">
+            <a:pPr marL="0" indent="0">
               <a:buNone/>
             </a:pPr>
             <a:r>
@@ -3202,17 +3016,24 @@
             <a:prstDash val="solid"/>
           </a:ln>
         </p:spPr>
+        <p:txBody>
+          <a:bodyPr/>
+          <a:lstStyle/>
+          <a:p>
+            <a:endParaRPr lang="fr-FR"/>
+          </a:p>
+        </p:txBody>
       </p:sp>
       <p:pic>
         <p:nvPicPr>
-          <p:cNvPr id="19" name="Icône Base de données" descr="Base de données">    </p:cNvPr>
+          <p:cNvPr id="19" name="Icône Base de données" descr="Base de données"/>
           <p:cNvPicPr>
             <a:picLocks noChangeAspect="1"/>
           </p:cNvPicPr>
           <p:nvPr/>
         </p:nvPicPr>
         <p:blipFill>
-          <a:blip r:embed="rId6"/>
+          <a:blip r:embed="rId8"/>
           <a:stretch>
             <a:fillRect/>
           </a:stretch>
@@ -3248,7 +3069,7 @@
           <a:bodyPr wrap="square" lIns="0" tIns="0" rIns="0" bIns="0" rtlCol="0" anchor="ctr"/>
           <a:lstStyle/>
           <a:p>
-            <a:pPr indent="0" marL="0">
+            <a:pPr marL="0" indent="0">
               <a:buNone/>
             </a:pPr>
             <a:r>
@@ -3262,7 +3083,7 @@
             <a:endParaRPr lang="en-US" sz="1500" dirty="0"/>
           </a:p>
           <a:p>
-            <a:pPr indent="0" marL="0">
+            <a:pPr marL="0" indent="0">
               <a:buNone/>
             </a:pPr>
             <a:r>
@@ -3303,6 +3124,13 @@
             <a:prstDash val="solid"/>
           </a:ln>
         </p:spPr>
+        <p:txBody>
+          <a:bodyPr/>
+          <a:lstStyle/>
+          <a:p>
+            <a:endParaRPr lang="fr-FR"/>
+          </a:p>
+        </p:txBody>
       </p:sp>
       <p:sp>
         <p:nvSpPr>
@@ -3325,7 +3153,7 @@
           <a:bodyPr wrap="square" lIns="0" tIns="0" rIns="0" bIns="0" rtlCol="0" anchor="ctr"/>
           <a:lstStyle/>
           <a:p>
-            <a:pPr indent="0" marL="0">
+            <a:pPr marL="0" indent="0">
               <a:buNone/>
             </a:pPr>
             <a:r>
@@ -3336,9 +3164,6 @@
               </a:rPr>
               <a:t>Plan de secours  </a:t>
             </a:r>
-            <a:pPr indent="0" marL="0">
-              <a:buNone/>
-            </a:pPr>
             <a:r>
               <a:rPr lang="en-US" sz="1400" dirty="0">
                 <a:solidFill>
@@ -3371,7 +3196,7 @@
           </a:prstGeom>
           <a:extLst>
             <a:ext uri="{C572A759-6A51-4108-AA02-DFA0A04FC94B}">
-              <ma14:wrappingTextBoxFlag xmlns:ma14="http://schemas.microsoft.com/office/mac/drawingml/2011/main" val="0"/>
+              <ma14:wrappingTextBoxFlag xmlns:ma14="http://schemas.microsoft.com/office/mac/drawingml/2011/main" xmlns="" val="0"/>
             </a:ext>
           </a:extLst>
         </p:spPr>
@@ -3389,7 +3214,7 @@
           <a:p>
             <a:pPr algn="r"/>
             <a:fld id="{F7021451-1387-4CA6-816F-3879F97B5CBC}" type="slidenum">
-              <a:rPr b="0" lang="en-US"/>
+              <a:rPr lang="en-US" b="0"/>
               <a:t>10</a:t>
             </a:fld>
             <a:endParaRPr lang="en-US"/>
@@ -3424,9 +3249,11 @@
       <p:sp>
         <p:nvSpPr>
           <p:cNvPr id="2" name="Text 1"/>
-          <p:cNvSpPr/>
+          <p:cNvSpPr>
+            <a:spLocks noGrp="1"/>
+          </p:cNvSpPr>
           <p:nvPr>
-            <p:ph idx="101" type="title" hasCustomPrompt="1"/>
+            <p:ph type="title" idx="101" hasCustomPrompt="1"/>
           </p:nvPr>
         </p:nvSpPr>
         <p:spPr>
@@ -3444,7 +3271,7 @@
           <a:bodyPr wrap="square" lIns="0" tIns="0" rIns="0" bIns="0" rtlCol="0" anchor="ctr"/>
           <a:lstStyle/>
           <a:p>
-            <a:pPr indent="0" marL="0">
+            <a:pPr marL="0" indent="0">
               <a:buNone/>
             </a:pPr>
             <a:r>
@@ -3484,6 +3311,13 @@
             <a:prstDash val="solid"/>
           </a:ln>
         </p:spPr>
+        <p:txBody>
+          <a:bodyPr/>
+          <a:lstStyle/>
+          <a:p>
+            <a:endParaRPr lang="fr-FR"/>
+          </a:p>
+        </p:txBody>
       </p:sp>
       <p:sp>
         <p:nvSpPr>
@@ -3509,6 +3343,13 @@
             <a:prstDash val="solid"/>
           </a:ln>
         </p:spPr>
+        <p:txBody>
+          <a:bodyPr/>
+          <a:lstStyle/>
+          <a:p>
+            <a:endParaRPr lang="fr-FR"/>
+          </a:p>
+        </p:txBody>
       </p:sp>
       <p:sp>
         <p:nvSpPr>
@@ -3531,7 +3372,7 @@
           <a:bodyPr wrap="square" lIns="0" tIns="0" rIns="0" bIns="0" rtlCol="0" anchor="ctr"/>
           <a:lstStyle/>
           <a:p>
-            <a:pPr algn="ctr" indent="0" marL="0">
+            <a:pPr marL="0" indent="0" algn="ctr">
               <a:buNone/>
             </a:pPr>
             <a:r>
@@ -3567,7 +3408,7 @@
           <a:bodyPr wrap="square" lIns="0" tIns="0" rIns="0" bIns="0" rtlCol="0" anchor="t"/>
           <a:lstStyle/>
           <a:p>
-            <a:pPr algn="ctr" indent="0" marL="0">
+            <a:pPr marL="0" indent="0" algn="ctr">
               <a:buNone/>
             </a:pPr>
             <a:r>
@@ -3606,6 +3447,13 @@
             <a:prstDash val="solid"/>
           </a:ln>
         </p:spPr>
+        <p:txBody>
+          <a:bodyPr/>
+          <a:lstStyle/>
+          <a:p>
+            <a:endParaRPr lang="fr-FR"/>
+          </a:p>
+        </p:txBody>
       </p:sp>
       <p:sp>
         <p:nvSpPr>
@@ -3628,7 +3476,7 @@
           <a:bodyPr wrap="square" lIns="0" tIns="0" rIns="0" bIns="0" rtlCol="0" anchor="ctr"/>
           <a:lstStyle/>
           <a:p>
-            <a:pPr algn="ctr" indent="0" marL="0">
+            <a:pPr marL="0" indent="0" algn="ctr">
               <a:buNone/>
             </a:pPr>
             <a:r>
@@ -3664,7 +3512,7 @@
           <a:bodyPr wrap="square" lIns="0" tIns="0" rIns="0" bIns="0" rtlCol="0" anchor="t"/>
           <a:lstStyle/>
           <a:p>
-            <a:pPr algn="ctr" indent="0" marL="0">
+            <a:pPr marL="0" indent="0" algn="ctr">
               <a:buNone/>
             </a:pPr>
             <a:r>
@@ -3703,6 +3551,13 @@
             <a:prstDash val="solid"/>
           </a:ln>
         </p:spPr>
+        <p:txBody>
+          <a:bodyPr/>
+          <a:lstStyle/>
+          <a:p>
+            <a:endParaRPr lang="fr-FR"/>
+          </a:p>
+        </p:txBody>
       </p:sp>
       <p:sp>
         <p:nvSpPr>
@@ -3725,7 +3580,7 @@
           <a:bodyPr wrap="square" lIns="0" tIns="0" rIns="0" bIns="0" rtlCol="0" anchor="ctr"/>
           <a:lstStyle/>
           <a:p>
-            <a:pPr algn="ctr" indent="0" marL="0">
+            <a:pPr marL="0" indent="0" algn="ctr">
               <a:buNone/>
             </a:pPr>
             <a:r>
@@ -3761,7 +3616,7 @@
           <a:bodyPr wrap="square" lIns="0" tIns="0" rIns="0" bIns="0" rtlCol="0" anchor="t"/>
           <a:lstStyle/>
           <a:p>
-            <a:pPr algn="ctr" indent="0" marL="0">
+            <a:pPr marL="0" indent="0" algn="ctr">
               <a:buNone/>
             </a:pPr>
             <a:r>
@@ -3800,6 +3655,13 @@
             <a:prstDash val="solid"/>
           </a:ln>
         </p:spPr>
+        <p:txBody>
+          <a:bodyPr/>
+          <a:lstStyle/>
+          <a:p>
+            <a:endParaRPr lang="fr-FR"/>
+          </a:p>
+        </p:txBody>
       </p:sp>
       <p:sp>
         <p:nvSpPr>
@@ -3822,7 +3684,7 @@
           <a:bodyPr wrap="square" lIns="0" tIns="0" rIns="0" bIns="0" rtlCol="0" anchor="ctr"/>
           <a:lstStyle/>
           <a:p>
-            <a:pPr algn="ctr" indent="0" marL="0">
+            <a:pPr marL="0" indent="0" algn="ctr">
               <a:buNone/>
             </a:pPr>
             <a:r>
@@ -3858,7 +3720,7 @@
           <a:bodyPr wrap="square" lIns="0" tIns="0" rIns="0" bIns="0" rtlCol="0" anchor="t"/>
           <a:lstStyle/>
           <a:p>
-            <a:pPr algn="ctr" indent="0" marL="0">
+            <a:pPr marL="0" indent="0" algn="ctr">
               <a:buNone/>
             </a:pPr>
             <a:r>
@@ -3897,6 +3759,13 @@
             <a:prstDash val="solid"/>
           </a:ln>
         </p:spPr>
+        <p:txBody>
+          <a:bodyPr/>
+          <a:lstStyle/>
+          <a:p>
+            <a:endParaRPr lang="fr-FR"/>
+          </a:p>
+        </p:txBody>
       </p:sp>
       <p:sp>
         <p:nvSpPr>
@@ -3919,7 +3788,7 @@
           <a:bodyPr wrap="square" lIns="0" tIns="0" rIns="0" bIns="0" rtlCol="0" anchor="ctr"/>
           <a:lstStyle/>
           <a:p>
-            <a:pPr algn="ctr" indent="0" marL="0">
+            <a:pPr marL="0" indent="0" algn="ctr">
               <a:buNone/>
             </a:pPr>
             <a:r>
@@ -3955,7 +3824,7 @@
           <a:bodyPr wrap="square" lIns="0" tIns="0" rIns="0" bIns="0" rtlCol="0" anchor="t"/>
           <a:lstStyle/>
           <a:p>
-            <a:pPr algn="ctr" indent="0" marL="0">
+            <a:pPr marL="0" indent="0" algn="ctr">
               <a:buNone/>
             </a:pPr>
             <a:r>
@@ -3996,6 +3865,13 @@
             <a:prstDash val="solid"/>
           </a:ln>
         </p:spPr>
+        <p:txBody>
+          <a:bodyPr/>
+          <a:lstStyle/>
+          <a:p>
+            <a:endParaRPr lang="fr-FR"/>
+          </a:p>
+        </p:txBody>
       </p:sp>
       <p:sp>
         <p:nvSpPr>
@@ -4021,17 +3897,24 @@
             <a:prstDash val="solid"/>
           </a:ln>
         </p:spPr>
+        <p:txBody>
+          <a:bodyPr/>
+          <a:lstStyle/>
+          <a:p>
+            <a:endParaRPr lang="fr-FR"/>
+          </a:p>
+        </p:txBody>
       </p:sp>
       <p:pic>
         <p:nvPicPr>
-          <p:cNvPr id="21" name="Icône GitHub" descr="GitHub">    </p:cNvPr>
+          <p:cNvPr id="21" name="Icône GitHub" descr="GitHub"/>
           <p:cNvPicPr>
             <a:picLocks noChangeAspect="1"/>
           </p:cNvPicPr>
           <p:nvPr/>
         </p:nvPicPr>
         <p:blipFill>
-          <a:blip r:embed="rId1"/>
+          <a:blip r:embed="rId3"/>
           <a:stretch>
             <a:fillRect/>
           </a:stretch>
@@ -4067,7 +3950,7 @@
           <a:bodyPr wrap="square" lIns="0" tIns="0" rIns="0" bIns="0" rtlCol="0" anchor="ctr"/>
           <a:lstStyle/>
           <a:p>
-            <a:pPr indent="0" marL="0">
+            <a:pPr marL="0" indent="0">
               <a:buNone/>
             </a:pPr>
             <a:r>
@@ -4081,7 +3964,7 @@
             <a:endParaRPr lang="en-US" sz="1500" dirty="0"/>
           </a:p>
           <a:p>
-            <a:pPr indent="0" marL="0">
+            <a:pPr marL="0" indent="0">
               <a:buNone/>
             </a:pPr>
             <a:r>
@@ -4122,6 +4005,13 @@
             <a:prstDash val="solid"/>
           </a:ln>
         </p:spPr>
+        <p:txBody>
+          <a:bodyPr/>
+          <a:lstStyle/>
+          <a:p>
+            <a:endParaRPr lang="fr-FR"/>
+          </a:p>
+        </p:txBody>
       </p:sp>
       <p:sp>
         <p:nvSpPr>
@@ -4147,17 +4037,24 @@
             <a:prstDash val="solid"/>
           </a:ln>
         </p:spPr>
+        <p:txBody>
+          <a:bodyPr/>
+          <a:lstStyle/>
+          <a:p>
+            <a:endParaRPr lang="fr-FR"/>
+          </a:p>
+        </p:txBody>
       </p:sp>
       <p:pic>
         <p:nvPicPr>
-          <p:cNvPr id="25" name="Icône Journal de bord" descr="Journal de bord">    </p:cNvPr>
+          <p:cNvPr id="25" name="Icône Journal de bord" descr="Journal de bord"/>
           <p:cNvPicPr>
             <a:picLocks noChangeAspect="1"/>
           </p:cNvPicPr>
           <p:nvPr/>
         </p:nvPicPr>
         <p:blipFill>
-          <a:blip r:embed="rId2"/>
+          <a:blip r:embed="rId4"/>
           <a:stretch>
             <a:fillRect/>
           </a:stretch>
@@ -4193,7 +4090,7 @@
           <a:bodyPr wrap="square" lIns="0" tIns="0" rIns="0" bIns="0" rtlCol="0" anchor="ctr"/>
           <a:lstStyle/>
           <a:p>
-            <a:pPr indent="0" marL="0">
+            <a:pPr marL="0" indent="0">
               <a:buNone/>
             </a:pPr>
             <a:r>
@@ -4207,7 +4104,7 @@
             <a:endParaRPr lang="en-US" sz="1500" dirty="0"/>
           </a:p>
           <a:p>
-            <a:pPr indent="0" marL="0">
+            <a:pPr marL="0" indent="0">
               <a:buNone/>
             </a:pPr>
             <a:r>
@@ -4248,6 +4145,13 @@
             <a:prstDash val="solid"/>
           </a:ln>
         </p:spPr>
+        <p:txBody>
+          <a:bodyPr/>
+          <a:lstStyle/>
+          <a:p>
+            <a:endParaRPr lang="fr-FR"/>
+          </a:p>
+        </p:txBody>
       </p:sp>
       <p:sp>
         <p:nvSpPr>
@@ -4273,17 +4177,24 @@
             <a:prstDash val="solid"/>
           </a:ln>
         </p:spPr>
+        <p:txBody>
+          <a:bodyPr/>
+          <a:lstStyle/>
+          <a:p>
+            <a:endParaRPr lang="fr-FR"/>
+          </a:p>
+        </p:txBody>
       </p:sp>
       <p:pic>
         <p:nvPicPr>
-          <p:cNvPr id="29" name="Icône Rôles tournants" descr="Rôles tournants">    </p:cNvPr>
+          <p:cNvPr id="29" name="Icône Rôles tournants" descr="Rôles tournants"/>
           <p:cNvPicPr>
             <a:picLocks noChangeAspect="1"/>
           </p:cNvPicPr>
           <p:nvPr/>
         </p:nvPicPr>
         <p:blipFill>
-          <a:blip r:embed="rId3"/>
+          <a:blip r:embed="rId5"/>
           <a:stretch>
             <a:fillRect/>
           </a:stretch>
@@ -4319,7 +4230,7 @@
           <a:bodyPr wrap="square" lIns="0" tIns="0" rIns="0" bIns="0" rtlCol="0" anchor="ctr"/>
           <a:lstStyle/>
           <a:p>
-            <a:pPr indent="0" marL="0">
+            <a:pPr marL="0" indent="0">
               <a:buNone/>
             </a:pPr>
             <a:r>
@@ -4333,7 +4244,7 @@
             <a:endParaRPr lang="en-US" sz="1500" dirty="0"/>
           </a:p>
           <a:p>
-            <a:pPr indent="0" marL="0">
+            <a:pPr marL="0" indent="0">
               <a:buNone/>
             </a:pPr>
             <a:r>
@@ -4350,7 +4261,7 @@
       </p:sp>
       <p:sp>
         <p:nvSpPr>
-          <p:cNvPr id="25" name="Slide Number Placeholder 0"/>
+          <p:cNvPr id="31" name="Slide Number Placeholder 0"/>
           <p:cNvSpPr>
             <a:spLocks noGrp="1"/>
           </p:cNvSpPr>
@@ -4368,7 +4279,7 @@
           </a:prstGeom>
           <a:extLst>
             <a:ext uri="{C572A759-6A51-4108-AA02-DFA0A04FC94B}">
-              <ma14:wrappingTextBoxFlag xmlns:ma14="http://schemas.microsoft.com/office/mac/drawingml/2011/main" val="0"/>
+              <ma14:wrappingTextBoxFlag xmlns:ma14="http://schemas.microsoft.com/office/mac/drawingml/2011/main" xmlns="" val="0"/>
             </a:ext>
           </a:extLst>
         </p:spPr>
@@ -4386,7 +4297,7 @@
           <a:p>
             <a:pPr algn="r"/>
             <a:fld id="{F7021451-1387-4CA6-816F-3879F97B5CBC}" type="slidenum">
-              <a:rPr b="0" lang="en-US"/>
+              <a:rPr lang="en-US" b="0"/>
               <a:t>11</a:t>
             </a:fld>
             <a:endParaRPr lang="en-US"/>
@@ -4421,9 +4332,11 @@
       <p:sp>
         <p:nvSpPr>
           <p:cNvPr id="2" name="Text 1"/>
-          <p:cNvSpPr/>
+          <p:cNvSpPr>
+            <a:spLocks noGrp="1"/>
+          </p:cNvSpPr>
           <p:nvPr>
-            <p:ph idx="101" type="title" hasCustomPrompt="1"/>
+            <p:ph type="title" idx="101" hasCustomPrompt="1"/>
           </p:nvPr>
         </p:nvSpPr>
         <p:spPr>
@@ -4441,7 +4354,7 @@
           <a:bodyPr wrap="square" lIns="0" tIns="0" rIns="0" bIns="0" rtlCol="0" anchor="ctr"/>
           <a:lstStyle/>
           <a:p>
-            <a:pPr indent="0" marL="0">
+            <a:pPr marL="0" indent="0">
               <a:buNone/>
             </a:pPr>
             <a:r>
@@ -4480,7 +4393,7 @@
           <a:bodyPr wrap="square" lIns="0" tIns="0" rIns="0" bIns="0" rtlCol="0" anchor="t"/>
           <a:lstStyle/>
           <a:p>
-            <a:pPr indent="0" marL="0">
+            <a:pPr marL="0" indent="0">
               <a:spcAft>
                 <a:spcPts val="600"/>
               </a:spcAft>
@@ -4497,7 +4410,7 @@
             <a:endParaRPr lang="en-US" sz="1800" dirty="0"/>
           </a:p>
           <a:p>
-            <a:pPr indent="0" marL="0">
+            <a:pPr marL="0" indent="0">
               <a:spcAft>
                 <a:spcPts val="1800"/>
               </a:spcAft>
@@ -4514,7 +4427,7 @@
             <a:endParaRPr lang="en-US" sz="1800" dirty="0"/>
           </a:p>
           <a:p>
-            <a:pPr indent="0" marL="0">
+            <a:pPr marL="0" indent="0">
               <a:buNone/>
             </a:pPr>
             <a:r>
@@ -4550,7 +4463,7 @@
           <a:bodyPr wrap="square" lIns="0" tIns="0" rIns="0" bIns="0" rtlCol="0" anchor="t"/>
           <a:lstStyle/>
           <a:p>
-            <a:pPr indent="0" marL="0">
+            <a:pPr marL="0" indent="0">
               <a:buNone/>
             </a:pPr>
             <a:r>
@@ -4567,7 +4480,7 @@
             <a:endParaRPr lang="en-US" sz="3200" dirty="0"/>
           </a:p>
           <a:p>
-            <a:pPr indent="0" marL="0">
+            <a:pPr marL="0" indent="0">
               <a:buNone/>
             </a:pPr>
             <a:r>
@@ -4611,24 +4524,31 @@
             <a:prstDash val="solid"/>
           </a:ln>
           <a:effectLst>
-            <a:outerShdw sx="100000" sy="100000" kx="0" ky="0" algn="bl" rotWithShape="0" blurRad="101600" dist="38100" dir="5400000">
+            <a:outerShdw blurRad="101600" dist="38100" dir="5400000" algn="bl" rotWithShape="0">
               <a:srgbClr val="000000">
                 <a:alpha val="30000"/>
               </a:srgbClr>
             </a:outerShdw>
           </a:effectLst>
         </p:spPr>
+        <p:txBody>
+          <a:bodyPr/>
+          <a:lstStyle/>
+          <a:p>
+            <a:endParaRPr lang="fr-FR"/>
+          </a:p>
+        </p:txBody>
       </p:sp>
       <p:pic>
         <p:nvPicPr>
-          <p:cNvPr id="6" name="Générique de fin" descr="Générique de fin">    </p:cNvPr>
+          <p:cNvPr id="6" name="Générique de fin" descr="Générique de fin"/>
           <p:cNvPicPr>
             <a:picLocks noChangeAspect="1"/>
           </p:cNvPicPr>
           <p:nvPr/>
         </p:nvPicPr>
         <p:blipFill>
-          <a:blip r:embed="rId1"/>
+          <a:blip r:embed="rId3"/>
           <a:stretch>
             <a:fillRect/>
           </a:stretch>
@@ -4664,7 +4584,7 @@
           <a:bodyPr wrap="square" lIns="0" tIns="0" rIns="0" bIns="0" rtlCol="0" anchor="ctr"/>
           <a:lstStyle/>
           <a:p>
-            <a:pPr algn="ctr" indent="0" marL="0">
+            <a:pPr marL="0" indent="0" algn="ctr">
               <a:buNone/>
             </a:pPr>
             <a:r>
@@ -4699,7 +4619,7 @@
           </a:prstGeom>
           <a:extLst>
             <a:ext uri="{C572A759-6A51-4108-AA02-DFA0A04FC94B}">
-              <ma14:wrappingTextBoxFlag xmlns:ma14="http://schemas.microsoft.com/office/mac/drawingml/2011/main" val="0"/>
+              <ma14:wrappingTextBoxFlag xmlns:ma14="http://schemas.microsoft.com/office/mac/drawingml/2011/main" xmlns="" val="0"/>
             </a:ext>
           </a:extLst>
         </p:spPr>
@@ -4717,7 +4637,7 @@
           <a:p>
             <a:pPr algn="r"/>
             <a:fld id="{F7021451-1387-4CA6-816F-3879F97B5CBC}" type="slidenum">
-              <a:rPr b="0" lang="en-US"/>
+              <a:rPr lang="en-US" b="0"/>
               <a:t>12</a:t>
             </a:fld>
             <a:endParaRPr lang="en-US"/>
@@ -4752,9 +4672,11 @@
       <p:sp>
         <p:nvSpPr>
           <p:cNvPr id="2" name="Text 1"/>
-          <p:cNvSpPr/>
+          <p:cNvSpPr>
+            <a:spLocks noGrp="1"/>
+          </p:cNvSpPr>
           <p:nvPr>
-            <p:ph idx="101" type="title" hasCustomPrompt="1"/>
+            <p:ph type="title" idx="101" hasCustomPrompt="1"/>
           </p:nvPr>
         </p:nvSpPr>
         <p:spPr>
@@ -4772,7 +4694,7 @@
           <a:bodyPr wrap="square" lIns="0" tIns="0" rIns="0" bIns="0" rtlCol="0" anchor="ctr"/>
           <a:lstStyle/>
           <a:p>
-            <a:pPr indent="0" marL="0">
+            <a:pPr marL="0" indent="0">
               <a:buNone/>
             </a:pPr>
             <a:r>
@@ -4816,6 +4738,13 @@
             <a:prstDash val="solid"/>
           </a:ln>
         </p:spPr>
+        <p:txBody>
+          <a:bodyPr/>
+          <a:lstStyle/>
+          <a:p>
+            <a:endParaRPr lang="fr-FR"/>
+          </a:p>
+        </p:txBody>
       </p:sp>
       <p:sp>
         <p:nvSpPr>
@@ -4841,17 +4770,24 @@
             <a:prstDash val="solid"/>
           </a:ln>
         </p:spPr>
+        <p:txBody>
+          <a:bodyPr/>
+          <a:lstStyle/>
+          <a:p>
+            <a:endParaRPr lang="fr-FR"/>
+          </a:p>
+        </p:txBody>
       </p:sp>
       <p:pic>
         <p:nvPicPr>
-          <p:cNvPr id="5" name="Icône membre 1" descr="membre 1">    </p:cNvPr>
+          <p:cNvPr id="5" name="Icône membre 1" descr="membre 1"/>
           <p:cNvPicPr>
             <a:picLocks noChangeAspect="1"/>
           </p:cNvPicPr>
           <p:nvPr/>
         </p:nvPicPr>
         <p:blipFill>
-          <a:blip r:embed="rId1"/>
+          <a:blip r:embed="rId3"/>
           <a:stretch>
             <a:fillRect/>
           </a:stretch>
@@ -4887,16 +4823,12 @@
           <a:bodyPr wrap="square" lIns="0" tIns="0" rIns="0" bIns="0" rtlCol="0" anchor="ctr"/>
           <a:lstStyle/>
           <a:p>
-            <a:pPr algn="ctr" indent="0" marL="0">
-              <a:buNone/>
-            </a:pPr>
-            <a:r>
-              <a:rPr lang="en-US" sz="1400" b="1" dirty="0">
-                <a:solidFill>
-                  <a:schemeClr val="tx1"/>
-                </a:solidFill>
-              </a:rPr>
-              <a:t>First name LAST NAME</a:t>
+            <a:pPr marL="0" indent="0" algn="ctr">
+              <a:buNone/>
+            </a:pPr>
+            <a:r>
+              <a:rPr lang="en-US" sz="1400" b="1" dirty="0"/>
+              <a:t>Romain MARDARGENT</a:t>
             </a:r>
             <a:endParaRPr lang="en-US" sz="1400" dirty="0"/>
           </a:p>
@@ -4923,7 +4855,7 @@
           <a:bodyPr wrap="square" lIns="0" tIns="0" rIns="0" bIns="0" rtlCol="0" anchor="t"/>
           <a:lstStyle/>
           <a:p>
-            <a:pPr algn="ctr" indent="0" marL="0">
+            <a:pPr marL="0" indent="0" algn="ctr">
               <a:buNone/>
             </a:pPr>
             <a:r>
@@ -4959,7 +4891,7 @@
           <a:bodyPr wrap="square" lIns="0" tIns="0" rIns="0" bIns="0" rtlCol="0" anchor="t"/>
           <a:lstStyle/>
           <a:p>
-            <a:pPr algn="ctr" indent="0" marL="0">
+            <a:pPr marL="0" indent="0" algn="ctr">
               <a:buNone/>
             </a:pPr>
             <a:r>
@@ -5000,6 +4932,13 @@
             <a:prstDash val="solid"/>
           </a:ln>
         </p:spPr>
+        <p:txBody>
+          <a:bodyPr/>
+          <a:lstStyle/>
+          <a:p>
+            <a:endParaRPr lang="fr-FR"/>
+          </a:p>
+        </p:txBody>
       </p:sp>
       <p:sp>
         <p:nvSpPr>
@@ -5025,17 +4964,24 @@
             <a:prstDash val="solid"/>
           </a:ln>
         </p:spPr>
+        <p:txBody>
+          <a:bodyPr/>
+          <a:lstStyle/>
+          <a:p>
+            <a:endParaRPr lang="fr-FR"/>
+          </a:p>
+        </p:txBody>
       </p:sp>
       <p:pic>
         <p:nvPicPr>
-          <p:cNvPr id="11" name="Icône membre 2" descr="membre 2">    </p:cNvPr>
+          <p:cNvPr id="11" name="Icône membre 2" descr="membre 2"/>
           <p:cNvPicPr>
             <a:picLocks noChangeAspect="1"/>
           </p:cNvPicPr>
           <p:nvPr/>
         </p:nvPicPr>
         <p:blipFill>
-          <a:blip r:embed="rId2"/>
+          <a:blip r:embed="rId3"/>
           <a:stretch>
             <a:fillRect/>
           </a:stretch>
@@ -5071,18 +5017,13 @@
           <a:bodyPr wrap="square" lIns="0" tIns="0" rIns="0" bIns="0" rtlCol="0" anchor="ctr"/>
           <a:lstStyle/>
           <a:p>
-            <a:pPr algn="ctr" indent="0" marL="0">
-              <a:buNone/>
-            </a:pPr>
-            <a:r>
-              <a:rPr lang="en-US" sz="1400" b="1" dirty="0">
-                <a:solidFill>
-                  <a:schemeClr val="tx1"/>
-                </a:solidFill>
-              </a:rPr>
-              <a:t>First name LAST NAME</a:t>
-            </a:r>
-            <a:endParaRPr lang="en-US" sz="1400" dirty="0"/>
+            <a:pPr marL="0" indent="0" algn="ctr">
+              <a:buNone/>
+            </a:pPr>
+            <a:r>
+              <a:rPr lang="en-US" sz="1400" b="1" dirty="0"/>
+              <a:t>Noa GUIGNOLLE</a:t>
+            </a:r>
           </a:p>
         </p:txBody>
       </p:sp>
@@ -5107,7 +5048,7 @@
           <a:bodyPr wrap="square" lIns="0" tIns="0" rIns="0" bIns="0" rtlCol="0" anchor="t"/>
           <a:lstStyle/>
           <a:p>
-            <a:pPr algn="ctr" indent="0" marL="0">
+            <a:pPr marL="0" indent="0" algn="ctr">
               <a:buNone/>
             </a:pPr>
             <a:r>
@@ -5143,7 +5084,7 @@
           <a:bodyPr wrap="square" lIns="0" tIns="0" rIns="0" bIns="0" rtlCol="0" anchor="t"/>
           <a:lstStyle/>
           <a:p>
-            <a:pPr algn="ctr" indent="0" marL="0">
+            <a:pPr marL="0" indent="0" algn="ctr">
               <a:buNone/>
             </a:pPr>
             <a:r>
@@ -5184,6 +5125,13 @@
             <a:prstDash val="solid"/>
           </a:ln>
         </p:spPr>
+        <p:txBody>
+          <a:bodyPr/>
+          <a:lstStyle/>
+          <a:p>
+            <a:endParaRPr lang="fr-FR"/>
+          </a:p>
+        </p:txBody>
       </p:sp>
       <p:sp>
         <p:nvSpPr>
@@ -5209,10 +5157,17 @@
             <a:prstDash val="solid"/>
           </a:ln>
         </p:spPr>
+        <p:txBody>
+          <a:bodyPr/>
+          <a:lstStyle/>
+          <a:p>
+            <a:endParaRPr lang="fr-FR"/>
+          </a:p>
+        </p:txBody>
       </p:sp>
       <p:pic>
         <p:nvPicPr>
-          <p:cNvPr id="17" name="Icône membre 3" descr="membre 3">    </p:cNvPr>
+          <p:cNvPr id="17" name="Icône membre 3" descr="membre 3"/>
           <p:cNvPicPr>
             <a:picLocks noChangeAspect="1"/>
           </p:cNvPicPr>
@@ -5255,7 +5210,7 @@
           <a:bodyPr wrap="square" lIns="0" tIns="0" rIns="0" bIns="0" rtlCol="0" anchor="ctr"/>
           <a:lstStyle/>
           <a:p>
-            <a:pPr algn="ctr" indent="0" marL="0">
+            <a:pPr marL="0" indent="0" algn="ctr">
               <a:buNone/>
             </a:pPr>
             <a:r>
@@ -5264,7 +5219,7 @@
                   <a:schemeClr val="tx1"/>
                 </a:solidFill>
               </a:rPr>
-              <a:t>First name LAST NAME</a:t>
+              <a:t>Tasha BAILLY LE ROCH</a:t>
             </a:r>
             <a:endParaRPr lang="en-US" sz="1400" dirty="0"/>
           </a:p>
@@ -5291,7 +5246,7 @@
           <a:bodyPr wrap="square" lIns="0" tIns="0" rIns="0" bIns="0" rtlCol="0" anchor="t"/>
           <a:lstStyle/>
           <a:p>
-            <a:pPr algn="ctr" indent="0" marL="0">
+            <a:pPr marL="0" indent="0" algn="ctr">
               <a:buNone/>
             </a:pPr>
             <a:r>
@@ -5327,7 +5282,7 @@
           <a:bodyPr wrap="square" lIns="0" tIns="0" rIns="0" bIns="0" rtlCol="0" anchor="t"/>
           <a:lstStyle/>
           <a:p>
-            <a:pPr algn="ctr" indent="0" marL="0">
+            <a:pPr marL="0" indent="0" algn="ctr">
               <a:buNone/>
             </a:pPr>
             <a:r>
@@ -5368,6 +5323,13 @@
             <a:prstDash val="solid"/>
           </a:ln>
         </p:spPr>
+        <p:txBody>
+          <a:bodyPr/>
+          <a:lstStyle/>
+          <a:p>
+            <a:endParaRPr lang="fr-FR"/>
+          </a:p>
+        </p:txBody>
       </p:sp>
       <p:sp>
         <p:nvSpPr>
@@ -5393,17 +5355,24 @@
             <a:prstDash val="solid"/>
           </a:ln>
         </p:spPr>
+        <p:txBody>
+          <a:bodyPr/>
+          <a:lstStyle/>
+          <a:p>
+            <a:endParaRPr lang="fr-FR"/>
+          </a:p>
+        </p:txBody>
       </p:sp>
       <p:pic>
         <p:nvPicPr>
-          <p:cNvPr id="23" name="Icône membre 4" descr="membre 4">    </p:cNvPr>
+          <p:cNvPr id="23" name="Icône membre 4" descr="membre 4"/>
           <p:cNvPicPr>
             <a:picLocks noChangeAspect="1"/>
           </p:cNvPicPr>
           <p:nvPr/>
         </p:nvPicPr>
         <p:blipFill>
-          <a:blip r:embed="rId4"/>
+          <a:blip r:embed="rId3"/>
           <a:stretch>
             <a:fillRect/>
           </a:stretch>
@@ -5439,16 +5408,24 @@
           <a:bodyPr wrap="square" lIns="0" tIns="0" rIns="0" bIns="0" rtlCol="0" anchor="ctr"/>
           <a:lstStyle/>
           <a:p>
-            <a:pPr algn="ctr" indent="0" marL="0">
-              <a:buNone/>
-            </a:pPr>
+            <a:pPr marL="0" indent="0" algn="ctr">
+              <a:buNone/>
+            </a:pPr>
+            <a:r>
+              <a:rPr lang="en-US" sz="1400" b="1" dirty="0" err="1">
+                <a:solidFill>
+                  <a:schemeClr val="tx1"/>
+                </a:solidFill>
+              </a:rPr>
+              <a:t>Killiann</a:t>
+            </a:r>
             <a:r>
               <a:rPr lang="en-US" sz="1400" b="1" dirty="0">
                 <a:solidFill>
                   <a:schemeClr val="tx1"/>
                 </a:solidFill>
               </a:rPr>
-              <a:t>First name LAST NAME</a:t>
+              <a:t> ODDO</a:t>
             </a:r>
             <a:endParaRPr lang="en-US" sz="1400" dirty="0"/>
           </a:p>
@@ -5475,7 +5452,7 @@
           <a:bodyPr wrap="square" lIns="0" tIns="0" rIns="0" bIns="0" rtlCol="0" anchor="t"/>
           <a:lstStyle/>
           <a:p>
-            <a:pPr algn="ctr" indent="0" marL="0">
+            <a:pPr marL="0" indent="0" algn="ctr">
               <a:buNone/>
             </a:pPr>
             <a:r>
@@ -5511,7 +5488,7 @@
           <a:bodyPr wrap="square" lIns="0" tIns="0" rIns="0" bIns="0" rtlCol="0" anchor="t"/>
           <a:lstStyle/>
           <a:p>
-            <a:pPr algn="ctr" indent="0" marL="0">
+            <a:pPr marL="0" indent="0" algn="ctr">
               <a:buNone/>
             </a:pPr>
             <a:r>
@@ -5552,6 +5529,13 @@
             <a:prstDash val="solid"/>
           </a:ln>
         </p:spPr>
+        <p:txBody>
+          <a:bodyPr/>
+          <a:lstStyle/>
+          <a:p>
+            <a:endParaRPr lang="fr-FR"/>
+          </a:p>
+        </p:txBody>
       </p:sp>
       <p:sp>
         <p:nvSpPr>
@@ -5577,17 +5561,24 @@
             <a:prstDash val="solid"/>
           </a:ln>
         </p:spPr>
+        <p:txBody>
+          <a:bodyPr/>
+          <a:lstStyle/>
+          <a:p>
+            <a:endParaRPr lang="fr-FR"/>
+          </a:p>
+        </p:txBody>
       </p:sp>
       <p:pic>
         <p:nvPicPr>
-          <p:cNvPr id="29" name="Icône membre 5" descr="membre 5">    </p:cNvPr>
+          <p:cNvPr id="29" name="Icône membre 5" descr="membre 5"/>
           <p:cNvPicPr>
             <a:picLocks noChangeAspect="1"/>
           </p:cNvPicPr>
           <p:nvPr/>
         </p:nvPicPr>
         <p:blipFill>
-          <a:blip r:embed="rId5"/>
+          <a:blip r:embed="rId3"/>
           <a:stretch>
             <a:fillRect/>
           </a:stretch>
@@ -5623,7 +5614,7 @@
           <a:bodyPr wrap="square" lIns="0" tIns="0" rIns="0" bIns="0" rtlCol="0" anchor="ctr"/>
           <a:lstStyle/>
           <a:p>
-            <a:pPr algn="ctr" indent="0" marL="0">
+            <a:pPr marL="0" indent="0" algn="ctr">
               <a:buNone/>
             </a:pPr>
             <a:r>
@@ -5632,7 +5623,7 @@
                   <a:schemeClr val="tx1"/>
                 </a:solidFill>
               </a:rPr>
-              <a:t>First name LAST NAME</a:t>
+              <a:t>Léo LEBLANC</a:t>
             </a:r>
             <a:endParaRPr lang="en-US" sz="1400" dirty="0"/>
           </a:p>
@@ -5659,7 +5650,7 @@
           <a:bodyPr wrap="square" lIns="0" tIns="0" rIns="0" bIns="0" rtlCol="0" anchor="t"/>
           <a:lstStyle/>
           <a:p>
-            <a:pPr algn="ctr" indent="0" marL="0">
+            <a:pPr marL="0" indent="0" algn="ctr">
               <a:buNone/>
             </a:pPr>
             <a:r>
@@ -5695,7 +5686,7 @@
           <a:bodyPr wrap="square" lIns="0" tIns="0" rIns="0" bIns="0" rtlCol="0" anchor="t"/>
           <a:lstStyle/>
           <a:p>
-            <a:pPr algn="ctr" indent="0" marL="0">
+            <a:pPr marL="0" indent="0" algn="ctr">
               <a:buNone/>
             </a:pPr>
             <a:r>
@@ -5731,7 +5722,7 @@
           <a:bodyPr wrap="square" lIns="0" tIns="0" rIns="0" bIns="0" rtlCol="0" anchor="ctr"/>
           <a:lstStyle/>
           <a:p>
-            <a:pPr algn="ctr" indent="0" marL="0">
+            <a:pPr marL="0" indent="0" algn="ctr">
               <a:buNone/>
             </a:pPr>
             <a:r>
@@ -5748,7 +5739,7 @@
       </p:sp>
       <p:sp>
         <p:nvSpPr>
-          <p:cNvPr id="25" name="Slide Number Placeholder 0"/>
+          <p:cNvPr id="34" name="Slide Number Placeholder 0"/>
           <p:cNvSpPr>
             <a:spLocks noGrp="1"/>
           </p:cNvSpPr>
@@ -5766,7 +5757,7 @@
           </a:prstGeom>
           <a:extLst>
             <a:ext uri="{C572A759-6A51-4108-AA02-DFA0A04FC94B}">
-              <ma14:wrappingTextBoxFlag xmlns:ma14="http://schemas.microsoft.com/office/mac/drawingml/2011/main" val="0"/>
+              <ma14:wrappingTextBoxFlag xmlns:ma14="http://schemas.microsoft.com/office/mac/drawingml/2011/main" xmlns="" val="0"/>
             </a:ext>
           </a:extLst>
         </p:spPr>
@@ -5784,7 +5775,7 @@
           <a:p>
             <a:pPr algn="r"/>
             <a:fld id="{F7021451-1387-4CA6-816F-3879F97B5CBC}" type="slidenum">
-              <a:rPr b="0" lang="en-US"/>
+              <a:rPr lang="en-US" b="0"/>
               <a:t>2</a:t>
             </a:fld>
             <a:endParaRPr lang="en-US"/>
@@ -5819,9 +5810,11 @@
       <p:sp>
         <p:nvSpPr>
           <p:cNvPr id="2" name="Text 1"/>
-          <p:cNvSpPr/>
+          <p:cNvSpPr>
+            <a:spLocks noGrp="1"/>
+          </p:cNvSpPr>
           <p:nvPr>
-            <p:ph idx="101" type="title" hasCustomPrompt="1"/>
+            <p:ph type="title" idx="101" hasCustomPrompt="1"/>
           </p:nvPr>
         </p:nvSpPr>
         <p:spPr>
@@ -5839,7 +5832,7 @@
           <a:bodyPr wrap="square" lIns="0" tIns="0" rIns="0" bIns="0" rtlCol="0" anchor="ctr"/>
           <a:lstStyle/>
           <a:p>
-            <a:pPr indent="0" marL="0">
+            <a:pPr marL="0" indent="0">
               <a:buNone/>
             </a:pPr>
             <a:r>
@@ -5878,7 +5871,7 @@
           <a:bodyPr wrap="square" lIns="0" tIns="0" rIns="0" bIns="0" rtlCol="0" anchor="t"/>
           <a:lstStyle/>
           <a:p>
-            <a:pPr indent="0" marL="0">
+            <a:pPr marL="0" indent="0">
               <a:spcAft>
                 <a:spcPts val="1000"/>
               </a:spcAft>
@@ -5895,7 +5888,7 @@
             <a:endParaRPr lang="en-US" sz="1600" dirty="0"/>
           </a:p>
           <a:p>
-            <a:pPr indent="0" marL="0">
+            <a:pPr marL="0" indent="0">
               <a:spcAft>
                 <a:spcPts val="1000"/>
               </a:spcAft>
@@ -5912,7 +5905,7 @@
             <a:endParaRPr lang="en-US" sz="1600" dirty="0"/>
           </a:p>
           <a:p>
-            <a:pPr indent="0" marL="0">
+            <a:pPr marL="0" indent="0">
               <a:buNone/>
             </a:pPr>
             <a:r>
@@ -5953,6 +5946,13 @@
             <a:prstDash val="solid"/>
           </a:ln>
         </p:spPr>
+        <p:txBody>
+          <a:bodyPr/>
+          <a:lstStyle/>
+          <a:p>
+            <a:endParaRPr lang="fr-FR"/>
+          </a:p>
+        </p:txBody>
       </p:sp>
       <p:sp>
         <p:nvSpPr>
@@ -5975,7 +5975,7 @@
           <a:bodyPr wrap="square" lIns="0" tIns="0" rIns="0" bIns="0" rtlCol="0" anchor="ctr"/>
           <a:lstStyle/>
           <a:p>
-            <a:pPr indent="0" marL="0">
+            <a:pPr marL="0" indent="0">
               <a:buNone/>
             </a:pPr>
             <a:r>
@@ -6014,7 +6014,7 @@
           <a:bodyPr wrap="square" lIns="0" tIns="0" rIns="0" bIns="0" rtlCol="0" anchor="t"/>
           <a:lstStyle/>
           <a:p>
-            <a:pPr indent="0" marL="0">
+            <a:pPr marL="0" indent="0">
               <a:buNone/>
             </a:pPr>
             <a:r>
@@ -6055,6 +6055,13 @@
             <a:prstDash val="solid"/>
           </a:ln>
         </p:spPr>
+        <p:txBody>
+          <a:bodyPr/>
+          <a:lstStyle/>
+          <a:p>
+            <a:endParaRPr lang="fr-FR"/>
+          </a:p>
+        </p:txBody>
       </p:sp>
       <p:sp>
         <p:nvSpPr>
@@ -6077,7 +6084,7 @@
           <a:bodyPr wrap="square" lIns="0" tIns="0" rIns="0" bIns="0" rtlCol="0" anchor="ctr"/>
           <a:lstStyle/>
           <a:p>
-            <a:pPr indent="0" marL="0">
+            <a:pPr marL="0" indent="0">
               <a:buNone/>
             </a:pPr>
             <a:r>
@@ -6116,7 +6123,7 @@
           <a:bodyPr wrap="square" lIns="0" tIns="0" rIns="0" bIns="0" rtlCol="0" anchor="t"/>
           <a:lstStyle/>
           <a:p>
-            <a:pPr indent="0" marL="0">
+            <a:pPr marL="0" indent="0">
               <a:buNone/>
             </a:pPr>
             <a:r>
@@ -6157,6 +6164,13 @@
             <a:prstDash val="solid"/>
           </a:ln>
         </p:spPr>
+        <p:txBody>
+          <a:bodyPr/>
+          <a:lstStyle/>
+          <a:p>
+            <a:endParaRPr lang="fr-FR"/>
+          </a:p>
+        </p:txBody>
       </p:sp>
       <p:sp>
         <p:nvSpPr>
@@ -6179,7 +6193,7 @@
           <a:bodyPr wrap="square" lIns="0" tIns="0" rIns="0" bIns="0" rtlCol="0" anchor="ctr"/>
           <a:lstStyle/>
           <a:p>
-            <a:pPr indent="0" marL="0">
+            <a:pPr marL="0" indent="0">
               <a:buNone/>
             </a:pPr>
             <a:r>
@@ -6218,7 +6232,7 @@
           <a:bodyPr wrap="square" lIns="0" tIns="0" rIns="0" bIns="0" rtlCol="0" anchor="t"/>
           <a:lstStyle/>
           <a:p>
-            <a:pPr indent="0" marL="0">
+            <a:pPr marL="0" indent="0">
               <a:buNone/>
             </a:pPr>
             <a:r>
@@ -6259,6 +6273,13 @@
             <a:prstDash val="solid"/>
           </a:ln>
         </p:spPr>
+        <p:txBody>
+          <a:bodyPr/>
+          <a:lstStyle/>
+          <a:p>
+            <a:endParaRPr lang="fr-FR"/>
+          </a:p>
+        </p:txBody>
       </p:sp>
       <p:sp>
         <p:nvSpPr>
@@ -6281,7 +6302,7 @@
           <a:bodyPr wrap="square" lIns="0" tIns="0" rIns="0" bIns="0" rtlCol="0" anchor="ctr"/>
           <a:lstStyle/>
           <a:p>
-            <a:pPr indent="0" marL="0">
+            <a:pPr marL="0" indent="0">
               <a:buNone/>
             </a:pPr>
             <a:r>
@@ -6320,7 +6341,7 @@
           <a:bodyPr wrap="square" lIns="0" tIns="0" rIns="0" bIns="0" rtlCol="0" anchor="t"/>
           <a:lstStyle/>
           <a:p>
-            <a:pPr indent="0" marL="0">
+            <a:pPr marL="0" indent="0">
               <a:buNone/>
             </a:pPr>
             <a:r>
@@ -6355,7 +6376,7 @@
           </a:prstGeom>
           <a:extLst>
             <a:ext uri="{C572A759-6A51-4108-AA02-DFA0A04FC94B}">
-              <ma14:wrappingTextBoxFlag xmlns:ma14="http://schemas.microsoft.com/office/mac/drawingml/2011/main" val="0"/>
+              <ma14:wrappingTextBoxFlag xmlns:ma14="http://schemas.microsoft.com/office/mac/drawingml/2011/main" xmlns="" val="0"/>
             </a:ext>
           </a:extLst>
         </p:spPr>
@@ -6373,7 +6394,7 @@
           <a:p>
             <a:pPr algn="r"/>
             <a:fld id="{F7021451-1387-4CA6-816F-3879F97B5CBC}" type="slidenum">
-              <a:rPr b="0" lang="en-US"/>
+              <a:rPr lang="en-US" b="0"/>
               <a:t>3</a:t>
             </a:fld>
             <a:endParaRPr lang="en-US"/>
@@ -6408,9 +6429,11 @@
       <p:sp>
         <p:nvSpPr>
           <p:cNvPr id="2" name="Text 1"/>
-          <p:cNvSpPr/>
+          <p:cNvSpPr>
+            <a:spLocks noGrp="1"/>
+          </p:cNvSpPr>
           <p:nvPr>
-            <p:ph idx="101" type="title" hasCustomPrompt="1"/>
+            <p:ph type="title" idx="101" hasCustomPrompt="1"/>
           </p:nvPr>
         </p:nvSpPr>
         <p:spPr>
@@ -6428,7 +6451,7 @@
           <a:bodyPr wrap="square" lIns="0" tIns="0" rIns="0" bIns="0" rtlCol="0" anchor="ctr"/>
           <a:lstStyle/>
           <a:p>
-            <a:pPr indent="0" marL="0">
+            <a:pPr marL="0" indent="0">
               <a:buNone/>
             </a:pPr>
             <a:r>
@@ -6472,6 +6495,13 @@
             <a:prstDash val="solid"/>
           </a:ln>
         </p:spPr>
+        <p:txBody>
+          <a:bodyPr/>
+          <a:lstStyle/>
+          <a:p>
+            <a:endParaRPr lang="fr-FR"/>
+          </a:p>
+        </p:txBody>
       </p:sp>
       <p:sp>
         <p:nvSpPr>
@@ -6497,17 +6527,24 @@
             <a:prstDash val="solid"/>
           </a:ln>
         </p:spPr>
+        <p:txBody>
+          <a:bodyPr/>
+          <a:lstStyle/>
+          <a:p>
+            <a:endParaRPr lang="fr-FR"/>
+          </a:p>
+        </p:txBody>
       </p:sp>
       <p:pic>
         <p:nvPicPr>
-          <p:cNvPr id="5" name="Icône QG" descr="QG">    </p:cNvPr>
+          <p:cNvPr id="5" name="Icône QG" descr="QG"/>
           <p:cNvPicPr>
             <a:picLocks noChangeAspect="1"/>
           </p:cNvPicPr>
           <p:nvPr/>
         </p:nvPicPr>
         <p:blipFill>
-          <a:blip r:embed="rId1"/>
+          <a:blip r:embed="rId3"/>
           <a:stretch>
             <a:fillRect/>
           </a:stretch>
@@ -6543,7 +6580,7 @@
           <a:bodyPr wrap="square" lIns="0" tIns="0" rIns="0" bIns="0" rtlCol="0" anchor="ctr"/>
           <a:lstStyle/>
           <a:p>
-            <a:pPr indent="0" marL="0">
+            <a:pPr marL="0" indent="0">
               <a:buNone/>
             </a:pPr>
             <a:r>
@@ -6645,6 +6682,13 @@
             <a:prstDash val="solid"/>
           </a:ln>
         </p:spPr>
+        <p:txBody>
+          <a:bodyPr/>
+          <a:lstStyle/>
+          <a:p>
+            <a:endParaRPr lang="fr-FR"/>
+          </a:p>
+        </p:txBody>
       </p:sp>
       <p:sp>
         <p:nvSpPr>
@@ -6670,17 +6714,24 @@
             <a:prstDash val="solid"/>
           </a:ln>
         </p:spPr>
+        <p:txBody>
+          <a:bodyPr/>
+          <a:lstStyle/>
+          <a:p>
+            <a:endParaRPr lang="fr-FR"/>
+          </a:p>
+        </p:txBody>
       </p:sp>
       <p:pic>
         <p:nvPicPr>
-          <p:cNvPr id="10" name="Icône agents" descr="agents">    </p:cNvPr>
+          <p:cNvPr id="10" name="Icône agents" descr="agents"/>
           <p:cNvPicPr>
             <a:picLocks noChangeAspect="1"/>
           </p:cNvPicPr>
           <p:nvPr/>
         </p:nvPicPr>
         <p:blipFill>
-          <a:blip r:embed="rId2"/>
+          <a:blip r:embed="rId4"/>
           <a:stretch>
             <a:fillRect/>
           </a:stretch>
@@ -6716,7 +6767,7 @@
           <a:bodyPr wrap="square" lIns="0" tIns="0" rIns="0" bIns="0" rtlCol="0" anchor="ctr"/>
           <a:lstStyle/>
           <a:p>
-            <a:pPr indent="0" marL="0">
+            <a:pPr marL="0" indent="0">
               <a:buNone/>
             </a:pPr>
             <a:r>
@@ -6816,17 +6867,24 @@
             <a:prstDash val="solid"/>
           </a:ln>
         </p:spPr>
+        <p:txBody>
+          <a:bodyPr/>
+          <a:lstStyle/>
+          <a:p>
+            <a:endParaRPr lang="fr-FR"/>
+          </a:p>
+        </p:txBody>
       </p:sp>
       <p:pic>
         <p:nvPicPr>
-          <p:cNvPr id="14" name="Icône chat" descr="chat">    </p:cNvPr>
+          <p:cNvPr id="14" name="Icône chat" descr="chat"/>
           <p:cNvPicPr>
             <a:picLocks noChangeAspect="1"/>
           </p:cNvPicPr>
           <p:nvPr/>
         </p:nvPicPr>
         <p:blipFill>
-          <a:blip r:embed="rId3"/>
+          <a:blip r:embed="rId5"/>
           <a:stretch>
             <a:fillRect/>
           </a:stretch>
@@ -6862,7 +6920,7 @@
           <a:bodyPr wrap="square" lIns="0" tIns="0" rIns="0" bIns="0" rtlCol="0" anchor="t"/>
           <a:lstStyle/>
           <a:p>
-            <a:pPr algn="ctr" indent="0" marL="0">
+            <a:pPr marL="0" indent="0" algn="ctr">
               <a:buNone/>
             </a:pPr>
             <a:r>
@@ -6901,6 +6959,13 @@
             <a:tailEnd type="triangle"/>
           </a:ln>
         </p:spPr>
+        <p:txBody>
+          <a:bodyPr/>
+          <a:lstStyle/>
+          <a:p>
+            <a:endParaRPr lang="fr-FR"/>
+          </a:p>
+        </p:txBody>
       </p:sp>
       <p:sp>
         <p:nvSpPr>
@@ -6926,6 +6991,13 @@
             <a:tailEnd type="triangle"/>
           </a:ln>
         </p:spPr>
+        <p:txBody>
+          <a:bodyPr/>
+          <a:lstStyle/>
+          <a:p>
+            <a:endParaRPr lang="fr-FR"/>
+          </a:p>
+        </p:txBody>
       </p:sp>
       <p:sp>
         <p:nvSpPr>
@@ -6953,6 +7025,13 @@
             <a:prstDash val="solid"/>
           </a:ln>
         </p:spPr>
+        <p:txBody>
+          <a:bodyPr/>
+          <a:lstStyle/>
+          <a:p>
+            <a:endParaRPr lang="fr-FR"/>
+          </a:p>
+        </p:txBody>
       </p:sp>
       <p:sp>
         <p:nvSpPr>
@@ -6975,7 +7054,7 @@
           <a:bodyPr wrap="square" lIns="0" tIns="0" rIns="0" bIns="0" rtlCol="0" anchor="ctr"/>
           <a:lstStyle/>
           <a:p>
-            <a:pPr algn="ctr" indent="0" marL="0">
+            <a:pPr marL="0" indent="0" algn="ctr">
               <a:buNone/>
             </a:pPr>
             <a:r>
@@ -6986,9 +7065,6 @@
               </a:rPr>
               <a:t>1  </a:t>
             </a:r>
-            <a:pPr algn="ctr" indent="0" marL="0">
-              <a:buNone/>
-            </a:pPr>
             <a:r>
               <a:rPr lang="en-US" sz="1600" b="1" dirty="0">
                 <a:solidFill>
@@ -7027,6 +7103,13 @@
             <a:prstDash val="solid"/>
           </a:ln>
         </p:spPr>
+        <p:txBody>
+          <a:bodyPr/>
+          <a:lstStyle/>
+          <a:p>
+            <a:endParaRPr lang="fr-FR"/>
+          </a:p>
+        </p:txBody>
       </p:sp>
       <p:sp>
         <p:nvSpPr>
@@ -7049,7 +7132,7 @@
           <a:bodyPr wrap="square" lIns="0" tIns="0" rIns="0" bIns="0" rtlCol="0" anchor="ctr"/>
           <a:lstStyle/>
           <a:p>
-            <a:pPr algn="ctr" indent="0" marL="0">
+            <a:pPr marL="0" indent="0" algn="ctr">
               <a:buNone/>
             </a:pPr>
             <a:r>
@@ -7060,9 +7143,6 @@
               </a:rPr>
               <a:t>2  </a:t>
             </a:r>
-            <a:pPr algn="ctr" indent="0" marL="0">
-              <a:buNone/>
-            </a:pPr>
             <a:r>
               <a:rPr lang="en-US" sz="1600" b="1" dirty="0">
                 <a:solidFill>
@@ -7101,6 +7181,13 @@
             <a:prstDash val="solid"/>
           </a:ln>
         </p:spPr>
+        <p:txBody>
+          <a:bodyPr/>
+          <a:lstStyle/>
+          <a:p>
+            <a:endParaRPr lang="fr-FR"/>
+          </a:p>
+        </p:txBody>
       </p:sp>
       <p:sp>
         <p:nvSpPr>
@@ -7123,7 +7210,7 @@
           <a:bodyPr wrap="square" lIns="0" tIns="0" rIns="0" bIns="0" rtlCol="0" anchor="ctr"/>
           <a:lstStyle/>
           <a:p>
-            <a:pPr algn="ctr" indent="0" marL="0">
+            <a:pPr marL="0" indent="0" algn="ctr">
               <a:buNone/>
             </a:pPr>
             <a:r>
@@ -7134,9 +7221,6 @@
               </a:rPr>
               <a:t>3  </a:t>
             </a:r>
-            <a:pPr algn="ctr" indent="0" marL="0">
-              <a:buNone/>
-            </a:pPr>
             <a:r>
               <a:rPr lang="en-US" sz="1600" b="1" dirty="0">
                 <a:solidFill>
@@ -7175,6 +7259,13 @@
             <a:prstDash val="solid"/>
           </a:ln>
         </p:spPr>
+        <p:txBody>
+          <a:bodyPr/>
+          <a:lstStyle/>
+          <a:p>
+            <a:endParaRPr lang="fr-FR"/>
+          </a:p>
+        </p:txBody>
       </p:sp>
       <p:sp>
         <p:nvSpPr>
@@ -7197,7 +7288,7 @@
           <a:bodyPr wrap="square" lIns="0" tIns="0" rIns="0" bIns="0" rtlCol="0" anchor="ctr"/>
           <a:lstStyle/>
           <a:p>
-            <a:pPr algn="ctr" indent="0" marL="0">
+            <a:pPr marL="0" indent="0" algn="ctr">
               <a:buNone/>
             </a:pPr>
             <a:r>
@@ -7206,18 +7297,7 @@
                   <a:schemeClr val="bg1"/>
                 </a:solidFill>
               </a:rPr>
-              <a:t>4  </a:t>
-            </a:r>
-            <a:pPr algn="ctr" indent="0" marL="0">
-              <a:buNone/>
-            </a:pPr>
-            <a:r>
-              <a:rPr lang="en-US" sz="1600" b="1" dirty="0">
-                <a:solidFill>
-                  <a:schemeClr val="bg1"/>
-                </a:solidFill>
-              </a:rPr>
-              <a:t>Agir</a:t>
+              <a:t>4  Agir</a:t>
             </a:r>
             <a:endParaRPr lang="en-US" sz="1600" dirty="0"/>
           </a:p>
@@ -7225,7 +7305,7 @@
       </p:sp>
       <p:sp>
         <p:nvSpPr>
-          <p:cNvPr id="25" name="Slide Number Placeholder 0"/>
+          <p:cNvPr id="26" name="Slide Number Placeholder 0"/>
           <p:cNvSpPr>
             <a:spLocks noGrp="1"/>
           </p:cNvSpPr>
@@ -7243,7 +7323,7 @@
           </a:prstGeom>
           <a:extLst>
             <a:ext uri="{C572A759-6A51-4108-AA02-DFA0A04FC94B}">
-              <ma14:wrappingTextBoxFlag xmlns:ma14="http://schemas.microsoft.com/office/mac/drawingml/2011/main" val="0"/>
+              <ma14:wrappingTextBoxFlag xmlns:ma14="http://schemas.microsoft.com/office/mac/drawingml/2011/main" xmlns="" val="0"/>
             </a:ext>
           </a:extLst>
         </p:spPr>
@@ -7261,7 +7341,7 @@
           <a:p>
             <a:pPr algn="r"/>
             <a:fld id="{F7021451-1387-4CA6-816F-3879F97B5CBC}" type="slidenum">
-              <a:rPr b="0" lang="en-US"/>
+              <a:rPr lang="en-US" b="0"/>
               <a:t>4</a:t>
             </a:fld>
             <a:endParaRPr lang="en-US"/>
@@ -7296,9 +7376,11 @@
       <p:sp>
         <p:nvSpPr>
           <p:cNvPr id="2" name="Text 1"/>
-          <p:cNvSpPr/>
+          <p:cNvSpPr>
+            <a:spLocks noGrp="1"/>
+          </p:cNvSpPr>
           <p:nvPr>
-            <p:ph idx="101" type="title" hasCustomPrompt="1"/>
+            <p:ph type="title" idx="101" hasCustomPrompt="1"/>
           </p:nvPr>
         </p:nvSpPr>
         <p:spPr>
@@ -7316,7 +7398,7 @@
           <a:bodyPr wrap="square" lIns="0" tIns="0" rIns="0" bIns="0" rtlCol="0" anchor="ctr"/>
           <a:lstStyle/>
           <a:p>
-            <a:pPr indent="0" marL="0">
+            <a:pPr marL="0" indent="0">
               <a:buNone/>
             </a:pPr>
             <a:r>
@@ -7360,6 +7442,13 @@
             <a:prstDash val="solid"/>
           </a:ln>
         </p:spPr>
+        <p:txBody>
+          <a:bodyPr/>
+          <a:lstStyle/>
+          <a:p>
+            <a:endParaRPr lang="fr-FR"/>
+          </a:p>
+        </p:txBody>
       </p:sp>
       <p:sp>
         <p:nvSpPr>
@@ -7385,17 +7474,24 @@
             <a:prstDash val="solid"/>
           </a:ln>
         </p:spPr>
+        <p:txBody>
+          <a:bodyPr/>
+          <a:lstStyle/>
+          <a:p>
+            <a:endParaRPr lang="fr-FR"/>
+          </a:p>
+        </p:txBody>
       </p:sp>
       <p:pic>
         <p:nvPicPr>
-          <p:cNvPr id="5" name="Icône Chauffage" descr="Chauffage">    </p:cNvPr>
+          <p:cNvPr id="5" name="Icône Chauffage" descr="Chauffage"/>
           <p:cNvPicPr>
             <a:picLocks noChangeAspect="1"/>
           </p:cNvPicPr>
           <p:nvPr/>
         </p:nvPicPr>
         <p:blipFill>
-          <a:blip r:embed="rId1"/>
+          <a:blip r:embed="rId3"/>
           <a:stretch>
             <a:fillRect/>
           </a:stretch>
@@ -7431,7 +7527,7 @@
           <a:bodyPr wrap="square" lIns="0" tIns="0" rIns="0" bIns="0" rtlCol="0" anchor="ctr"/>
           <a:lstStyle/>
           <a:p>
-            <a:pPr indent="0" marL="0">
+            <a:pPr marL="0" indent="0">
               <a:buNone/>
             </a:pPr>
             <a:r>
@@ -7467,7 +7563,7 @@
           <a:bodyPr wrap="square" lIns="0" tIns="0" rIns="0" bIns="0" rtlCol="0" anchor="ctr"/>
           <a:lstStyle/>
           <a:p>
-            <a:pPr indent="0" marL="0">
+            <a:pPr marL="0" indent="0">
               <a:buNone/>
             </a:pPr>
             <a:r>
@@ -7503,7 +7599,7 @@
           <a:bodyPr wrap="square" lIns="0" tIns="0" rIns="0" bIns="0" rtlCol="0" anchor="ctr"/>
           <a:lstStyle/>
           <a:p>
-            <a:pPr indent="0" marL="0">
+            <a:pPr marL="0" indent="0">
               <a:buNone/>
             </a:pPr>
             <a:r>
@@ -7544,6 +7640,13 @@
             <a:prstDash val="solid"/>
           </a:ln>
         </p:spPr>
+        <p:txBody>
+          <a:bodyPr/>
+          <a:lstStyle/>
+          <a:p>
+            <a:endParaRPr lang="fr-FR"/>
+          </a:p>
+        </p:txBody>
       </p:sp>
       <p:sp>
         <p:nvSpPr>
@@ -7569,17 +7672,24 @@
             <a:prstDash val="solid"/>
           </a:ln>
         </p:spPr>
+        <p:txBody>
+          <a:bodyPr/>
+          <a:lstStyle/>
+          <a:p>
+            <a:endParaRPr lang="fr-FR"/>
+          </a:p>
+        </p:txBody>
       </p:sp>
       <p:pic>
         <p:nvPicPr>
-          <p:cNvPr id="11" name="Icône Éclairage" descr="Éclairage">    </p:cNvPr>
+          <p:cNvPr id="11" name="Icône Éclairage" descr="Éclairage"/>
           <p:cNvPicPr>
             <a:picLocks noChangeAspect="1"/>
           </p:cNvPicPr>
           <p:nvPr/>
         </p:nvPicPr>
         <p:blipFill>
-          <a:blip r:embed="rId2"/>
+          <a:blip r:embed="rId4"/>
           <a:stretch>
             <a:fillRect/>
           </a:stretch>
@@ -7615,7 +7725,7 @@
           <a:bodyPr wrap="square" lIns="0" tIns="0" rIns="0" bIns="0" rtlCol="0" anchor="ctr"/>
           <a:lstStyle/>
           <a:p>
-            <a:pPr indent="0" marL="0">
+            <a:pPr marL="0" indent="0">
               <a:buNone/>
             </a:pPr>
             <a:r>
@@ -7651,7 +7761,7 @@
           <a:bodyPr wrap="square" lIns="0" tIns="0" rIns="0" bIns="0" rtlCol="0" anchor="ctr"/>
           <a:lstStyle/>
           <a:p>
-            <a:pPr indent="0" marL="0">
+            <a:pPr marL="0" indent="0">
               <a:buNone/>
             </a:pPr>
             <a:r>
@@ -7687,7 +7797,7 @@
           <a:bodyPr wrap="square" lIns="0" tIns="0" rIns="0" bIns="0" rtlCol="0" anchor="ctr"/>
           <a:lstStyle/>
           <a:p>
-            <a:pPr indent="0" marL="0">
+            <a:pPr marL="0" indent="0">
               <a:buNone/>
             </a:pPr>
             <a:r>
@@ -7728,6 +7838,13 @@
             <a:prstDash val="solid"/>
           </a:ln>
         </p:spPr>
+        <p:txBody>
+          <a:bodyPr/>
+          <a:lstStyle/>
+          <a:p>
+            <a:endParaRPr lang="fr-FR"/>
+          </a:p>
+        </p:txBody>
       </p:sp>
       <p:sp>
         <p:nvSpPr>
@@ -7753,17 +7870,24 @@
             <a:prstDash val="solid"/>
           </a:ln>
         </p:spPr>
+        <p:txBody>
+          <a:bodyPr/>
+          <a:lstStyle/>
+          <a:p>
+            <a:endParaRPr lang="fr-FR"/>
+          </a:p>
+        </p:txBody>
       </p:sp>
       <p:pic>
         <p:nvPicPr>
-          <p:cNvPr id="17" name="Icône Présence" descr="Présence">    </p:cNvPr>
+          <p:cNvPr id="17" name="Icône Présence" descr="Présence"/>
           <p:cNvPicPr>
             <a:picLocks noChangeAspect="1"/>
           </p:cNvPicPr>
           <p:nvPr/>
         </p:nvPicPr>
         <p:blipFill>
-          <a:blip r:embed="rId3"/>
+          <a:blip r:embed="rId5"/>
           <a:stretch>
             <a:fillRect/>
           </a:stretch>
@@ -7799,7 +7923,7 @@
           <a:bodyPr wrap="square" lIns="0" tIns="0" rIns="0" bIns="0" rtlCol="0" anchor="ctr"/>
           <a:lstStyle/>
           <a:p>
-            <a:pPr indent="0" marL="0">
+            <a:pPr marL="0" indent="0">
               <a:buNone/>
             </a:pPr>
             <a:r>
@@ -7835,7 +7959,7 @@
           <a:bodyPr wrap="square" lIns="0" tIns="0" rIns="0" bIns="0" rtlCol="0" anchor="ctr"/>
           <a:lstStyle/>
           <a:p>
-            <a:pPr indent="0" marL="0">
+            <a:pPr marL="0" indent="0">
               <a:buNone/>
             </a:pPr>
             <a:r>
@@ -7871,7 +7995,7 @@
           <a:bodyPr wrap="square" lIns="0" tIns="0" rIns="0" bIns="0" rtlCol="0" anchor="ctr"/>
           <a:lstStyle/>
           <a:p>
-            <a:pPr indent="0" marL="0">
+            <a:pPr marL="0" indent="0">
               <a:buNone/>
             </a:pPr>
             <a:r>
@@ -7912,6 +8036,13 @@
             <a:prstDash val="solid"/>
           </a:ln>
         </p:spPr>
+        <p:txBody>
+          <a:bodyPr/>
+          <a:lstStyle/>
+          <a:p>
+            <a:endParaRPr lang="fr-FR"/>
+          </a:p>
+        </p:txBody>
       </p:sp>
       <p:sp>
         <p:nvSpPr>
@@ -7937,17 +8068,24 @@
             <a:prstDash val="solid"/>
           </a:ln>
         </p:spPr>
+        <p:txBody>
+          <a:bodyPr/>
+          <a:lstStyle/>
+          <a:p>
+            <a:endParaRPr lang="fr-FR"/>
+          </a:p>
+        </p:txBody>
       </p:sp>
       <p:pic>
         <p:nvPicPr>
-          <p:cNvPr id="23" name="Icône Code de l'armoire" descr="Code de l'armoire">    </p:cNvPr>
+          <p:cNvPr id="23" name="Icône Code de l'armoire" descr="Code de l'armoire"/>
           <p:cNvPicPr>
             <a:picLocks noChangeAspect="1"/>
           </p:cNvPicPr>
           <p:nvPr/>
         </p:nvPicPr>
         <p:blipFill>
-          <a:blip r:embed="rId4"/>
+          <a:blip r:embed="rId6"/>
           <a:stretch>
             <a:fillRect/>
           </a:stretch>
@@ -7983,7 +8121,7 @@
           <a:bodyPr wrap="square" lIns="0" tIns="0" rIns="0" bIns="0" rtlCol="0" anchor="ctr"/>
           <a:lstStyle/>
           <a:p>
-            <a:pPr indent="0" marL="0">
+            <a:pPr marL="0" indent="0">
               <a:buNone/>
             </a:pPr>
             <a:r>
@@ -8019,7 +8157,7 @@
           <a:bodyPr wrap="square" lIns="0" tIns="0" rIns="0" bIns="0" rtlCol="0" anchor="ctr"/>
           <a:lstStyle/>
           <a:p>
-            <a:pPr indent="0" marL="0">
+            <a:pPr marL="0" indent="0">
               <a:buNone/>
             </a:pPr>
             <a:r>
@@ -8055,7 +8193,7 @@
           <a:bodyPr wrap="square" lIns="0" tIns="0" rIns="0" bIns="0" rtlCol="0" anchor="ctr"/>
           <a:lstStyle/>
           <a:p>
-            <a:pPr indent="0" marL="0">
+            <a:pPr marL="0" indent="0">
               <a:buNone/>
             </a:pPr>
             <a:r>
@@ -8096,6 +8234,13 @@
             <a:prstDash val="solid"/>
           </a:ln>
         </p:spPr>
+        <p:txBody>
+          <a:bodyPr/>
+          <a:lstStyle/>
+          <a:p>
+            <a:endParaRPr lang="fr-FR"/>
+          </a:p>
+        </p:txBody>
       </p:sp>
       <p:sp>
         <p:nvSpPr>
@@ -8121,17 +8266,24 @@
             <a:prstDash val="solid"/>
           </a:ln>
         </p:spPr>
+        <p:txBody>
+          <a:bodyPr/>
+          <a:lstStyle/>
+          <a:p>
+            <a:endParaRPr lang="fr-FR"/>
+          </a:p>
+        </p:txBody>
       </p:sp>
       <p:pic>
         <p:nvPicPr>
-          <p:cNvPr id="29" name="Icône Compteur" descr="Compteur">    </p:cNvPr>
+          <p:cNvPr id="29" name="Icône Compteur" descr="Compteur"/>
           <p:cNvPicPr>
             <a:picLocks noChangeAspect="1"/>
           </p:cNvPicPr>
           <p:nvPr/>
         </p:nvPicPr>
         <p:blipFill>
-          <a:blip r:embed="rId5"/>
+          <a:blip r:embed="rId7"/>
           <a:stretch>
             <a:fillRect/>
           </a:stretch>
@@ -8167,7 +8319,7 @@
           <a:bodyPr wrap="square" lIns="0" tIns="0" rIns="0" bIns="0" rtlCol="0" anchor="ctr"/>
           <a:lstStyle/>
           <a:p>
-            <a:pPr indent="0" marL="0">
+            <a:pPr marL="0" indent="0">
               <a:buNone/>
             </a:pPr>
             <a:r>
@@ -8203,7 +8355,7 @@
           <a:bodyPr wrap="square" lIns="0" tIns="0" rIns="0" bIns="0" rtlCol="0" anchor="ctr"/>
           <a:lstStyle/>
           <a:p>
-            <a:pPr indent="0" marL="0">
+            <a:pPr marL="0" indent="0">
               <a:buNone/>
             </a:pPr>
             <a:r>
@@ -8239,7 +8391,7 @@
           <a:bodyPr wrap="square" lIns="0" tIns="0" rIns="0" bIns="0" rtlCol="0" anchor="ctr"/>
           <a:lstStyle/>
           <a:p>
-            <a:pPr indent="0" marL="0">
+            <a:pPr marL="0" indent="0">
               <a:buNone/>
             </a:pPr>
             <a:r>
@@ -8256,7 +8408,7 @@
       </p:sp>
       <p:sp>
         <p:nvSpPr>
-          <p:cNvPr id="25" name="Slide Number Placeholder 0"/>
+          <p:cNvPr id="33" name="Slide Number Placeholder 0"/>
           <p:cNvSpPr>
             <a:spLocks noGrp="1"/>
           </p:cNvSpPr>
@@ -8274,7 +8426,7 @@
           </a:prstGeom>
           <a:extLst>
             <a:ext uri="{C572A759-6A51-4108-AA02-DFA0A04FC94B}">
-              <ma14:wrappingTextBoxFlag xmlns:ma14="http://schemas.microsoft.com/office/mac/drawingml/2011/main" val="0"/>
+              <ma14:wrappingTextBoxFlag xmlns:ma14="http://schemas.microsoft.com/office/mac/drawingml/2011/main" xmlns="" val="0"/>
             </a:ext>
           </a:extLst>
         </p:spPr>
@@ -8292,7 +8444,7 @@
           <a:p>
             <a:pPr algn="r"/>
             <a:fld id="{F7021451-1387-4CA6-816F-3879F97B5CBC}" type="slidenum">
-              <a:rPr b="0" lang="en-US"/>
+              <a:rPr lang="en-US" b="0"/>
               <a:t>5</a:t>
             </a:fld>
             <a:endParaRPr lang="en-US"/>
@@ -8327,9 +8479,11 @@
       <p:sp>
         <p:nvSpPr>
           <p:cNvPr id="2" name="Text 1"/>
-          <p:cNvSpPr/>
+          <p:cNvSpPr>
+            <a:spLocks noGrp="1"/>
+          </p:cNvSpPr>
           <p:nvPr>
-            <p:ph idx="101" type="title" hasCustomPrompt="1"/>
+            <p:ph type="title" idx="101" hasCustomPrompt="1"/>
           </p:nvPr>
         </p:nvSpPr>
         <p:spPr>
@@ -8347,7 +8501,7 @@
           <a:bodyPr wrap="square" lIns="0" tIns="0" rIns="0" bIns="0" rtlCol="0" anchor="ctr"/>
           <a:lstStyle/>
           <a:p>
-            <a:pPr indent="0" marL="0">
+            <a:pPr marL="0" indent="0">
               <a:buNone/>
             </a:pPr>
             <a:r>
@@ -8386,7 +8540,7 @@
           <a:bodyPr wrap="square" lIns="0" tIns="0" rIns="0" bIns="0" rtlCol="0" anchor="ctr"/>
           <a:lstStyle/>
           <a:p>
-            <a:pPr indent="0" marL="0">
+            <a:pPr marL="0" indent="0">
               <a:buNone/>
             </a:pPr>
             <a:r>
@@ -8422,7 +8576,7 @@
           <a:bodyPr wrap="square" lIns="0" tIns="0" rIns="0" bIns="0" rtlCol="0" anchor="ctr"/>
           <a:lstStyle/>
           <a:p>
-            <a:pPr indent="0" marL="0">
+            <a:pPr marL="0" indent="0">
               <a:buNone/>
             </a:pPr>
             <a:r>
@@ -8461,7 +8615,7 @@
           <a:bodyPr wrap="square" lIns="0" tIns="0" rIns="0" bIns="0" rtlCol="0" anchor="ctr"/>
           <a:lstStyle/>
           <a:p>
-            <a:pPr indent="0" marL="0">
+            <a:pPr marL="0" indent="0">
               <a:buNone/>
             </a:pPr>
             <a:r>
@@ -8475,7 +8629,7 @@
             <a:endParaRPr lang="en-US" sz="1400" dirty="0"/>
           </a:p>
           <a:p>
-            <a:pPr indent="0" marL="0">
+            <a:pPr marL="0" indent="0">
               <a:buNone/>
             </a:pPr>
             <a:r>
@@ -8511,7 +8665,7 @@
           <a:bodyPr wrap="square" lIns="0" tIns="0" rIns="0" bIns="0" rtlCol="0" anchor="ctr"/>
           <a:lstStyle/>
           <a:p>
-            <a:pPr indent="0" marL="0">
+            <a:pPr marL="0" indent="0">
               <a:buNone/>
             </a:pPr>
             <a:r>
@@ -8550,7 +8704,7 @@
           <a:bodyPr wrap="square" lIns="0" tIns="0" rIns="0" bIns="0" rtlCol="0" anchor="ctr"/>
           <a:lstStyle/>
           <a:p>
-            <a:pPr indent="0" marL="0">
+            <a:pPr marL="0" indent="0">
               <a:buNone/>
             </a:pPr>
             <a:r>
@@ -8564,7 +8718,7 @@
             <a:endParaRPr lang="en-US" sz="1400" dirty="0"/>
           </a:p>
           <a:p>
-            <a:pPr indent="0" marL="0">
+            <a:pPr marL="0" indent="0">
               <a:buNone/>
             </a:pPr>
             <a:r>
@@ -8600,7 +8754,7 @@
           <a:bodyPr wrap="square" lIns="0" tIns="0" rIns="0" bIns="0" rtlCol="0" anchor="ctr"/>
           <a:lstStyle/>
           <a:p>
-            <a:pPr indent="0" marL="0">
+            <a:pPr marL="0" indent="0">
               <a:buNone/>
             </a:pPr>
             <a:r>
@@ -8639,7 +8793,7 @@
           <a:bodyPr wrap="square" lIns="0" tIns="0" rIns="0" bIns="0" rtlCol="0" anchor="ctr"/>
           <a:lstStyle/>
           <a:p>
-            <a:pPr indent="0" marL="0">
+            <a:pPr marL="0" indent="0">
               <a:buNone/>
             </a:pPr>
             <a:r>
@@ -8653,7 +8807,7 @@
             <a:endParaRPr lang="en-US" sz="1400" dirty="0"/>
           </a:p>
           <a:p>
-            <a:pPr indent="0" marL="0">
+            <a:pPr marL="0" indent="0">
               <a:buNone/>
             </a:pPr>
             <a:r>
@@ -8694,6 +8848,13 @@
             <a:prstDash val="solid"/>
           </a:ln>
         </p:spPr>
+        <p:txBody>
+          <a:bodyPr/>
+          <a:lstStyle/>
+          <a:p>
+            <a:endParaRPr lang="fr-FR"/>
+          </a:p>
+        </p:txBody>
       </p:sp>
       <p:sp>
         <p:nvSpPr>
@@ -8719,17 +8880,24 @@
             <a:prstDash val="solid"/>
           </a:ln>
         </p:spPr>
+        <p:txBody>
+          <a:bodyPr/>
+          <a:lstStyle/>
+          <a:p>
+            <a:endParaRPr lang="fr-FR"/>
+          </a:p>
+        </p:txBody>
       </p:sp>
       <p:pic>
         <p:nvPicPr>
-          <p:cNvPr id="12" name="Icône apprentissages" descr="apprentissages">    </p:cNvPr>
+          <p:cNvPr id="12" name="Icône apprentissages" descr="apprentissages"/>
           <p:cNvPicPr>
             <a:picLocks noChangeAspect="1"/>
           </p:cNvPicPr>
           <p:nvPr/>
         </p:nvPicPr>
         <p:blipFill>
-          <a:blip r:embed="rId1"/>
+          <a:blip r:embed="rId3"/>
           <a:stretch>
             <a:fillRect/>
           </a:stretch>
@@ -8765,7 +8933,7 @@
           <a:bodyPr wrap="square" lIns="0" tIns="0" rIns="0" bIns="0" rtlCol="0" anchor="ctr"/>
           <a:lstStyle/>
           <a:p>
-            <a:pPr indent="0" marL="0">
+            <a:pPr marL="0" indent="0">
               <a:buNone/>
             </a:pPr>
             <a:r>
@@ -8858,7 +9026,7 @@
             <a:endParaRPr lang="en-US" sz="1400" dirty="0"/>
           </a:p>
           <a:p>
-            <a:pPr indent="0" marL="0">
+            <a:pPr marL="0" indent="0">
               <a:spcAft>
                 <a:spcPts val="500"/>
               </a:spcAft>
@@ -8875,7 +9043,7 @@
             <a:endParaRPr lang="en-US" sz="1400" dirty="0"/>
           </a:p>
           <a:p>
-            <a:pPr indent="0" marL="0">
+            <a:pPr marL="0" indent="0">
               <a:buNone/>
             </a:pPr>
             <a:r>
@@ -8910,7 +9078,7 @@
           </a:prstGeom>
           <a:extLst>
             <a:ext uri="{C572A759-6A51-4108-AA02-DFA0A04FC94B}">
-              <ma14:wrappingTextBoxFlag xmlns:ma14="http://schemas.microsoft.com/office/mac/drawingml/2011/main" val="0"/>
+              <ma14:wrappingTextBoxFlag xmlns:ma14="http://schemas.microsoft.com/office/mac/drawingml/2011/main" xmlns="" val="0"/>
             </a:ext>
           </a:extLst>
         </p:spPr>
@@ -8928,7 +9096,7 @@
           <a:p>
             <a:pPr algn="r"/>
             <a:fld id="{F7021451-1387-4CA6-816F-3879F97B5CBC}" type="slidenum">
-              <a:rPr b="0" lang="en-US"/>
+              <a:rPr lang="en-US" b="0"/>
               <a:t>6</a:t>
             </a:fld>
             <a:endParaRPr lang="en-US"/>
@@ -8963,9 +9131,11 @@
       <p:sp>
         <p:nvSpPr>
           <p:cNvPr id="2" name="Text 1"/>
-          <p:cNvSpPr/>
+          <p:cNvSpPr>
+            <a:spLocks noGrp="1"/>
+          </p:cNvSpPr>
           <p:nvPr>
-            <p:ph idx="101" type="title" hasCustomPrompt="1"/>
+            <p:ph type="title" idx="101" hasCustomPrompt="1"/>
           </p:nvPr>
         </p:nvSpPr>
         <p:spPr>
@@ -8983,7 +9153,7 @@
           <a:bodyPr wrap="square" lIns="0" tIns="0" rIns="0" bIns="0" rtlCol="0" anchor="ctr"/>
           <a:lstStyle/>
           <a:p>
-            <a:pPr indent="0" marL="0">
+            <a:pPr marL="0" indent="0">
               <a:buNone/>
             </a:pPr>
             <a:r>
@@ -9027,24 +9197,31 @@
             <a:prstDash val="solid"/>
           </a:ln>
           <a:effectLst>
-            <a:outerShdw sx="100000" sy="100000" kx="0" ky="0" algn="bl" rotWithShape="0" blurRad="101600" dist="38100" dir="5400000">
+            <a:outerShdw blurRad="101600" dist="38100" dir="5400000" algn="bl" rotWithShape="0">
               <a:srgbClr val="000000">
                 <a:alpha val="30000"/>
               </a:srgbClr>
             </a:outerShdw>
           </a:effectLst>
         </p:spPr>
+        <p:txBody>
+          <a:bodyPr/>
+          <a:lstStyle/>
+          <a:p>
+            <a:endParaRPr lang="fr-FR"/>
+          </a:p>
+        </p:txBody>
       </p:sp>
       <p:pic>
         <p:nvPicPr>
-          <p:cNvPr id="4" name="Accueil : QR code et briefing défilant" descr="Accueil : QR code et briefing défilant">    </p:cNvPr>
+          <p:cNvPr id="4" name="Accueil : QR code et briefing défilant" descr="Accueil : QR code et briefing défilant"/>
           <p:cNvPicPr>
             <a:picLocks noChangeAspect="1"/>
           </p:cNvPicPr>
           <p:nvPr/>
         </p:nvPicPr>
         <p:blipFill>
-          <a:blip r:embed="rId1"/>
+          <a:blip r:embed="rId3"/>
           <a:stretch>
             <a:fillRect/>
           </a:stretch>
@@ -9080,7 +9257,7 @@
           <a:bodyPr wrap="square" lIns="0" tIns="0" rIns="0" bIns="0" rtlCol="0" anchor="ctr"/>
           <a:lstStyle/>
           <a:p>
-            <a:pPr algn="ctr" indent="0" marL="0">
+            <a:pPr marL="0" indent="0" algn="ctr">
               <a:buNone/>
             </a:pPr>
             <a:r>
@@ -9121,24 +9298,31 @@
             <a:prstDash val="solid"/>
           </a:ln>
           <a:effectLst>
-            <a:outerShdw sx="100000" sy="100000" kx="0" ky="0" algn="bl" rotWithShape="0" blurRad="101600" dist="38100" dir="5400000">
+            <a:outerShdw blurRad="101600" dist="38100" dir="5400000" algn="bl" rotWithShape="0">
               <a:srgbClr val="000000">
                 <a:alpha val="30000"/>
               </a:srgbClr>
             </a:outerShdw>
           </a:effectLst>
         </p:spPr>
+        <p:txBody>
+          <a:bodyPr/>
+          <a:lstStyle/>
+          <a:p>
+            <a:endParaRPr lang="fr-FR"/>
+          </a:p>
+        </p:txBody>
       </p:sp>
       <p:pic>
         <p:nvPicPr>
-          <p:cNvPr id="7" name="Une salle en cours, avec le chat" descr="Une salle en cours, avec le chat">    </p:cNvPr>
+          <p:cNvPr id="7" name="Une salle en cours, avec le chat" descr="Une salle en cours, avec le chat"/>
           <p:cNvPicPr>
             <a:picLocks noChangeAspect="1"/>
           </p:cNvPicPr>
           <p:nvPr/>
         </p:nvPicPr>
         <p:blipFill>
-          <a:blip r:embed="rId2"/>
+          <a:blip r:embed="rId4"/>
           <a:stretch>
             <a:fillRect/>
           </a:stretch>
@@ -9174,7 +9358,7 @@
           <a:bodyPr wrap="square" lIns="0" tIns="0" rIns="0" bIns="0" rtlCol="0" anchor="ctr"/>
           <a:lstStyle/>
           <a:p>
-            <a:pPr algn="ctr" indent="0" marL="0">
+            <a:pPr marL="0" indent="0" algn="ctr">
               <a:buNone/>
             </a:pPr>
             <a:r>
@@ -9215,24 +9399,31 @@
             <a:prstDash val="solid"/>
           </a:ln>
           <a:effectLst>
-            <a:outerShdw sx="100000" sy="100000" kx="0" ky="0" algn="bl" rotWithShape="0" blurRad="101600" dist="38100" dir="5400000">
+            <a:outerShdw blurRad="101600" dist="38100" dir="5400000" algn="bl" rotWithShape="0">
               <a:srgbClr val="000000">
                 <a:alpha val="30000"/>
               </a:srgbClr>
             </a:outerShdw>
           </a:effectLst>
         </p:spPr>
+        <p:txBody>
+          <a:bodyPr/>
+          <a:lstStyle/>
+          <a:p>
+            <a:endParaRPr lang="fr-FR"/>
+          </a:p>
+        </p:txBody>
       </p:sp>
       <p:pic>
         <p:nvPicPr>
-          <p:cNvPr id="10" name="Clavier AZERTY du code" descr="Clavier AZERTY du code">    </p:cNvPr>
+          <p:cNvPr id="10" name="Clavier AZERTY du code" descr="Clavier AZERTY du code"/>
           <p:cNvPicPr>
             <a:picLocks noChangeAspect="1"/>
           </p:cNvPicPr>
           <p:nvPr/>
         </p:nvPicPr>
         <p:blipFill>
-          <a:blip r:embed="rId3"/>
+          <a:blip r:embed="rId5"/>
           <a:stretch>
             <a:fillRect/>
           </a:stretch>
@@ -9268,7 +9459,7 @@
           <a:bodyPr wrap="square" lIns="0" tIns="0" rIns="0" bIns="0" rtlCol="0" anchor="ctr"/>
           <a:lstStyle/>
           <a:p>
-            <a:pPr algn="ctr" indent="0" marL="0">
+            <a:pPr marL="0" indent="0" algn="ctr">
               <a:buNone/>
             </a:pPr>
             <a:r>
@@ -9307,17 +9498,24 @@
             <a:prstDash val="solid"/>
           </a:ln>
         </p:spPr>
+        <p:txBody>
+          <a:bodyPr/>
+          <a:lstStyle/>
+          <a:p>
+            <a:endParaRPr lang="fr-FR"/>
+          </a:p>
+        </p:txBody>
       </p:sp>
       <p:pic>
         <p:nvPicPr>
-          <p:cNvPr id="13" name="Icône Boutons de 52 px et plus, sans zoom" descr="Boutons de 52 px et plus, sans zoom">    </p:cNvPr>
+          <p:cNvPr id="13" name="Icône Boutons de 52 px et plus, sans zoom" descr="Boutons de 52 px et plus, sans zoom"/>
           <p:cNvPicPr>
             <a:picLocks noChangeAspect="1"/>
           </p:cNvPicPr>
           <p:nvPr/>
         </p:nvPicPr>
         <p:blipFill>
-          <a:blip r:embed="rId4"/>
+          <a:blip r:embed="rId6"/>
           <a:stretch>
             <a:fillRect/>
           </a:stretch>
@@ -9353,7 +9551,7 @@
           <a:bodyPr wrap="square" lIns="0" tIns="0" rIns="0" bIns="0" rtlCol="0" anchor="ctr"/>
           <a:lstStyle/>
           <a:p>
-            <a:pPr indent="0" marL="0">
+            <a:pPr marL="0" indent="0">
               <a:buNone/>
             </a:pPr>
             <a:r>
@@ -9392,17 +9590,24 @@
             <a:prstDash val="solid"/>
           </a:ln>
         </p:spPr>
+        <p:txBody>
+          <a:bodyPr/>
+          <a:lstStyle/>
+          <a:p>
+            <a:endParaRPr lang="fr-FR"/>
+          </a:p>
+        </p:txBody>
       </p:sp>
       <p:pic>
         <p:nvPicPr>
-          <p:cNvPr id="16" name="Icône Retours visuels et sonores" descr="Retours visuels et sonores">    </p:cNvPr>
+          <p:cNvPr id="16" name="Icône Retours visuels et sonores" descr="Retours visuels et sonores"/>
           <p:cNvPicPr>
             <a:picLocks noChangeAspect="1"/>
           </p:cNvPicPr>
           <p:nvPr/>
         </p:nvPicPr>
         <p:blipFill>
-          <a:blip r:embed="rId5"/>
+          <a:blip r:embed="rId7"/>
           <a:stretch>
             <a:fillRect/>
           </a:stretch>
@@ -9438,7 +9643,7 @@
           <a:bodyPr wrap="square" lIns="0" tIns="0" rIns="0" bIns="0" rtlCol="0" anchor="ctr"/>
           <a:lstStyle/>
           <a:p>
-            <a:pPr indent="0" marL="0">
+            <a:pPr marL="0" indent="0">
               <a:buNone/>
             </a:pPr>
             <a:r>
@@ -9477,17 +9682,24 @@
             <a:prstDash val="solid"/>
           </a:ln>
         </p:spPr>
+        <p:txBody>
+          <a:bodyPr/>
+          <a:lstStyle/>
+          <a:p>
+            <a:endParaRPr lang="fr-FR"/>
+          </a:p>
+        </p:txBody>
       </p:sp>
       <p:pic>
         <p:nvPicPr>
-          <p:cNvPr id="19" name="Icône Aide au calcul, sans la réponse" descr="Aide au calcul, sans la réponse">    </p:cNvPr>
+          <p:cNvPr id="19" name="Icône Aide au calcul, sans la réponse" descr="Aide au calcul, sans la réponse"/>
           <p:cNvPicPr>
             <a:picLocks noChangeAspect="1"/>
           </p:cNvPicPr>
           <p:nvPr/>
         </p:nvPicPr>
         <p:blipFill>
-          <a:blip r:embed="rId6"/>
+          <a:blip r:embed="rId8"/>
           <a:stretch>
             <a:fillRect/>
           </a:stretch>
@@ -9523,7 +9735,7 @@
           <a:bodyPr wrap="square" lIns="0" tIns="0" rIns="0" bIns="0" rtlCol="0" anchor="ctr"/>
           <a:lstStyle/>
           <a:p>
-            <a:pPr indent="0" marL="0">
+            <a:pPr marL="0" indent="0">
               <a:buNone/>
             </a:pPr>
             <a:r>
@@ -9562,17 +9774,24 @@
             <a:prstDash val="solid"/>
           </a:ln>
         </p:spPr>
+        <p:txBody>
+          <a:bodyPr/>
+          <a:lstStyle/>
+          <a:p>
+            <a:endParaRPr lang="fr-FR"/>
+          </a:p>
+        </p:txBody>
       </p:sp>
       <p:pic>
         <p:nvPicPr>
-          <p:cNvPr id="22" name="Icône Couleurs de la charte CCI" descr="Couleurs de la charte CCI">    </p:cNvPr>
+          <p:cNvPr id="22" name="Icône Couleurs de la charte CCI" descr="Couleurs de la charte CCI"/>
           <p:cNvPicPr>
             <a:picLocks noChangeAspect="1"/>
           </p:cNvPicPr>
           <p:nvPr/>
         </p:nvPicPr>
         <p:blipFill>
-          <a:blip r:embed="rId7"/>
+          <a:blip r:embed="rId9"/>
           <a:stretch>
             <a:fillRect/>
           </a:stretch>
@@ -9608,7 +9827,7 @@
           <a:bodyPr wrap="square" lIns="0" tIns="0" rIns="0" bIns="0" rtlCol="0" anchor="ctr"/>
           <a:lstStyle/>
           <a:p>
-            <a:pPr indent="0" marL="0">
+            <a:pPr marL="0" indent="0">
               <a:buNone/>
             </a:pPr>
             <a:r>
@@ -9644,7 +9863,7 @@
           <a:bodyPr wrap="square" lIns="0" tIns="0" rIns="0" bIns="0" rtlCol="0" anchor="ctr"/>
           <a:lstStyle/>
           <a:p>
-            <a:pPr indent="0" marL="0">
+            <a:pPr marL="0" indent="0">
               <a:buNone/>
             </a:pPr>
             <a:r>
@@ -9679,7 +9898,7 @@
           </a:prstGeom>
           <a:extLst>
             <a:ext uri="{C572A759-6A51-4108-AA02-DFA0A04FC94B}">
-              <ma14:wrappingTextBoxFlag xmlns:ma14="http://schemas.microsoft.com/office/mac/drawingml/2011/main" val="0"/>
+              <ma14:wrappingTextBoxFlag xmlns:ma14="http://schemas.microsoft.com/office/mac/drawingml/2011/main" xmlns="" val="0"/>
             </a:ext>
           </a:extLst>
         </p:spPr>
@@ -9697,7 +9916,7 @@
           <a:p>
             <a:pPr algn="r"/>
             <a:fld id="{F7021451-1387-4CA6-816F-3879F97B5CBC}" type="slidenum">
-              <a:rPr b="0" lang="en-US"/>
+              <a:rPr lang="en-US" b="0"/>
               <a:t>7</a:t>
             </a:fld>
             <a:endParaRPr lang="en-US"/>
@@ -9732,9 +9951,11 @@
       <p:sp>
         <p:nvSpPr>
           <p:cNvPr id="2" name="Text 1"/>
-          <p:cNvSpPr/>
+          <p:cNvSpPr>
+            <a:spLocks noGrp="1"/>
+          </p:cNvSpPr>
           <p:nvPr>
-            <p:ph idx="101" type="title" hasCustomPrompt="1"/>
+            <p:ph type="title" idx="101" hasCustomPrompt="1"/>
           </p:nvPr>
         </p:nvSpPr>
         <p:spPr>
@@ -9752,7 +9973,7 @@
           <a:bodyPr wrap="square" lIns="0" tIns="0" rIns="0" bIns="0" rtlCol="0" anchor="ctr"/>
           <a:lstStyle/>
           <a:p>
-            <a:pPr indent="0" marL="0">
+            <a:pPr marL="0" indent="0">
               <a:buNone/>
             </a:pPr>
             <a:r>
@@ -9796,6 +10017,13 @@
             <a:prstDash val="solid"/>
           </a:ln>
         </p:spPr>
+        <p:txBody>
+          <a:bodyPr/>
+          <a:lstStyle/>
+          <a:p>
+            <a:endParaRPr lang="fr-FR"/>
+          </a:p>
+        </p:txBody>
       </p:sp>
       <p:sp>
         <p:nvSpPr>
@@ -9821,17 +10049,24 @@
             <a:prstDash val="solid"/>
           </a:ln>
         </p:spPr>
+        <p:txBody>
+          <a:bodyPr/>
+          <a:lstStyle/>
+          <a:p>
+            <a:endParaRPr lang="fr-FR"/>
+          </a:p>
+        </p:txBody>
       </p:sp>
       <p:pic>
         <p:nvPicPr>
-          <p:cNvPr id="5" name="Icône Arduino" descr="Arduino">    </p:cNvPr>
+          <p:cNvPr id="5" name="Icône Arduino" descr="Arduino"/>
           <p:cNvPicPr>
             <a:picLocks noChangeAspect="1"/>
           </p:cNvPicPr>
           <p:nvPr/>
         </p:nvPicPr>
         <p:blipFill>
-          <a:blip r:embed="rId1"/>
+          <a:blip r:embed="rId3"/>
           <a:stretch>
             <a:fillRect/>
           </a:stretch>
@@ -9867,7 +10102,7 @@
           <a:bodyPr wrap="square" lIns="0" tIns="0" rIns="0" bIns="0" rtlCol="0" anchor="ctr"/>
           <a:lstStyle/>
           <a:p>
-            <a:pPr indent="0" marL="0">
+            <a:pPr marL="0" indent="0">
               <a:buNone/>
             </a:pPr>
             <a:r>
@@ -9881,7 +10116,7 @@
             <a:endParaRPr lang="en-US" sz="1500" dirty="0"/>
           </a:p>
           <a:p>
-            <a:pPr indent="0" marL="0">
+            <a:pPr marL="0" indent="0">
               <a:buNone/>
             </a:pPr>
             <a:r>
@@ -9922,6 +10157,13 @@
             <a:prstDash val="solid"/>
           </a:ln>
         </p:spPr>
+        <p:txBody>
+          <a:bodyPr/>
+          <a:lstStyle/>
+          <a:p>
+            <a:endParaRPr lang="fr-FR"/>
+          </a:p>
+        </p:txBody>
       </p:sp>
       <p:sp>
         <p:nvSpPr>
@@ -9947,17 +10189,24 @@
             <a:prstDash val="solid"/>
           </a:ln>
         </p:spPr>
+        <p:txBody>
+          <a:bodyPr/>
+          <a:lstStyle/>
+          <a:p>
+            <a:endParaRPr lang="fr-FR"/>
+          </a:p>
+        </p:txBody>
       </p:sp>
       <p:pic>
         <p:nvPicPr>
-          <p:cNvPr id="9" name="Icône Raspberry Pi" descr="Raspberry Pi">    </p:cNvPr>
+          <p:cNvPr id="9" name="Icône Raspberry Pi" descr="Raspberry Pi"/>
           <p:cNvPicPr>
             <a:picLocks noChangeAspect="1"/>
           </p:cNvPicPr>
           <p:nvPr/>
         </p:nvPicPr>
         <p:blipFill>
-          <a:blip r:embed="rId2"/>
+          <a:blip r:embed="rId4"/>
           <a:stretch>
             <a:fillRect/>
           </a:stretch>
@@ -9993,7 +10242,7 @@
           <a:bodyPr wrap="square" lIns="0" tIns="0" rIns="0" bIns="0" rtlCol="0" anchor="ctr"/>
           <a:lstStyle/>
           <a:p>
-            <a:pPr indent="0" marL="0">
+            <a:pPr marL="0" indent="0">
               <a:buNone/>
             </a:pPr>
             <a:r>
@@ -10007,7 +10256,7 @@
             <a:endParaRPr lang="en-US" sz="1500" dirty="0"/>
           </a:p>
           <a:p>
-            <a:pPr indent="0" marL="0">
+            <a:pPr marL="0" indent="0">
               <a:buNone/>
             </a:pPr>
             <a:r>
@@ -10048,6 +10297,13 @@
             <a:prstDash val="solid"/>
           </a:ln>
         </p:spPr>
+        <p:txBody>
+          <a:bodyPr/>
+          <a:lstStyle/>
+          <a:p>
+            <a:endParaRPr lang="fr-FR"/>
+          </a:p>
+        </p:txBody>
       </p:sp>
       <p:sp>
         <p:nvSpPr>
@@ -10073,17 +10329,24 @@
             <a:prstDash val="solid"/>
           </a:ln>
         </p:spPr>
+        <p:txBody>
+          <a:bodyPr/>
+          <a:lstStyle/>
+          <a:p>
+            <a:endParaRPr lang="fr-FR"/>
+          </a:p>
+        </p:txBody>
       </p:sp>
       <p:pic>
         <p:nvPicPr>
-          <p:cNvPr id="13" name="Icône écran" descr="écran">    </p:cNvPr>
+          <p:cNvPr id="13" name="Icône écran" descr="écran"/>
           <p:cNvPicPr>
             <a:picLocks noChangeAspect="1"/>
           </p:cNvPicPr>
           <p:nvPr/>
         </p:nvPicPr>
         <p:blipFill>
-          <a:blip r:embed="rId3"/>
+          <a:blip r:embed="rId5"/>
           <a:stretch>
             <a:fillRect/>
           </a:stretch>
@@ -10119,7 +10382,7 @@
           <a:bodyPr wrap="square" lIns="0" tIns="0" rIns="0" bIns="0" rtlCol="0" anchor="ctr"/>
           <a:lstStyle/>
           <a:p>
-            <a:pPr indent="0" marL="0">
+            <a:pPr marL="0" indent="0">
               <a:buNone/>
             </a:pPr>
             <a:r>
@@ -10133,7 +10396,7 @@
             <a:endParaRPr lang="en-US" sz="1500" dirty="0"/>
           </a:p>
           <a:p>
-            <a:pPr indent="0" marL="0">
+            <a:pPr marL="0" indent="0">
               <a:buNone/>
             </a:pPr>
             <a:r>
@@ -10174,6 +10437,13 @@
             <a:prstDash val="solid"/>
           </a:ln>
         </p:spPr>
+        <p:txBody>
+          <a:bodyPr/>
+          <a:lstStyle/>
+          <a:p>
+            <a:endParaRPr lang="fr-FR"/>
+          </a:p>
+        </p:txBody>
       </p:sp>
       <p:sp>
         <p:nvSpPr>
@@ -10199,17 +10469,24 @@
             <a:prstDash val="solid"/>
           </a:ln>
         </p:spPr>
+        <p:txBody>
+          <a:bodyPr/>
+          <a:lstStyle/>
+          <a:p>
+            <a:endParaRPr lang="fr-FR"/>
+          </a:p>
+        </p:txBody>
       </p:sp>
       <p:pic>
         <p:nvPicPr>
-          <p:cNvPr id="17" name="Icône téléphones" descr="téléphones">    </p:cNvPr>
+          <p:cNvPr id="17" name="Icône téléphones" descr="téléphones"/>
           <p:cNvPicPr>
             <a:picLocks noChangeAspect="1"/>
           </p:cNvPicPr>
           <p:nvPr/>
         </p:nvPicPr>
         <p:blipFill>
-          <a:blip r:embed="rId4"/>
+          <a:blip r:embed="rId6"/>
           <a:stretch>
             <a:fillRect/>
           </a:stretch>
@@ -10245,7 +10522,7 @@
           <a:bodyPr wrap="square" lIns="0" tIns="0" rIns="0" bIns="0" rtlCol="0" anchor="ctr"/>
           <a:lstStyle/>
           <a:p>
-            <a:pPr indent="0" marL="0">
+            <a:pPr marL="0" indent="0">
               <a:buNone/>
             </a:pPr>
             <a:r>
@@ -10259,7 +10536,7 @@
             <a:endParaRPr lang="en-US" sz="1500" dirty="0"/>
           </a:p>
           <a:p>
-            <a:pPr indent="0" marL="0">
+            <a:pPr marL="0" indent="0">
               <a:buNone/>
             </a:pPr>
             <a:r>
@@ -10300,6 +10577,13 @@
             <a:prstDash val="solid"/>
           </a:ln>
         </p:spPr>
+        <p:txBody>
+          <a:bodyPr/>
+          <a:lstStyle/>
+          <a:p>
+            <a:endParaRPr lang="fr-FR"/>
+          </a:p>
+        </p:txBody>
       </p:sp>
       <p:sp>
         <p:nvSpPr>
@@ -10325,17 +10609,24 @@
             <a:prstDash val="solid"/>
           </a:ln>
         </p:spPr>
+        <p:txBody>
+          <a:bodyPr/>
+          <a:lstStyle/>
+          <a:p>
+            <a:endParaRPr lang="fr-FR"/>
+          </a:p>
+        </p:txBody>
       </p:sp>
       <p:pic>
         <p:nvPicPr>
-          <p:cNvPr id="21" name="Icône MySQL" descr="MySQL">    </p:cNvPr>
+          <p:cNvPr id="21" name="Icône MySQL" descr="MySQL"/>
           <p:cNvPicPr>
             <a:picLocks noChangeAspect="1"/>
           </p:cNvPicPr>
           <p:nvPr/>
         </p:nvPicPr>
         <p:blipFill>
-          <a:blip r:embed="rId5"/>
+          <a:blip r:embed="rId7"/>
           <a:stretch>
             <a:fillRect/>
           </a:stretch>
@@ -10371,7 +10662,7 @@
           <a:bodyPr wrap="square" lIns="0" tIns="0" rIns="0" bIns="0" rtlCol="0" anchor="ctr"/>
           <a:lstStyle/>
           <a:p>
-            <a:pPr indent="0" marL="0">
+            <a:pPr marL="0" indent="0">
               <a:buNone/>
             </a:pPr>
             <a:r>
@@ -10385,7 +10676,7 @@
             <a:endParaRPr lang="en-US" sz="1500" dirty="0"/>
           </a:p>
           <a:p>
-            <a:pPr indent="0" marL="0">
+            <a:pPr marL="0" indent="0">
               <a:buNone/>
             </a:pPr>
             <a:r>
@@ -10424,6 +10715,13 @@
             <a:tailEnd type="triangle"/>
           </a:ln>
         </p:spPr>
+        <p:txBody>
+          <a:bodyPr/>
+          <a:lstStyle/>
+          <a:p>
+            <a:endParaRPr lang="fr-FR"/>
+          </a:p>
+        </p:txBody>
       </p:sp>
       <p:sp>
         <p:nvSpPr>
@@ -10446,7 +10744,7 @@
           <a:bodyPr wrap="square" lIns="0" tIns="0" rIns="0" bIns="0" rtlCol="0" anchor="b"/>
           <a:lstStyle/>
           <a:p>
-            <a:pPr algn="ctr" indent="0" marL="0">
+            <a:pPr marL="0" indent="0" algn="ctr">
               <a:buNone/>
             </a:pPr>
             <a:r>
@@ -10460,7 +10758,7 @@
             <a:endParaRPr lang="en-US" sz="1000" dirty="0"/>
           </a:p>
           <a:p>
-            <a:pPr algn="ctr" indent="0" marL="0">
+            <a:pPr marL="0" indent="0" algn="ctr">
               <a:buNone/>
             </a:pPr>
             <a:r>
@@ -10499,6 +10797,13 @@
             <a:tailEnd type="triangle"/>
           </a:ln>
         </p:spPr>
+        <p:txBody>
+          <a:bodyPr/>
+          <a:lstStyle/>
+          <a:p>
+            <a:endParaRPr lang="fr-FR"/>
+          </a:p>
+        </p:txBody>
       </p:sp>
       <p:sp>
         <p:nvSpPr>
@@ -10524,6 +10829,13 @@
             <a:tailEnd type="triangle"/>
           </a:ln>
         </p:spPr>
+        <p:txBody>
+          <a:bodyPr/>
+          <a:lstStyle/>
+          <a:p>
+            <a:endParaRPr lang="fr-FR"/>
+          </a:p>
+        </p:txBody>
       </p:sp>
       <p:sp>
         <p:nvSpPr>
@@ -10546,7 +10858,7 @@
           <a:bodyPr wrap="square" lIns="0" tIns="0" rIns="0" bIns="0" rtlCol="0" anchor="ctr"/>
           <a:lstStyle/>
           <a:p>
-            <a:pPr algn="ctr" indent="0" marL="0">
+            <a:pPr marL="0" indent="0" algn="ctr">
               <a:buNone/>
             </a:pPr>
             <a:r>
@@ -10560,7 +10872,7 @@
             <a:endParaRPr lang="en-US" sz="1000" dirty="0"/>
           </a:p>
           <a:p>
-            <a:pPr algn="ctr" indent="0" marL="0">
+            <a:pPr marL="0" indent="0" algn="ctr">
               <a:buNone/>
             </a:pPr>
             <a:r>
@@ -10599,6 +10911,13 @@
             <a:tailEnd type="triangle"/>
           </a:ln>
         </p:spPr>
+        <p:txBody>
+          <a:bodyPr/>
+          <a:lstStyle/>
+          <a:p>
+            <a:endParaRPr lang="fr-FR"/>
+          </a:p>
+        </p:txBody>
       </p:sp>
       <p:sp>
         <p:nvSpPr>
@@ -10621,7 +10940,7 @@
           <a:bodyPr wrap="square" lIns="0" tIns="0" rIns="0" bIns="0" rtlCol="0" anchor="ctr"/>
           <a:lstStyle/>
           <a:p>
-            <a:pPr indent="0" marL="0">
+            <a:pPr marL="0" indent="0">
               <a:buNone/>
             </a:pPr>
             <a:r>
@@ -10638,7 +10957,7 @@
       </p:sp>
       <p:sp>
         <p:nvSpPr>
-          <p:cNvPr id="25" name="Slide Number Placeholder 0"/>
+          <p:cNvPr id="30" name="Slide Number Placeholder 0"/>
           <p:cNvSpPr>
             <a:spLocks noGrp="1"/>
           </p:cNvSpPr>
@@ -10656,7 +10975,7 @@
           </a:prstGeom>
           <a:extLst>
             <a:ext uri="{C572A759-6A51-4108-AA02-DFA0A04FC94B}">
-              <ma14:wrappingTextBoxFlag xmlns:ma14="http://schemas.microsoft.com/office/mac/drawingml/2011/main" val="0"/>
+              <ma14:wrappingTextBoxFlag xmlns:ma14="http://schemas.microsoft.com/office/mac/drawingml/2011/main" xmlns="" val="0"/>
             </a:ext>
           </a:extLst>
         </p:spPr>
@@ -10674,7 +10993,7 @@
           <a:p>
             <a:pPr algn="r"/>
             <a:fld id="{F7021451-1387-4CA6-816F-3879F97B5CBC}" type="slidenum">
-              <a:rPr b="0" lang="en-US"/>
+              <a:rPr lang="en-US" b="0"/>
               <a:t>8</a:t>
             </a:fld>
             <a:endParaRPr lang="en-US"/>
@@ -10709,9 +11028,11 @@
       <p:sp>
         <p:nvSpPr>
           <p:cNvPr id="2" name="Text 1"/>
-          <p:cNvSpPr/>
+          <p:cNvSpPr>
+            <a:spLocks noGrp="1"/>
+          </p:cNvSpPr>
           <p:nvPr>
-            <p:ph idx="101" type="title" hasCustomPrompt="1"/>
+            <p:ph type="title" idx="101" hasCustomPrompt="1"/>
           </p:nvPr>
         </p:nvSpPr>
         <p:spPr>
@@ -10729,7 +11050,7 @@
           <a:bodyPr wrap="square" lIns="0" tIns="0" rIns="0" bIns="0" rtlCol="0" anchor="ctr"/>
           <a:lstStyle/>
           <a:p>
-            <a:pPr indent="0" marL="0">
+            <a:pPr marL="0" indent="0">
               <a:buNone/>
             </a:pPr>
             <a:r>
@@ -10773,6 +11094,13 @@
             <a:prstDash val="solid"/>
           </a:ln>
         </p:spPr>
+        <p:txBody>
+          <a:bodyPr/>
+          <a:lstStyle/>
+          <a:p>
+            <a:endParaRPr lang="fr-FR"/>
+          </a:p>
+        </p:txBody>
       </p:sp>
       <p:sp>
         <p:nvSpPr>
@@ -10795,7 +11123,7 @@
           <a:bodyPr wrap="square" lIns="0" tIns="0" rIns="0" bIns="0" rtlCol="0" anchor="ctr"/>
           <a:lstStyle/>
           <a:p>
-            <a:pPr indent="0" marL="0">
+            <a:pPr marL="0" indent="0">
               <a:buNone/>
             </a:pPr>
             <a:r>
@@ -10809,9 +11137,6 @@
               </a:rPr>
               <a:t>1</a:t>
             </a:r>
-            <a:pPr indent="0" marL="0">
-              <a:buNone/>
-            </a:pPr>
             <a:r>
               <a:rPr lang="en-US" sz="1600" b="1" dirty="0">
                 <a:solidFill>
@@ -10848,7 +11173,7 @@
           <a:bodyPr wrap="square" lIns="0" tIns="0" rIns="0" bIns="0" rtlCol="0" anchor="t"/>
           <a:lstStyle/>
           <a:p>
-            <a:pPr indent="0" marL="0">
+            <a:pPr marL="0" indent="0">
               <a:spcAft>
                 <a:spcPts val="400"/>
               </a:spcAft>
@@ -10868,7 +11193,7 @@
             <a:endParaRPr lang="en-US" sz="1400" dirty="0"/>
           </a:p>
           <a:p>
-            <a:pPr indent="0" marL="0">
+            <a:pPr marL="0" indent="0">
               <a:spcAft>
                 <a:spcPts val="400"/>
               </a:spcAft>
@@ -10912,6 +11237,13 @@
             <a:prstDash val="solid"/>
           </a:ln>
         </p:spPr>
+        <p:txBody>
+          <a:bodyPr/>
+          <a:lstStyle/>
+          <a:p>
+            <a:endParaRPr lang="fr-FR"/>
+          </a:p>
+        </p:txBody>
       </p:sp>
       <p:sp>
         <p:nvSpPr>
@@ -10934,7 +11266,7 @@
           <a:bodyPr wrap="square" lIns="0" tIns="0" rIns="0" bIns="0" rtlCol="0" anchor="ctr"/>
           <a:lstStyle/>
           <a:p>
-            <a:pPr indent="0" marL="0">
+            <a:pPr marL="0" indent="0">
               <a:buNone/>
             </a:pPr>
             <a:r>
@@ -10948,9 +11280,6 @@
               </a:rPr>
               <a:t>2</a:t>
             </a:r>
-            <a:pPr indent="0" marL="0">
-              <a:buNone/>
-            </a:pPr>
             <a:r>
               <a:rPr lang="en-US" sz="1600" b="1" dirty="0">
                 <a:solidFill>
@@ -10987,7 +11316,7 @@
           <a:bodyPr wrap="square" lIns="0" tIns="0" rIns="0" bIns="0" rtlCol="0" anchor="t"/>
           <a:lstStyle/>
           <a:p>
-            <a:pPr indent="0" marL="0">
+            <a:pPr marL="0" indent="0">
               <a:spcAft>
                 <a:spcPts val="400"/>
               </a:spcAft>
@@ -11031,6 +11360,13 @@
             <a:prstDash val="solid"/>
           </a:ln>
         </p:spPr>
+        <p:txBody>
+          <a:bodyPr/>
+          <a:lstStyle/>
+          <a:p>
+            <a:endParaRPr lang="fr-FR"/>
+          </a:p>
+        </p:txBody>
       </p:sp>
       <p:sp>
         <p:nvSpPr>
@@ -11053,7 +11389,7 @@
           <a:bodyPr wrap="square" lIns="0" tIns="0" rIns="0" bIns="0" rtlCol="0" anchor="ctr"/>
           <a:lstStyle/>
           <a:p>
-            <a:pPr indent="0" marL="0">
+            <a:pPr marL="0" indent="0">
               <a:buNone/>
             </a:pPr>
             <a:r>
@@ -11067,9 +11403,6 @@
               </a:rPr>
               <a:t>3</a:t>
             </a:r>
-            <a:pPr indent="0" marL="0">
-              <a:buNone/>
-            </a:pPr>
             <a:r>
               <a:rPr lang="en-US" sz="1600" b="1" dirty="0">
                 <a:solidFill>
@@ -11106,7 +11439,7 @@
           <a:bodyPr wrap="square" lIns="0" tIns="0" rIns="0" bIns="0" rtlCol="0" anchor="t"/>
           <a:lstStyle/>
           <a:p>
-            <a:pPr indent="0" marL="0">
+            <a:pPr marL="0" indent="0">
               <a:spcAft>
                 <a:spcPts val="400"/>
               </a:spcAft>
@@ -11150,6 +11483,13 @@
             <a:prstDash val="solid"/>
           </a:ln>
         </p:spPr>
+        <p:txBody>
+          <a:bodyPr/>
+          <a:lstStyle/>
+          <a:p>
+            <a:endParaRPr lang="fr-FR"/>
+          </a:p>
+        </p:txBody>
       </p:sp>
       <p:sp>
         <p:nvSpPr>
@@ -11172,7 +11512,7 @@
           <a:bodyPr wrap="square" lIns="0" tIns="0" rIns="0" bIns="0" rtlCol="0" anchor="ctr"/>
           <a:lstStyle/>
           <a:p>
-            <a:pPr indent="0" marL="0">
+            <a:pPr marL="0" indent="0">
               <a:buNone/>
             </a:pPr>
             <a:r>
@@ -11186,9 +11526,6 @@
               </a:rPr>
               <a:t>4</a:t>
             </a:r>
-            <a:pPr indent="0" marL="0">
-              <a:buNone/>
-            </a:pPr>
             <a:r>
               <a:rPr lang="en-US" sz="1600" b="1" dirty="0">
                 <a:solidFill>
@@ -11225,7 +11562,7 @@
           <a:bodyPr wrap="square" lIns="0" tIns="0" rIns="0" bIns="0" rtlCol="0" anchor="t"/>
           <a:lstStyle/>
           <a:p>
-            <a:pPr indent="0" marL="0">
+            <a:pPr marL="0" indent="0">
               <a:spcAft>
                 <a:spcPts val="400"/>
               </a:spcAft>
@@ -11245,7 +11582,7 @@
             <a:endParaRPr lang="en-US" sz="1400" dirty="0"/>
           </a:p>
           <a:p>
-            <a:pPr indent="0" marL="0">
+            <a:pPr marL="0" indent="0">
               <a:spcAft>
                 <a:spcPts val="400"/>
               </a:spcAft>
@@ -11283,7 +11620,7 @@
           </a:prstGeom>
           <a:extLst>
             <a:ext uri="{C572A759-6A51-4108-AA02-DFA0A04FC94B}">
-              <ma14:wrappingTextBoxFlag xmlns:ma14="http://schemas.microsoft.com/office/mac/drawingml/2011/main" val="0"/>
+              <ma14:wrappingTextBoxFlag xmlns:ma14="http://schemas.microsoft.com/office/mac/drawingml/2011/main" xmlns="" val="0"/>
             </a:ext>
           </a:extLst>
         </p:spPr>
@@ -11301,7 +11638,7 @@
           <a:p>
             <a:pPr algn="r"/>
             <a:fld id="{F7021451-1387-4CA6-816F-3879F97B5CBC}" type="slidenum">
-              <a:rPr b="0" lang="en-US"/>
+              <a:rPr lang="en-US" b="0"/>
               <a:t>9</a:t>
             </a:fld>
             <a:endParaRPr lang="en-US"/>
@@ -11609,4 +11946,319 @@
     </a:ext>
   </a:extLst>
 </a:theme>
+</file>
+
+<file path=ppt/theme/theme2.xml><?xml version="1.0" encoding="utf-8"?>
+<a:theme xmlns:a="http://schemas.openxmlformats.org/drawingml/2006/main" name="Thème Office">
+  <a:themeElements>
+    <a:clrScheme name="Office">
+      <a:dk1>
+        <a:sysClr val="windowText" lastClr="000000"/>
+      </a:dk1>
+      <a:lt1>
+        <a:sysClr val="window" lastClr="FFFFFF"/>
+      </a:lt1>
+      <a:dk2>
+        <a:srgbClr val="0E2841"/>
+      </a:dk2>
+      <a:lt2>
+        <a:srgbClr val="E8E8E8"/>
+      </a:lt2>
+      <a:accent1>
+        <a:srgbClr val="156082"/>
+      </a:accent1>
+      <a:accent2>
+        <a:srgbClr val="E97132"/>
+      </a:accent2>
+      <a:accent3>
+        <a:srgbClr val="196B24"/>
+      </a:accent3>
+      <a:accent4>
+        <a:srgbClr val="0F9ED5"/>
+      </a:accent4>
+      <a:accent5>
+        <a:srgbClr val="A02B93"/>
+      </a:accent5>
+      <a:accent6>
+        <a:srgbClr val="4EA72E"/>
+      </a:accent6>
+      <a:hlink>
+        <a:srgbClr val="467886"/>
+      </a:hlink>
+      <a:folHlink>
+        <a:srgbClr val="96607D"/>
+      </a:folHlink>
+    </a:clrScheme>
+    <a:fontScheme name="Office">
+      <a:majorFont>
+        <a:latin typeface="Aptos Display" panose="02110004020202020204"/>
+        <a:ea typeface=""/>
+        <a:cs typeface=""/>
+        <a:font script="Jpan" typeface="游ゴシック Light"/>
+        <a:font script="Hang" typeface="맑은 고딕"/>
+        <a:font script="Hans" typeface="等线 Light"/>
+        <a:font script="Hant" typeface="新細明體"/>
+        <a:font script="Arab" typeface="Times New Roman"/>
+        <a:font script="Hebr" typeface="Times New Roman"/>
+        <a:font script="Thai" typeface="Angsana New"/>
+        <a:font script="Ethi" typeface="Nyala"/>
+        <a:font script="Beng" typeface="Vrinda"/>
+        <a:font script="Gujr" typeface="Shruti"/>
+        <a:font script="Khmr" typeface="MoolBoran"/>
+        <a:font script="Knda" typeface="Tunga"/>
+        <a:font script="Guru" typeface="Raavi"/>
+        <a:font script="Cans" typeface="Euphemia"/>
+        <a:font script="Cher" typeface="Plantagenet Cherokee"/>
+        <a:font script="Yiii" typeface="Microsoft Yi Baiti"/>
+        <a:font script="Tibt" typeface="Microsoft Himalaya"/>
+        <a:font script="Thaa" typeface="MV Boli"/>
+        <a:font script="Deva" typeface="Mangal"/>
+        <a:font script="Telu" typeface="Gautami"/>
+        <a:font script="Taml" typeface="Latha"/>
+        <a:font script="Syrc" typeface="Estrangelo Edessa"/>
+        <a:font script="Orya" typeface="Kalinga"/>
+        <a:font script="Mlym" typeface="Kartika"/>
+        <a:font script="Laoo" typeface="DokChampa"/>
+        <a:font script="Sinh" typeface="Iskoola Pota"/>
+        <a:font script="Mong" typeface="Mongolian Baiti"/>
+        <a:font script="Viet" typeface="Times New Roman"/>
+        <a:font script="Uigh" typeface="Microsoft Uighur"/>
+        <a:font script="Geor" typeface="Sylfaen"/>
+        <a:font script="Armn" typeface="Arial"/>
+        <a:font script="Bugi" typeface="Leelawadee UI"/>
+        <a:font script="Bopo" typeface="Microsoft JhengHei"/>
+        <a:font script="Java" typeface="Javanese Text"/>
+        <a:font script="Lisu" typeface="Segoe UI"/>
+        <a:font script="Mymr" typeface="Myanmar Text"/>
+        <a:font script="Nkoo" typeface="Ebrima"/>
+        <a:font script="Olck" typeface="Nirmala UI"/>
+        <a:font script="Osma" typeface="Ebrima"/>
+        <a:font script="Phag" typeface="Phagspa"/>
+        <a:font script="Syrn" typeface="Estrangelo Edessa"/>
+        <a:font script="Syrj" typeface="Estrangelo Edessa"/>
+        <a:font script="Syre" typeface="Estrangelo Edessa"/>
+        <a:font script="Sora" typeface="Nirmala UI"/>
+        <a:font script="Tale" typeface="Microsoft Tai Le"/>
+        <a:font script="Talu" typeface="Microsoft New Tai Lue"/>
+        <a:font script="Tfng" typeface="Ebrima"/>
+      </a:majorFont>
+      <a:minorFont>
+        <a:latin typeface="Aptos" panose="02110004020202020204"/>
+        <a:ea typeface=""/>
+        <a:cs typeface=""/>
+        <a:font script="Jpan" typeface="游ゴシック"/>
+        <a:font script="Hang" typeface="맑은 고딕"/>
+        <a:font script="Hans" typeface="等线"/>
+        <a:font script="Hant" typeface="新細明體"/>
+        <a:font script="Arab" typeface="Arial"/>
+        <a:font script="Hebr" typeface="Arial"/>
+        <a:font script="Thai" typeface="Cordia New"/>
+        <a:font script="Ethi" typeface="Nyala"/>
+        <a:font script="Beng" typeface="Vrinda"/>
+        <a:font script="Gujr" typeface="Shruti"/>
+        <a:font script="Khmr" typeface="DaunPenh"/>
+        <a:font script="Knda" typeface="Tunga"/>
+        <a:font script="Guru" typeface="Raavi"/>
+        <a:font script="Cans" typeface="Euphemia"/>
+        <a:font script="Cher" typeface="Plantagenet Cherokee"/>
+        <a:font script="Yiii" typeface="Microsoft Yi Baiti"/>
+        <a:font script="Tibt" typeface="Microsoft Himalaya"/>
+        <a:font script="Thaa" typeface="MV Boli"/>
+        <a:font script="Deva" typeface="Mangal"/>
+        <a:font script="Telu" typeface="Gautami"/>
+        <a:font script="Taml" typeface="Latha"/>
+        <a:font script="Syrc" typeface="Estrangelo Edessa"/>
+        <a:font script="Orya" typeface="Kalinga"/>
+        <a:font script="Mlym" typeface="Kartika"/>
+        <a:font script="Laoo" typeface="DokChampa"/>
+        <a:font script="Sinh" typeface="Iskoola Pota"/>
+        <a:font script="Mong" typeface="Mongolian Baiti"/>
+        <a:font script="Viet" typeface="Arial"/>
+        <a:font script="Uigh" typeface="Microsoft Uighur"/>
+        <a:font script="Geor" typeface="Sylfaen"/>
+        <a:font script="Armn" typeface="Arial"/>
+        <a:font script="Bugi" typeface="Leelawadee UI"/>
+        <a:font script="Bopo" typeface="Microsoft JhengHei"/>
+        <a:font script="Java" typeface="Javanese Text"/>
+        <a:font script="Lisu" typeface="Segoe UI"/>
+        <a:font script="Mymr" typeface="Myanmar Text"/>
+        <a:font script="Nkoo" typeface="Ebrima"/>
+        <a:font script="Olck" typeface="Nirmala UI"/>
+        <a:font script="Osma" typeface="Ebrima"/>
+        <a:font script="Phag" typeface="Phagspa"/>
+        <a:font script="Syrn" typeface="Estrangelo Edessa"/>
+        <a:font script="Syrj" typeface="Estrangelo Edessa"/>
+        <a:font script="Syre" typeface="Estrangelo Edessa"/>
+        <a:font script="Sora" typeface="Nirmala UI"/>
+        <a:font script="Tale" typeface="Microsoft Tai Le"/>
+        <a:font script="Talu" typeface="Microsoft New Tai Lue"/>
+        <a:font script="Tfng" typeface="Ebrima"/>
+      </a:minorFont>
+    </a:fontScheme>
+    <a:fmtScheme name="Office">
+      <a:fillStyleLst>
+        <a:solidFill>
+          <a:schemeClr val="phClr"/>
+        </a:solidFill>
+        <a:gradFill rotWithShape="1">
+          <a:gsLst>
+            <a:gs pos="0">
+              <a:schemeClr val="phClr">
+                <a:lumMod val="110000"/>
+                <a:satMod val="105000"/>
+                <a:tint val="67000"/>
+              </a:schemeClr>
+            </a:gs>
+            <a:gs pos="50000">
+              <a:schemeClr val="phClr">
+                <a:lumMod val="105000"/>
+                <a:satMod val="103000"/>
+                <a:tint val="73000"/>
+              </a:schemeClr>
+            </a:gs>
+            <a:gs pos="100000">
+              <a:schemeClr val="phClr">
+                <a:lumMod val="105000"/>
+                <a:satMod val="109000"/>
+                <a:tint val="81000"/>
+              </a:schemeClr>
+            </a:gs>
+          </a:gsLst>
+          <a:lin ang="5400000" scaled="0"/>
+        </a:gradFill>
+        <a:gradFill rotWithShape="1">
+          <a:gsLst>
+            <a:gs pos="0">
+              <a:schemeClr val="phClr">
+                <a:satMod val="103000"/>
+                <a:lumMod val="102000"/>
+                <a:tint val="94000"/>
+              </a:schemeClr>
+            </a:gs>
+            <a:gs pos="50000">
+              <a:schemeClr val="phClr">
+                <a:satMod val="110000"/>
+                <a:lumMod val="100000"/>
+                <a:shade val="100000"/>
+              </a:schemeClr>
+            </a:gs>
+            <a:gs pos="100000">
+              <a:schemeClr val="phClr">
+                <a:lumMod val="99000"/>
+                <a:satMod val="120000"/>
+                <a:shade val="78000"/>
+              </a:schemeClr>
+            </a:gs>
+          </a:gsLst>
+          <a:lin ang="5400000" scaled="0"/>
+        </a:gradFill>
+      </a:fillStyleLst>
+      <a:lnStyleLst>
+        <a:ln w="12700" cap="flat" cmpd="sng" algn="ctr">
+          <a:solidFill>
+            <a:schemeClr val="phClr"/>
+          </a:solidFill>
+          <a:prstDash val="solid"/>
+          <a:miter lim="800000"/>
+        </a:ln>
+        <a:ln w="19050" cap="flat" cmpd="sng" algn="ctr">
+          <a:solidFill>
+            <a:schemeClr val="phClr"/>
+          </a:solidFill>
+          <a:prstDash val="solid"/>
+          <a:miter lim="800000"/>
+        </a:ln>
+        <a:ln w="25400" cap="flat" cmpd="sng" algn="ctr">
+          <a:solidFill>
+            <a:schemeClr val="phClr"/>
+          </a:solidFill>
+          <a:prstDash val="solid"/>
+          <a:miter lim="800000"/>
+        </a:ln>
+      </a:lnStyleLst>
+      <a:effectStyleLst>
+        <a:effectStyle>
+          <a:effectLst/>
+        </a:effectStyle>
+        <a:effectStyle>
+          <a:effectLst/>
+        </a:effectStyle>
+        <a:effectStyle>
+          <a:effectLst>
+            <a:outerShdw blurRad="57150" dist="19050" dir="5400000" algn="ctr" rotWithShape="0">
+              <a:srgbClr val="000000">
+                <a:alpha val="63000"/>
+              </a:srgbClr>
+            </a:outerShdw>
+          </a:effectLst>
+        </a:effectStyle>
+      </a:effectStyleLst>
+      <a:bgFillStyleLst>
+        <a:solidFill>
+          <a:schemeClr val="phClr"/>
+        </a:solidFill>
+        <a:solidFill>
+          <a:schemeClr val="phClr">
+            <a:tint val="95000"/>
+            <a:satMod val="170000"/>
+          </a:schemeClr>
+        </a:solidFill>
+        <a:gradFill rotWithShape="1">
+          <a:gsLst>
+            <a:gs pos="0">
+              <a:schemeClr val="phClr">
+                <a:tint val="93000"/>
+                <a:satMod val="150000"/>
+                <a:shade val="98000"/>
+                <a:lumMod val="102000"/>
+              </a:schemeClr>
+            </a:gs>
+            <a:gs pos="50000">
+              <a:schemeClr val="phClr">
+                <a:tint val="98000"/>
+                <a:satMod val="130000"/>
+                <a:shade val="90000"/>
+                <a:lumMod val="103000"/>
+              </a:schemeClr>
+            </a:gs>
+            <a:gs pos="100000">
+              <a:schemeClr val="phClr">
+                <a:shade val="63000"/>
+                <a:satMod val="120000"/>
+              </a:schemeClr>
+            </a:gs>
+          </a:gsLst>
+          <a:lin ang="5400000" scaled="0"/>
+        </a:gradFill>
+      </a:bgFillStyleLst>
+    </a:fmtScheme>
+  </a:themeElements>
+  <a:objectDefaults>
+    <a:lnDef>
+      <a:spPr/>
+      <a:bodyPr/>
+      <a:lstStyle/>
+      <a:style>
+        <a:lnRef idx="2">
+          <a:schemeClr val="accent1"/>
+        </a:lnRef>
+        <a:fillRef idx="0">
+          <a:schemeClr val="accent1"/>
+        </a:fillRef>
+        <a:effectRef idx="1">
+          <a:schemeClr val="accent1"/>
+        </a:effectRef>
+        <a:fontRef idx="minor">
+          <a:schemeClr val="tx1"/>
+        </a:fontRef>
+      </a:style>
+    </a:lnDef>
+  </a:objectDefaults>
+  <a:extraClrSchemeLst/>
+  <a:extLst>
+    <a:ext uri="{05A4C25C-085E-4340-85A3-A5531E510DB2}">
+      <thm15:themeFamily xmlns:thm15="http://schemas.microsoft.com/office/thememl/2012/main" name="Office Theme" id="{2E142A2C-CD16-42D6-873A-C26D2A0506FA}" vid="{1BDDFF52-6CD6-40A5-AB3C-68EB2F1E4D0A}"/>
+    </a:ext>
+  </a:extLst>
+</a:theme>
 </file>
</xml_diff>

<commit_message>
UPDATE présentation : retouches
</commit_message>
<xml_diff>
--- a/livrables/Workshop2025-26-M1gX-pres.pptx
+++ b/livrables/Workshop2025-26-M1gX-pres.pptx
@@ -326,7 +326,7 @@
           <a:p>
             <a:r>
               <a:rPr lang="en-US" dirty="0"/>
-              <a:t>Qui parle : Membre 3 · Durée : 20 s
+              <a:t>Qui parle : Tasha · Durée : 20 s
 « Bonjour, nous sommes le groupe X et voici Black-out, notre escape game sur le thème de l'environnement. »
 Accroche : « Imaginez : un saboteur pirate le chauffage, l'éclairage et les détecteurs du campus. Tel un gréviste, il veut consolider le blocus du campus, en soutien aux lycéens mobilisés, en provoquant un black-out général. Vous avez 20 minutes pour l'en empêcher… sans gaspiller d'énergie. »
 On enchaîne tout de suite sur la présentation de l'équipe, en anglais.
@@ -417,7 +417,7 @@
           <a:p>
             <a:r>
               <a:rPr lang="en-US" dirty="0"/>
-              <a:t>Qui parle : Membre 5 · Durée : 50 s
+              <a:t>Qui parle : Léo · Durée : 50 s
 - Données : les agents ne donnent qu'un pseudo ; aucune donnée personnelle n'est stockée, et le chat repart à zéro à chaque partie. L'historique ne garde que des chiffres de partie.
 - Chat : messages limités, anti-spam, affichés en texte brut ; on a testé une tentative d'injection HTML.
 - Seul l'écran du Pi peut lancer, réinitialiser ou simuler une partie : un téléphone qui ouvre la page du QG est en lecture seule.
@@ -511,7 +511,7 @@
           <a:p>
             <a:r>
               <a:rPr lang="en-US" dirty="0"/>
-              <a:t>Qui parle : Membre 5 · Durée : 30 s
+              <a:t>Qui parle : Léo · Durée : 30 s
 - On a avancé tous ensemble, étape par étape, plutôt qu'un module par personne : chacun a touché à l'Arduino, au Pi et au code.
 - Les rôles tournent toutes les heures : un pilote au clavier, un copilote qui relit, un secrétaire qui tient le journal.
 - GitHub : une issue par tâche, rangée par étape, et un jalon par jour ; le journal de bord nourrit directement le dossier technique.
@@ -602,7 +602,7 @@
           <a:p>
             <a:r>
               <a:rPr lang="en-US" dirty="0"/>
-              <a:t>Qui parle : Membre 3 · Durée : 20 s
+              <a:t>Qui parle : Tasha · Durée : 20 s
 « Black-out, c'est 20 minutes pour déjouer le blocus, deux équipes qui doivent se parler, cinq salles… et des gestes que les lycéens peuvent refaire dès le lendemain. »
 À l'écran : le générique de victoire, fond rose CCI, logo du campus et score de l'équipe.
 « Merci ! Nous avons la console avec nous : si vous voulez, on vous lance une démo de deux salles. Place à vos questions. »
@@ -695,15 +695,22 @@
             <a:r>
               <a:rPr lang="en-US" dirty="0"/>
               <a:t>Speakers: all five members, about 12 seconds each, IN ENGLISH (this is the only part of the talk in English). Total: 1 minute.
-Replace "First name LAST NAME" on the slide with your names, and adjust the roles if needed.
 Template for each person:
 "Hi, I'm [first name]. I'm a fourth-year student at EPSI [+ work-study at …]. In this project, I was mainly in charge of [role]. What I enjoyed most was [one thing: wiring the sensors / the real-time chat / the touch interface / writing the puzzles / setting up the Raspberry Pi]."
 Example lines:
-- Member 1: "I built the Arduino console: seven Modulino sensors and the Grove kit, all talking to the Raspberry Pi through a simple text protocol."
-- Member 2: "I wrote the game server in Node.js: it runs the timer, checks the answers and pushes everything in real time."
-- Member 3: "I designed the touch interface for the 7-inch screen and the page the field agents use on their phones."
-- Member 4: "I wrote the puzzles and the envelopes, based on real data about energy in buildings."
-- Member 5: "I set up the Raspberry Pi, the network, the database and our documentation."
+- Romain: "I built the Arduino console: seven Modulino sensors and the Grove kit, all talking to the Raspberry Pi through a simple text protocol."
+- Noa: "I wrote the game server in Node.js: it runs the timer, checks the answers and pushes everything in real time."
+- Tasha: "I designed the touch interface for the 7-inch screen and the page the field agents use on their phones."
+- </a:t>
+            </a:r>
+            <a:r>
+              <a:rPr lang="en-US" dirty="0" err="1"/>
+              <a:t>Killiann</a:t>
+            </a:r>
+            <a:r>
+              <a:rPr lang="en-US" dirty="0"/>
+              <a:t>: "I wrote the puzzles and the envelopes, based on real data about energy in buildings."
+- Léo: "I set up the Raspberry Pi, the network, the database and our documentation."
 Transition (last speaker, back to French): « Et maintenant, place au jeu. »</a:t>
             </a:r>
           </a:p>
@@ -791,7 +798,15 @@
           <a:p>
             <a:r>
               <a:rPr lang="en-US" dirty="0"/>
-              <a:t>Qui parle : Membre 4 · Durée : 40 s
+              <a:t>Qui parle : </a:t>
+            </a:r>
+            <a:r>
+              <a:rPr lang="en-US" dirty="0" err="1"/>
+              <a:t>Killiann</a:t>
+            </a:r>
+            <a:r>
+              <a:rPr lang="en-US" dirty="0"/>
+              <a:t> · Durée : 40 s
 - Le sujet : des agents qui déjouent un plan lié au thème. Le nôtre : l'énergie du bâtiment.
 - L'intrigue : tel un gréviste, un saboteur veut consolider le blocus du campus, en soutien aux lycéens mobilisés, en provoquant un black-out général. Il dérègle tout un mardi à 14 h 20 (l'heure est affichée sur l'écran du QG, toutes les énigmes en dépendent).
 - Les joueurs découvrent cette histoire dans le briefing qui défile sur l'écran d'accueil du QG, à côté du QR code.
@@ -884,7 +899,7 @@
           <a:p>
             <a:r>
               <a:rPr lang="en-US" dirty="0"/>
-              <a:t>Qui parle : Membre 2 · Durée : 1 min · SLIDE OBLIGATOIRE
+              <a:t>Qui parle : Noa · Durée : 1 min · SLIDE OBLIGATOIRE
 - Le principe vient de Keep Talking and Nobody Explodes : une équipe voit, l'autre sait.
 - Le QG reste au poste fixe : Raspberry Pi, écran tactile 7 pouces et console Arduino. Il voit tout mais ne connaît aucune règle.
 - Les agents terrain partent dans le campus avec le plan. Dans chaque salle, une enveloppe contient les règles et les données de l'énigme.
@@ -978,7 +993,15 @@
           <a:p>
             <a:r>
               <a:rPr lang="en-US" dirty="0"/>
-              <a:t>Qui parle : Membre 4 · Durée : 50 s
+              <a:t>Qui parle : </a:t>
+            </a:r>
+            <a:r>
+              <a:rPr lang="en-US" dirty="0" err="1"/>
+              <a:t>Killiann</a:t>
+            </a:r>
+            <a:r>
+              <a:rPr lang="en-US" dirty="0"/>
+              <a:t> · Durée : 50 s
 Le sujet demande des énigmes variées (logique, maths, réflexion critique) et des objets connectés : chaque salle mobilise une compétence et un capteur différents.
 1. Chauffage : on calcule depuis combien d'heures la salle est vide et on applique la loi. Le QG règle la consigne à la molette.
 2. Éclairage : déduction logique à partir d'un planning ; on éteint les salles vides sur les 8 LEDs.
@@ -1072,7 +1095,15 @@
           <a:p>
             <a:r>
               <a:rPr lang="en-US" dirty="0"/>
-              <a:t>Qui parle : Membre 4 · Durée : 1 min · SLIDE OBLIGATOIRE
+              <a:t>Qui parle : </a:t>
+            </a:r>
+            <a:r>
+              <a:rPr lang="en-US" dirty="0" err="1"/>
+              <a:t>Killiann</a:t>
+            </a:r>
+            <a:r>
+              <a:rPr lang="en-US" dirty="0"/>
+              <a:t> · Durée : 1 min · SLIDE OBLIGATOIRE
 - Le sujet demande des énigmes basées sur des données réelles : les nôtres viennent du Code de l'énergie (19, 16 et 8 °C), de l'ADEME (7 % d'économie par degré) et du bilan 2024 de RTE (30 g de CO₂ par kWh en cycle de vie, 21,7 g en émissions directes).
 - Les plannings, capteurs et index de compteur sont inventés pour le jeu ; les règles et les chiffres de référence sont réels.
 - Ce que les lycéens travaillent : déduire, calculer, et surtout se parler clairement sous la pression du chrono.
@@ -1165,7 +1196,7 @@
           <a:p>
             <a:r>
               <a:rPr lang="en-US" dirty="0"/>
-              <a:t>Qui parle : Membre 3 · Durée : 40 s
+              <a:t>Qui parle : Tasha · Durée : 40 s
 - L'écran du QG fait 7 pouces (800 × 480) : tout est pensé pour le doigt, avec des boutons d'au moins 52 pixels, pas de zoom ni de sélection, et un curseur masqué.
 - L'accueil réunit tout ce qu'il faut pour démarrer : le QR code des agents, le briefing de mission qui défile (un toucher le met en pause pour lire) et deux gros boutons côte à côte.
 - Les joueurs savent toujours où ils en sont : salle 1 sur 5, chrono, erreurs, heure de l'histoire ; même le chat vide explique ce qui va y apparaître.
@@ -1259,7 +1290,7 @@
           <a:p>
             <a:r>
               <a:rPr lang="en-US" dirty="0"/>
-              <a:t>Qui parle : Membre 2 · Durée : 50 s
+              <a:t>Qui parle : Noa · Durée : 50 s
 - À gauche, la console : une Arduino UNO R4 WiFi avec 7 modules Modulino (molette, LEDs, boutons, buzzer, distance, mouvement, température) et le Sensor Kit Grove (OLED, potentiomètre, bouton, buzzer du morse).
 - Elle parle au Raspberry Pi 5 par USB : le même câble l'alimente et transporte les données.
 - Sur le Pi, un serveur Node.js (Express + Socket.io + serialport) fait tourner le jeu : chrono, erreurs, validation des réponses, enchaînement des salles.
@@ -1352,7 +1383,15 @@
           <a:p>
             <a:r>
               <a:rPr lang="en-US" dirty="0"/>
-              <a:t>Qui parle : Membre 1 (protocole) puis Membre 2 · Durée : 40 s
+              <a:t>Qui parle : Romain (protocole) </a:t>
+            </a:r>
+            <a:r>
+              <a:rPr lang="en-US" dirty="0" err="1"/>
+              <a:t>puis</a:t>
+            </a:r>
+            <a:r>
+              <a:rPr lang="en-US" dirty="0"/>
+              <a:t> Noa · Durée : 40 s
 1. Protocole : l'Arduino envoie par exemple « KNOB 19 » quand on tourne la molette, le Pi répond « LED 3 OK » pour allumer une LED en vert. Une ligne de texte par message : on peut tout tester dans le moniteur série.
 2. Validation : les écrans reçoivent seulement ce qu'ils doivent afficher. Les réponses attendues restent dans le serveur.
 3. Reprise : l'état de la partie est écrit chaque seconde dans un fichier, de façon atomique (pas de fichier à moitié écrit). Le chrono n'avance que quand le serveur tourne : une coupure ne fait pas perdre de temps. Au redémarrage, on ne relance pas la partie d'office : l'accueil affiche « Partie interrompue » avec un bouton Reprendre (même salle, même chrono), ou Nouvelle partie. Testé en coupant le serveur en pleine partie.
@@ -1586,7 +1625,7 @@
           </a:prstGeom>
           <a:extLst>
             <a:ext uri="{C572A759-6A51-4108-AA02-DFA0A04FC94B}">
-              <ma14:wrappingTextBoxFlag xmlns:ma14="http://schemas.microsoft.com/office/mac/drawingml/2011/main" xmlns="" val="0"/>
+              <ma14:wrappingTextBoxFlag xmlns="" xmlns:ma14="http://schemas.microsoft.com/office/mac/drawingml/2011/main" val="0"/>
             </a:ext>
           </a:extLst>
         </p:spPr>
@@ -1744,7 +1783,7 @@
           </a:prstGeom>
           <a:extLst>
             <a:ext uri="{C572A759-6A51-4108-AA02-DFA0A04FC94B}">
-              <ma14:wrappingTextBoxFlag xmlns:ma14="http://schemas.microsoft.com/office/mac/drawingml/2011/main" xmlns="" val="0"/>
+              <ma14:wrappingTextBoxFlag xmlns="" xmlns:ma14="http://schemas.microsoft.com/office/mac/drawingml/2011/main" val="0"/>
             </a:ext>
           </a:extLst>
         </p:spPr>
@@ -1819,7 +1858,7 @@
           </a:prstGeom>
           <a:extLst>
             <a:ext uri="{C572A759-6A51-4108-AA02-DFA0A04FC94B}">
-              <ma14:wrappingTextBoxFlag xmlns:ma14="http://schemas.microsoft.com/office/mac/drawingml/2011/main" xmlns="" val="0"/>
+              <ma14:wrappingTextBoxFlag xmlns="" xmlns:ma14="http://schemas.microsoft.com/office/mac/drawingml/2011/main" val="0"/>
             </a:ext>
           </a:extLst>
         </p:spPr>
@@ -2287,7 +2326,23 @@
                   <a:schemeClr val="accent5"/>
                 </a:solidFill>
               </a:rPr>
-              <a:t>Groupe X  ·  Thème : Environnement</a:t>
+              <a:t>Groupe Les </a:t>
+            </a:r>
+            <a:r>
+              <a:rPr lang="en-US" sz="1400" dirty="0" err="1">
+                <a:solidFill>
+                  <a:schemeClr val="accent5"/>
+                </a:solidFill>
+              </a:rPr>
+              <a:t>Goules</a:t>
+            </a:r>
+            <a:r>
+              <a:rPr lang="en-US" sz="1400" dirty="0">
+                <a:solidFill>
+                  <a:schemeClr val="accent5"/>
+                </a:solidFill>
+              </a:rPr>
+              <a:t>  ·  Thème : Environnement</a:t>
             </a:r>
             <a:endParaRPr lang="en-US" sz="1400" dirty="0"/>
           </a:p>
@@ -3196,7 +3251,7 @@
           </a:prstGeom>
           <a:extLst>
             <a:ext uri="{C572A759-6A51-4108-AA02-DFA0A04FC94B}">
-              <ma14:wrappingTextBoxFlag xmlns:ma14="http://schemas.microsoft.com/office/mac/drawingml/2011/main" xmlns="" val="0"/>
+              <ma14:wrappingTextBoxFlag xmlns="" xmlns:ma14="http://schemas.microsoft.com/office/mac/drawingml/2011/main" val="0"/>
             </a:ext>
           </a:extLst>
         </p:spPr>
@@ -4279,7 +4334,7 @@
           </a:prstGeom>
           <a:extLst>
             <a:ext uri="{C572A759-6A51-4108-AA02-DFA0A04FC94B}">
-              <ma14:wrappingTextBoxFlag xmlns:ma14="http://schemas.microsoft.com/office/mac/drawingml/2011/main" xmlns="" val="0"/>
+              <ma14:wrappingTextBoxFlag xmlns="" xmlns:ma14="http://schemas.microsoft.com/office/mac/drawingml/2011/main" val="0"/>
             </a:ext>
           </a:extLst>
         </p:spPr>
@@ -4619,7 +4674,7 @@
           </a:prstGeom>
           <a:extLst>
             <a:ext uri="{C572A759-6A51-4108-AA02-DFA0A04FC94B}">
-              <ma14:wrappingTextBoxFlag xmlns:ma14="http://schemas.microsoft.com/office/mac/drawingml/2011/main" xmlns="" val="0"/>
+              <ma14:wrappingTextBoxFlag xmlns="" xmlns:ma14="http://schemas.microsoft.com/office/mac/drawingml/2011/main" val="0"/>
             </a:ext>
           </a:extLst>
         </p:spPr>
@@ -5757,7 +5812,7 @@
           </a:prstGeom>
           <a:extLst>
             <a:ext uri="{C572A759-6A51-4108-AA02-DFA0A04FC94B}">
-              <ma14:wrappingTextBoxFlag xmlns:ma14="http://schemas.microsoft.com/office/mac/drawingml/2011/main" xmlns="" val="0"/>
+              <ma14:wrappingTextBoxFlag xmlns="" xmlns:ma14="http://schemas.microsoft.com/office/mac/drawingml/2011/main" val="0"/>
             </a:ext>
           </a:extLst>
         </p:spPr>
@@ -6376,7 +6431,7 @@
           </a:prstGeom>
           <a:extLst>
             <a:ext uri="{C572A759-6A51-4108-AA02-DFA0A04FC94B}">
-              <ma14:wrappingTextBoxFlag xmlns:ma14="http://schemas.microsoft.com/office/mac/drawingml/2011/main" xmlns="" val="0"/>
+              <ma14:wrappingTextBoxFlag xmlns="" xmlns:ma14="http://schemas.microsoft.com/office/mac/drawingml/2011/main" val="0"/>
             </a:ext>
           </a:extLst>
         </p:spPr>
@@ -7323,7 +7378,7 @@
           </a:prstGeom>
           <a:extLst>
             <a:ext uri="{C572A759-6A51-4108-AA02-DFA0A04FC94B}">
-              <ma14:wrappingTextBoxFlag xmlns:ma14="http://schemas.microsoft.com/office/mac/drawingml/2011/main" xmlns="" val="0"/>
+              <ma14:wrappingTextBoxFlag xmlns="" xmlns:ma14="http://schemas.microsoft.com/office/mac/drawingml/2011/main" val="0"/>
             </a:ext>
           </a:extLst>
         </p:spPr>
@@ -8426,7 +8481,7 @@
           </a:prstGeom>
           <a:extLst>
             <a:ext uri="{C572A759-6A51-4108-AA02-DFA0A04FC94B}">
-              <ma14:wrappingTextBoxFlag xmlns:ma14="http://schemas.microsoft.com/office/mac/drawingml/2011/main" xmlns="" val="0"/>
+              <ma14:wrappingTextBoxFlag xmlns="" xmlns:ma14="http://schemas.microsoft.com/office/mac/drawingml/2011/main" val="0"/>
             </a:ext>
           </a:extLst>
         </p:spPr>
@@ -9078,7 +9133,7 @@
           </a:prstGeom>
           <a:extLst>
             <a:ext uri="{C572A759-6A51-4108-AA02-DFA0A04FC94B}">
-              <ma14:wrappingTextBoxFlag xmlns:ma14="http://schemas.microsoft.com/office/mac/drawingml/2011/main" xmlns="" val="0"/>
+              <ma14:wrappingTextBoxFlag xmlns="" xmlns:ma14="http://schemas.microsoft.com/office/mac/drawingml/2011/main" val="0"/>
             </a:ext>
           </a:extLst>
         </p:spPr>
@@ -9898,7 +9953,7 @@
           </a:prstGeom>
           <a:extLst>
             <a:ext uri="{C572A759-6A51-4108-AA02-DFA0A04FC94B}">
-              <ma14:wrappingTextBoxFlag xmlns:ma14="http://schemas.microsoft.com/office/mac/drawingml/2011/main" xmlns="" val="0"/>
+              <ma14:wrappingTextBoxFlag xmlns="" xmlns:ma14="http://schemas.microsoft.com/office/mac/drawingml/2011/main" val="0"/>
             </a:ext>
           </a:extLst>
         </p:spPr>
@@ -10975,7 +11030,7 @@
           </a:prstGeom>
           <a:extLst>
             <a:ext uri="{C572A759-6A51-4108-AA02-DFA0A04FC94B}">
-              <ma14:wrappingTextBoxFlag xmlns:ma14="http://schemas.microsoft.com/office/mac/drawingml/2011/main" xmlns="" val="0"/>
+              <ma14:wrappingTextBoxFlag xmlns="" xmlns:ma14="http://schemas.microsoft.com/office/mac/drawingml/2011/main" val="0"/>
             </a:ext>
           </a:extLst>
         </p:spPr>
@@ -11620,7 +11675,7 @@
           </a:prstGeom>
           <a:extLst>
             <a:ext uri="{C572A759-6A51-4108-AA02-DFA0A04FC94B}">
-              <ma14:wrappingTextBoxFlag xmlns:ma14="http://schemas.microsoft.com/office/mac/drawingml/2011/main" xmlns="" val="0"/>
+              <ma14:wrappingTextBoxFlag xmlns="" xmlns:ma14="http://schemas.microsoft.com/office/mac/drawingml/2011/main" val="0"/>
             </a:ext>
           </a:extLst>
         </p:spPr>

</xml_diff>

<commit_message>
ADD vidéo de fin et transitions dans la présentation
</commit_message>
<xml_diff>
--- a/livrables/Workshop2025-26-M1gX-pres.pptx
+++ b/livrables/Workshop2025-26-M1gX-pres.pptx
@@ -5,7 +5,7 @@
     <p:sldMasterId id="2147483648" r:id="rId1"/>
   </p:sldMasterIdLst>
   <p:notesMasterIdLst>
-    <p:notesMasterId r:id="rId14"/>
+    <p:notesMasterId r:id="rId15"/>
   </p:notesMasterIdLst>
   <p:sldIdLst>
     <p:sldId id="256" r:id="rId2"/>
@@ -20,6 +20,7 @@
     <p:sldId id="265" r:id="rId11"/>
     <p:sldId id="266" r:id="rId12"/>
     <p:sldId id="267" r:id="rId13"/>
+    <p:sldId id="268" r:id="rId14"/>
   </p:sldIdLst>
   <p:sldSz cx="9144000" cy="5143500" type="screen16x9"/>
   <p:notesSz cx="5143500" cy="9144000"/>
@@ -118,13 +119,13 @@
   <p:extLst>
     <p:ext uri="{521415D9-36F7-43E2-AB2F-B90AF26B5E84}">
       <p14:sectionLst xmlns:p14="http://schemas.microsoft.com/office/powerpoint/2010/main">
-        <p14:section name="Introduction" id="{974C8B78-1B18-8DD5-15EE-16A4368251CE}">
+        <p14:section name="Introduction" id="{2E068CA2-A481-DFBE-A782-43423D8CEF4A}">
           <p14:sldIdLst>
             <p14:sldId id="256"/>
             <p14:sldId id="257"/>
           </p14:sldIdLst>
         </p14:section>
-        <p14:section name="Le jeu" id="{5E9220E4-0DE0-73F0-1518-2C7D5D67CA31}">
+        <p14:section name="Le jeu" id="{F7CE480F-5BBF-38C7-06AC-43C3F34735C2}">
           <p14:sldIdLst>
             <p14:sldId id="258"/>
             <p14:sldId id="259"/>
@@ -133,17 +134,18 @@
             <p14:sldId id="262"/>
           </p14:sldIdLst>
         </p14:section>
-        <p14:section name="Technique" id="{8F3327CF-747D-94DE-77A9-5F1E5D304990}">
+        <p14:section name="Technique" id="{4CD593B6-60D5-EEB9-68E2-34927AE8C078}">
           <p14:sldIdLst>
             <p14:sldId id="263"/>
             <p14:sldId id="264"/>
             <p14:sldId id="265"/>
           </p14:sldIdLst>
         </p14:section>
-        <p14:section name="Projet" id="{D62DE006-CB9F-F0EE-49C1-E2D23D858AF2}">
+        <p14:section name="Projet" id="{760EDF76-8D31-9A3C-39A6-5102BE6A8096}">
           <p14:sldIdLst>
             <p14:sldId id="266"/>
             <p14:sldId id="267"/>
+            <p14:sldId id="268"/>
           </p14:sldIdLst>
         </p14:section>
       </p14:sectionLst>
@@ -180,7 +182,7 @@
     </p:spTree>
     <p:extLst>
       <p:ext uri="{BB962C8B-B14F-4D97-AF65-F5344CB8AC3E}">
-        <p14:creationId xmlns:p14="http://schemas.microsoft.com/office/powerpoint/2010/main" val="722869013"/>
+        <p14:creationId xmlns:p14="http://schemas.microsoft.com/office/powerpoint/2010/main" val="4011242128"/>
       </p:ext>
     </p:extLst>
   </p:cSld>
@@ -330,7 +332,7 @@
 « Bonjour, nous sommes le groupe X et voici Black-out, notre escape game sur le thème de l'environnement. »
 Accroche : « Imaginez : un saboteur pirate le chauffage, l'éclairage et les détecteurs du campus. Tel un gréviste, il veut consolider le blocus du campus, en soutien aux lycéens mobilisés, en provoquant un black-out général. Vous avez 20 minutes pour l'en empêcher… sans gaspiller d'énergie. »
 On enchaîne tout de suite sur la présentation de l'équipe, en anglais.
-Version 5 minutes : gardez les slides 1, 2, 3, 4, 6, 8, 10 et 12 (les autres servent pour les questions ou la version longue). Version 8 à 10 minutes : toutes les slides, environ 45 s chacune.</a:t>
+Version 5 minutes : gardez les slides 1, 2, 3, 4, 6, 8, 10, 12 (vidéo de fin, 14 s) et 13 (les autres servent pour les questions ou la version longue). Version 8 à 10 minutes : toutes les slides, environ 45 s chacune.</a:t>
             </a:r>
           </a:p>
         </p:txBody>
@@ -602,12 +604,9 @@
           <a:p>
             <a:r>
               <a:rPr lang="en-US" dirty="0"/>
-              <a:t>Qui parle : Tasha · Durée : 20 s
-« Black-out, c'est 20 minutes pour déjouer le blocus, deux équipes qui doivent se parler, cinq salles… et des gestes que les lycéens peuvent refaire dès le lendemain. »
-À l'écran : le générique de victoire, fond rose CCI, logo du campus et score de l'équipe.
-« Merci ! Nous avons la console avec nous : si vous voulez, on vous lance une démo de deux salles. Place à vos questions. »
-Démo courte : MODULES=chauffage,eclairage DURATION=420 npm start (ou lancer une partie depuis l'écran du Pi).
-Questions probables à préparer : pourquoi pas de HTTPS (ou comment), que se passe-t-il si le Pi plante, comment ajouter une salle, comment rejouer avec d'autres valeurs, combien coûte le matériel, accessibilité (daltonisme, lecture).</a:t>
+              <a:t>Qui parle : personne · Durée : 14 s
+La vidéo se lance toute seule à l'arrivée sur la slide, avec le son : vérifiez le volume de l'ordinateur avant la soutenance. On la laisse jouer en entier, puis on passe à la slide « À vous de jouer » pour les questions.
+Si elle ne démarre pas (selon la version de PowerPoint) : un clic sur la vidéo la lance.</a:t>
             </a:r>
           </a:p>
         </p:txBody>
@@ -630,6 +629,98 @@
             <a:fld id="{F7021451-1387-4CA6-816F-3879F97B5CBC}" type="slidenum">
               <a:rPr lang="en-US"/>
               <a:t>12</a:t>
+            </a:fld>
+            <a:endParaRPr lang="en-US"/>
+          </a:p>
+        </p:txBody>
+      </p:sp>
+    </p:spTree>
+    <p:extLst>
+      <p:ext uri="{BB962C8B-B14F-4D97-AF65-F5344CB8AC3E}">
+        <p14:creationId xmlns:p14="http://schemas.microsoft.com/office/powerpoint/2010/main" val="1024086991"/>
+      </p:ext>
+    </p:extLst>
+  </p:cSld>
+  <p:clrMapOvr>
+    <a:masterClrMapping/>
+  </p:clrMapOvr>
+</p:notes>
+</file>
+
+<file path=ppt/notesSlides/notesSlide13.xml><?xml version="1.0" encoding="utf-8"?>
+<p:notes xmlns:a="http://schemas.openxmlformats.org/drawingml/2006/main" xmlns:r="http://schemas.openxmlformats.org/officeDocument/2006/relationships" xmlns:p="http://schemas.openxmlformats.org/presentationml/2006/main">
+  <p:cSld>
+    <p:spTree>
+      <p:nvGrpSpPr>
+        <p:cNvPr id="1" name=""/>
+        <p:cNvGrpSpPr/>
+        <p:nvPr/>
+      </p:nvGrpSpPr>
+      <p:grpSpPr>
+        <a:xfrm>
+          <a:off x="0" y="0"/>
+          <a:ext cx="0" cy="0"/>
+          <a:chOff x="0" y="0"/>
+          <a:chExt cx="0" cy="0"/>
+        </a:xfrm>
+      </p:grpSpPr>
+      <p:sp>
+        <p:nvSpPr>
+          <p:cNvPr id="2" name="Slide Image Placeholder 1"/>
+          <p:cNvSpPr>
+            <a:spLocks noGrp="1" noRot="1" noChangeAspect="1"/>
+          </p:cNvSpPr>
+          <p:nvPr>
+            <p:ph type="sldImg"/>
+          </p:nvPr>
+        </p:nvSpPr>
+        <p:spPr/>
+      </p:sp>
+      <p:sp>
+        <p:nvSpPr>
+          <p:cNvPr id="3" name="Notes Placeholder 2"/>
+          <p:cNvSpPr>
+            <a:spLocks noGrp="1"/>
+          </p:cNvSpPr>
+          <p:nvPr>
+            <p:ph type="body" idx="1"/>
+          </p:nvPr>
+        </p:nvSpPr>
+        <p:spPr/>
+        <p:txBody>
+          <a:bodyPr/>
+          <a:lstStyle/>
+          <a:p>
+            <a:r>
+              <a:rPr lang="en-US" dirty="0"/>
+              <a:t>Qui parle : Tasha · Durée : 20 s
+« Black-out, c'est 20 minutes pour déjouer le blocus, deux équipes qui doivent se parler, cinq salles… et des gestes que les lycéens peuvent refaire dès le lendemain. »
+À l'écran : le générique de victoire, fond rose CCI, logo du campus et score de l'équipe.
+« Merci ! Nous avons la console avec nous : si vous voulez, on vous lance une démo de deux salles. Place à vos questions. »
+Démo courte : MODULES=chauffage,eclairage DURATION=420 npm start (ou lancer une partie depuis l'écran du Pi).
+Questions probables à préparer : pourquoi pas de HTTPS (ou comment), que se passe-t-il si le Pi plante, comment ajouter une salle, comment rejouer avec d'autres valeurs, combien coûte le matériel, accessibilité (daltonisme, lecture).</a:t>
+            </a:r>
+          </a:p>
+        </p:txBody>
+      </p:sp>
+      <p:sp>
+        <p:nvSpPr>
+          <p:cNvPr id="4" name="Slide Number Placeholder 3"/>
+          <p:cNvSpPr>
+            <a:spLocks noGrp="1"/>
+          </p:cNvSpPr>
+          <p:nvPr>
+            <p:ph type="sldNum" sz="quarter" idx="10"/>
+          </p:nvPr>
+        </p:nvSpPr>
+        <p:spPr/>
+        <p:txBody>
+          <a:bodyPr/>
+          <a:lstStyle/>
+          <a:p>
+            <a:fld id="{F7021451-1387-4CA6-816F-3879F97B5CBC}" type="slidenum">
+              <a:rPr lang="en-US"/>
+              <a:t>13</a:t>
             </a:fld>
             <a:endParaRPr lang="en-US"/>
           </a:p>
@@ -701,15 +792,7 @@
 - Romain: "I built the Arduino console: seven Modulino sensors and the Grove kit, all talking to the Raspberry Pi through a simple text protocol."
 - Noa: "I wrote the game server in Node.js: it runs the timer, checks the answers and pushes everything in real time."
 - Tasha: "I designed the touch interface for the 7-inch screen and the page the field agents use on their phones."
-- </a:t>
-            </a:r>
-            <a:r>
-              <a:rPr lang="en-US" dirty="0" err="1"/>
-              <a:t>Killiann</a:t>
-            </a:r>
-            <a:r>
-              <a:rPr lang="en-US" dirty="0"/>
-              <a:t>: "I wrote the puzzles and the envelopes, based on real data about energy in buildings."
+- Killiann: "I wrote the puzzles and the envelopes, based on real data about energy in buildings."
 - Léo: "I set up the Raspberry Pi, the network, the database and our documentation."
 Transition (last speaker, back to French): « Et maintenant, place au jeu. »</a:t>
             </a:r>
@@ -798,15 +881,7 @@
           <a:p>
             <a:r>
               <a:rPr lang="en-US" dirty="0"/>
-              <a:t>Qui parle : </a:t>
-            </a:r>
-            <a:r>
-              <a:rPr lang="en-US" dirty="0" err="1"/>
-              <a:t>Killiann</a:t>
-            </a:r>
-            <a:r>
-              <a:rPr lang="en-US" dirty="0"/>
-              <a:t> · Durée : 40 s
+              <a:t>Qui parle : Killiann · Durée : 40 s
 - Le sujet : des agents qui déjouent un plan lié au thème. Le nôtre : l'énergie du bâtiment.
 - L'intrigue : tel un gréviste, un saboteur veut consolider le blocus du campus, en soutien aux lycéens mobilisés, en provoquant un black-out général. Il dérègle tout un mardi à 14 h 20 (l'heure est affichée sur l'écran du QG, toutes les énigmes en dépendent).
 - Les joueurs découvrent cette histoire dans le briefing qui défile sur l'écran d'accueil du QG, à côté du QR code.
@@ -993,15 +1068,7 @@
           <a:p>
             <a:r>
               <a:rPr lang="en-US" dirty="0"/>
-              <a:t>Qui parle : </a:t>
-            </a:r>
-            <a:r>
-              <a:rPr lang="en-US" dirty="0" err="1"/>
-              <a:t>Killiann</a:t>
-            </a:r>
-            <a:r>
-              <a:rPr lang="en-US" dirty="0"/>
-              <a:t> · Durée : 50 s
+              <a:t>Qui parle : Killiann · Durée : 50 s
 Le sujet demande des énigmes variées (logique, maths, réflexion critique) et des objets connectés : chaque salle mobilise une compétence et un capteur différents.
 1. Chauffage : on calcule depuis combien d'heures la salle est vide et on applique la loi. Le QG règle la consigne à la molette.
 2. Éclairage : déduction logique à partir d'un planning ; on éteint les salles vides sur les 8 LEDs.
@@ -1095,15 +1162,7 @@
           <a:p>
             <a:r>
               <a:rPr lang="en-US" dirty="0"/>
-              <a:t>Qui parle : </a:t>
-            </a:r>
-            <a:r>
-              <a:rPr lang="en-US" dirty="0" err="1"/>
-              <a:t>Killiann</a:t>
-            </a:r>
-            <a:r>
-              <a:rPr lang="en-US" dirty="0"/>
-              <a:t> · Durée : 1 min · SLIDE OBLIGATOIRE
+              <a:t>Qui parle : Killiann · Durée : 1 min · SLIDE OBLIGATOIRE
 - Le sujet demande des énigmes basées sur des données réelles : les nôtres viennent du Code de l'énergie (19, 16 et 8 °C), de l'ADEME (7 % d'économie par degré) et du bilan 2024 de RTE (30 g de CO₂ par kWh en cycle de vie, 21,7 g en émissions directes).
 - Les plannings, capteurs et index de compteur sont inventés pour le jeu ; les règles et les chiffres de référence sont réels.
 - Ce que les lycéens travaillent : déduire, calculer, et surtout se parler clairement sous la pression du chrono.
@@ -1383,15 +1442,7 @@
           <a:p>
             <a:r>
               <a:rPr lang="en-US" dirty="0"/>
-              <a:t>Qui parle : Romain (protocole) </a:t>
-            </a:r>
-            <a:r>
-              <a:rPr lang="en-US" dirty="0" err="1"/>
-              <a:t>puis</a:t>
-            </a:r>
-            <a:r>
-              <a:rPr lang="en-US" dirty="0"/>
-              <a:t> Noa · Durée : 40 s
+              <a:t>Qui parle : Romain (protocole) puis Noa · Durée : 40 s
 1. Protocole : l'Arduino envoie par exemple « KNOB 19 » quand on tourne la molette, le Pi répond « LED 3 OK » pour allumer une LED en vert. Une ligne de texte par message : on peut tout tester dans le moniteur série.
 2. Validation : les écrans reçoivent seulement ce qu'ils doivent afficher. Les réponses attendues restent dans le serveur.
 3. Reprise : l'état de la partie est écrit chaque seconde dans un fichier, de façon atomique (pas de fichier à moitié écrit). Le chrono n'avance que quand le serveur tourne : une coupure ne fait pas perdre de temps. Au redémarrage, on ne relance pas la partie d'office : l'accueil affiche « Partie interrompue » avec un bouton Reprendre (même salle, même chrono), ou Nouvelle partie. Testé en coupant le serveur en pleine partie.
@@ -1625,7 +1676,7 @@
           </a:prstGeom>
           <a:extLst>
             <a:ext uri="{C572A759-6A51-4108-AA02-DFA0A04FC94B}">
-              <ma14:wrappingTextBoxFlag xmlns="" xmlns:ma14="http://schemas.microsoft.com/office/mac/drawingml/2011/main" val="0"/>
+              <ma14:wrappingTextBoxFlag xmlns:ma14="http://schemas.microsoft.com/office/mac/drawingml/2011/main" xmlns="" val="0"/>
             </a:ext>
           </a:extLst>
         </p:spPr>
@@ -1783,7 +1834,7 @@
           </a:prstGeom>
           <a:extLst>
             <a:ext uri="{C572A759-6A51-4108-AA02-DFA0A04FC94B}">
-              <ma14:wrappingTextBoxFlag xmlns="" xmlns:ma14="http://schemas.microsoft.com/office/mac/drawingml/2011/main" val="0"/>
+              <ma14:wrappingTextBoxFlag xmlns:ma14="http://schemas.microsoft.com/office/mac/drawingml/2011/main" xmlns="" val="0"/>
             </a:ext>
           </a:extLst>
         </p:spPr>
@@ -1858,7 +1909,7 @@
           </a:prstGeom>
           <a:extLst>
             <a:ext uri="{C572A759-6A51-4108-AA02-DFA0A04FC94B}">
-              <ma14:wrappingTextBoxFlag xmlns="" xmlns:ma14="http://schemas.microsoft.com/office/mac/drawingml/2011/main" val="0"/>
+              <ma14:wrappingTextBoxFlag xmlns:ma14="http://schemas.microsoft.com/office/mac/drawingml/2011/main" xmlns="" val="0"/>
             </a:ext>
           </a:extLst>
         </p:spPr>
@@ -2326,23 +2377,7 @@
                   <a:schemeClr val="accent5"/>
                 </a:solidFill>
               </a:rPr>
-              <a:t>Groupe Les </a:t>
-            </a:r>
-            <a:r>
-              <a:rPr lang="en-US" sz="1400" dirty="0" err="1">
-                <a:solidFill>
-                  <a:schemeClr val="accent5"/>
-                </a:solidFill>
-              </a:rPr>
-              <a:t>Goules</a:t>
-            </a:r>
-            <a:r>
-              <a:rPr lang="en-US" sz="1400" dirty="0">
-                <a:solidFill>
-                  <a:schemeClr val="accent5"/>
-                </a:solidFill>
-              </a:rPr>
-              <a:t>  ·  Thème : Environnement</a:t>
+              <a:t>Groupe Les Goules  ·  Thème : Environnement</a:t>
             </a:r>
             <a:endParaRPr lang="en-US" sz="1400" dirty="0"/>
           </a:p>
@@ -2454,6 +2489,9 @@
   <p:clrMapOvr>
     <a:masterClrMapping/>
   </p:clrMapOvr>
+  <p:transition spd="slow">
+    <p:fade thruBlk="1"/>
+  </p:transition>
 </p:sld>
 </file>
 
@@ -3251,7 +3289,7 @@
           </a:prstGeom>
           <a:extLst>
             <a:ext uri="{C572A759-6A51-4108-AA02-DFA0A04FC94B}">
-              <ma14:wrappingTextBoxFlag xmlns="" xmlns:ma14="http://schemas.microsoft.com/office/mac/drawingml/2011/main" val="0"/>
+              <ma14:wrappingTextBoxFlag xmlns:ma14="http://schemas.microsoft.com/office/mac/drawingml/2011/main" xmlns="" val="0"/>
             </a:ext>
           </a:extLst>
         </p:spPr>
@@ -3281,6 +3319,9 @@
   <p:clrMapOvr>
     <a:masterClrMapping/>
   </p:clrMapOvr>
+  <p:transition spd="med">
+    <p:fade/>
+  </p:transition>
 </p:sld>
 </file>
 
@@ -4334,7 +4375,7 @@
           </a:prstGeom>
           <a:extLst>
             <a:ext uri="{C572A759-6A51-4108-AA02-DFA0A04FC94B}">
-              <ma14:wrappingTextBoxFlag xmlns="" xmlns:ma14="http://schemas.microsoft.com/office/mac/drawingml/2011/main" val="0"/>
+              <ma14:wrappingTextBoxFlag xmlns:ma14="http://schemas.microsoft.com/office/mac/drawingml/2011/main" xmlns="" val="0"/>
             </a:ext>
           </a:extLst>
         </p:spPr>
@@ -4364,6 +4405,9 @@
   <p:clrMapOvr>
     <a:masterClrMapping/>
   </p:clrMapOvr>
+  <p:transition spd="med">
+    <p:push dir="u"/>
+  </p:transition>
 </p:sld>
 </file>
 
@@ -4384,6 +4428,205 @@
           <a:chExt cx="0" cy="0"/>
         </a:xfrm>
       </p:grpSpPr>
+      <p:pic>
+        <p:nvPicPr>
+          <p:cNvPr id="3" name="Vidéo de fin">
+            <a:hlinkClick r:id="" action="ppaction://media"/>
+          </p:cNvPr>
+          <p:cNvPicPr>
+            <a:picLocks noChangeAspect="1"/>
+          </p:cNvPicPr>
+          <p:nvPr>
+            <a:videoFile r:link="rId2"/>
+            <p:extLst>
+              <p:ext uri="{DAA4B4D4-6D71-4841-9C94-3DE7FCFB9230}">
+                <p14:media xmlns:p14="http://schemas.microsoft.com/office/powerpoint/2010/main" r:embed="rId1"/>
+              </p:ext>
+            </p:extLst>
+          </p:nvPr>
+        </p:nvPicPr>
+        <p:blipFill>
+          <a:blip r:embed="rId5"/>
+          <a:stretch>
+            <a:fillRect/>
+          </a:stretch>
+        </p:blipFill>
+        <p:spPr>
+          <a:xfrm>
+            <a:off x="0" y="0"/>
+            <a:ext cx="9144000" cy="5143500"/>
+          </a:xfrm>
+          <a:prstGeom prst="rect">
+            <a:avLst/>
+          </a:prstGeom>
+        </p:spPr>
+      </p:pic>
+    </p:spTree>
+  </p:cSld>
+  <p:clrMapOvr>
+    <a:masterClrMapping/>
+  </p:clrMapOvr>
+  <p:transition spd="slow">
+    <p:fade thruBlk="1"/>
+  </p:transition>
+  <p:timing>
+    <p:tnLst>
+      <p:par>
+        <p:cTn id="1" dur="indefinite" restart="never" nodeType="tmRoot">
+          <p:childTnLst>
+            <p:seq concurrent="1" nextAc="seek">
+              <p:cTn id="2" dur="indefinite" nodeType="mainSeq">
+                <p:childTnLst>
+                  <p:par>
+                    <p:cTn id="3" fill="hold">
+                      <p:stCondLst>
+                        <p:cond delay="indefinite"/>
+                        <p:cond evt="onBegin" delay="0">
+                          <p:tn val="2"/>
+                        </p:cond>
+                      </p:stCondLst>
+                      <p:childTnLst>
+                        <p:par>
+                          <p:cTn id="4" fill="hold">
+                            <p:stCondLst>
+                              <p:cond delay="0"/>
+                            </p:stCondLst>
+                            <p:childTnLst>
+                              <p:par>
+                                <p:cTn id="5" presetID="1" presetClass="mediacall" presetSubtype="0" fill="hold" nodeType="afterEffect">
+                                  <p:stCondLst>
+                                    <p:cond delay="0"/>
+                                  </p:stCondLst>
+                                  <p:childTnLst>
+                                    <p:cmd type="call" cmd="playFrom(0.0)">
+                                      <p:cBhvr>
+                                        <p:cTn id="6" dur="14000" fill="hold"/>
+                                        <p:tgtEl>
+                                          <p:spTgt spid="3"/>
+                                        </p:tgtEl>
+                                      </p:cBhvr>
+                                    </p:cmd>
+                                  </p:childTnLst>
+                                </p:cTn>
+                              </p:par>
+                            </p:childTnLst>
+                          </p:cTn>
+                        </p:par>
+                      </p:childTnLst>
+                    </p:cTn>
+                  </p:par>
+                </p:childTnLst>
+              </p:cTn>
+              <p:prevCondLst>
+                <p:cond evt="onPrev" delay="0">
+                  <p:tgtEl>
+                    <p:sldTgt/>
+                  </p:tgtEl>
+                </p:cond>
+              </p:prevCondLst>
+              <p:nextCondLst>
+                <p:cond evt="onNext" delay="0">
+                  <p:tgtEl>
+                    <p:sldTgt/>
+                  </p:tgtEl>
+                </p:cond>
+              </p:nextCondLst>
+            </p:seq>
+            <p:video>
+              <p:cMediaNode vol="80000">
+                <p:cTn id="7" fill="hold" display="0">
+                  <p:stCondLst>
+                    <p:cond delay="indefinite"/>
+                  </p:stCondLst>
+                </p:cTn>
+                <p:tgtEl>
+                  <p:spTgt spid="3"/>
+                </p:tgtEl>
+              </p:cMediaNode>
+            </p:video>
+            <p:seq concurrent="1" nextAc="seek">
+              <p:cTn id="8" restart="whenNotActive" fill="hold" evtFilter="cancelBubble" nodeType="interactiveSeq">
+                <p:stCondLst>
+                  <p:cond evt="onClick" delay="0">
+                    <p:tgtEl>
+                      <p:spTgt spid="3"/>
+                    </p:tgtEl>
+                  </p:cond>
+                </p:stCondLst>
+                <p:endSync evt="end" delay="0">
+                  <p:rtn val="all"/>
+                </p:endSync>
+                <p:childTnLst>
+                  <p:par>
+                    <p:cTn id="9" fill="hold">
+                      <p:stCondLst>
+                        <p:cond delay="0"/>
+                      </p:stCondLst>
+                      <p:childTnLst>
+                        <p:par>
+                          <p:cTn id="10" fill="hold">
+                            <p:stCondLst>
+                              <p:cond delay="0"/>
+                            </p:stCondLst>
+                            <p:childTnLst>
+                              <p:par>
+                                <p:cTn id="11" presetID="2" presetClass="mediacall" presetSubtype="0" fill="hold" nodeType="clickEffect">
+                                  <p:stCondLst>
+                                    <p:cond delay="0"/>
+                                  </p:stCondLst>
+                                  <p:childTnLst>
+                                    <p:cmd type="call" cmd="togglePause">
+                                      <p:cBhvr>
+                                        <p:cTn id="12" dur="1" fill="hold"/>
+                                        <p:tgtEl>
+                                          <p:spTgt spid="3"/>
+                                        </p:tgtEl>
+                                      </p:cBhvr>
+                                    </p:cmd>
+                                  </p:childTnLst>
+                                </p:cTn>
+                              </p:par>
+                            </p:childTnLst>
+                          </p:cTn>
+                        </p:par>
+                      </p:childTnLst>
+                    </p:cTn>
+                  </p:par>
+                </p:childTnLst>
+              </p:cTn>
+              <p:nextCondLst>
+                <p:cond evt="onClick" delay="0">
+                  <p:tgtEl>
+                    <p:spTgt spid="3"/>
+                  </p:tgtEl>
+                </p:cond>
+              </p:nextCondLst>
+            </p:seq>
+          </p:childTnLst>
+        </p:cTn>
+      </p:par>
+    </p:tnLst>
+  </p:timing>
+</p:sld>
+</file>
+
+<file path=ppt/slides/slide13.xml><?xml version="1.0" encoding="utf-8"?>
+<p:sld xmlns:a="http://schemas.openxmlformats.org/drawingml/2006/main" xmlns:r="http://schemas.openxmlformats.org/officeDocument/2006/relationships" xmlns:p="http://schemas.openxmlformats.org/presentationml/2006/main">
+  <p:cSld name="Slide 13">
+    <p:spTree>
+      <p:nvGrpSpPr>
+        <p:cNvPr id="1" name=""/>
+        <p:cNvGrpSpPr/>
+        <p:nvPr/>
+      </p:nvGrpSpPr>
+      <p:grpSpPr>
+        <a:xfrm>
+          <a:off x="0" y="0"/>
+          <a:ext cx="0" cy="0"/>
+          <a:chOff x="0" y="0"/>
+          <a:chExt cx="0" cy="0"/>
+        </a:xfrm>
+      </p:grpSpPr>
       <p:sp>
         <p:nvSpPr>
           <p:cNvPr id="2" name="Text 1"/>
@@ -4674,7 +4917,7 @@
           </a:prstGeom>
           <a:extLst>
             <a:ext uri="{C572A759-6A51-4108-AA02-DFA0A04FC94B}">
-              <ma14:wrappingTextBoxFlag xmlns="" xmlns:ma14="http://schemas.microsoft.com/office/mac/drawingml/2011/main" val="0"/>
+              <ma14:wrappingTextBoxFlag xmlns:ma14="http://schemas.microsoft.com/office/mac/drawingml/2011/main" xmlns="" val="0"/>
             </a:ext>
           </a:extLst>
         </p:spPr>
@@ -4693,7 +4936,7 @@
             <a:pPr algn="r"/>
             <a:fld id="{F7021451-1387-4CA6-816F-3879F97B5CBC}" type="slidenum">
               <a:rPr lang="en-US" b="0"/>
-              <a:t>12</a:t>
+              <a:t>13</a:t>
             </a:fld>
             <a:endParaRPr lang="en-US"/>
           </a:p>
@@ -4704,6 +4947,9 @@
   <p:clrMapOvr>
     <a:masterClrMapping/>
   </p:clrMapOvr>
+  <p:transition spd="med">
+    <p:fade/>
+  </p:transition>
 </p:sld>
 </file>
 
@@ -4882,7 +5128,11 @@
               <a:buNone/>
             </a:pPr>
             <a:r>
-              <a:rPr lang="en-US" sz="1400" b="1" dirty="0"/>
+              <a:rPr lang="en-US" sz="1400" b="1" dirty="0">
+                <a:solidFill>
+                  <a:schemeClr val="tx1"/>
+                </a:solidFill>
+              </a:rPr>
               <a:t>Romain MARDARGENT</a:t>
             </a:r>
             <a:endParaRPr lang="en-US" sz="1400" dirty="0"/>
@@ -5076,9 +5326,14 @@
               <a:buNone/>
             </a:pPr>
             <a:r>
-              <a:rPr lang="en-US" sz="1400" b="1" dirty="0"/>
+              <a:rPr lang="en-US" sz="1400" b="1" dirty="0">
+                <a:solidFill>
+                  <a:schemeClr val="tx1"/>
+                </a:solidFill>
+              </a:rPr>
               <a:t>Noa GUIGNOLLE</a:t>
             </a:r>
+            <a:endParaRPr lang="en-US" sz="1400" dirty="0"/>
           </a:p>
         </p:txBody>
       </p:sp>
@@ -5467,20 +5722,12 @@
               <a:buNone/>
             </a:pPr>
             <a:r>
-              <a:rPr lang="en-US" sz="1400" b="1" dirty="0" err="1">
+              <a:rPr lang="en-US" sz="1400" b="1" dirty="0">
                 <a:solidFill>
                   <a:schemeClr val="tx1"/>
                 </a:solidFill>
               </a:rPr>
-              <a:t>Killiann</a:t>
-            </a:r>
-            <a:r>
-              <a:rPr lang="en-US" sz="1400" b="1" dirty="0">
-                <a:solidFill>
-                  <a:schemeClr val="tx1"/>
-                </a:solidFill>
-              </a:rPr>
-              <a:t> ODDO</a:t>
+              <a:t>Killiann ODDO</a:t>
             </a:r>
             <a:endParaRPr lang="en-US" sz="1400" dirty="0"/>
           </a:p>
@@ -5812,7 +6059,7 @@
           </a:prstGeom>
           <a:extLst>
             <a:ext uri="{C572A759-6A51-4108-AA02-DFA0A04FC94B}">
-              <ma14:wrappingTextBoxFlag xmlns="" xmlns:ma14="http://schemas.microsoft.com/office/mac/drawingml/2011/main" val="0"/>
+              <ma14:wrappingTextBoxFlag xmlns:ma14="http://schemas.microsoft.com/office/mac/drawingml/2011/main" xmlns="" val="0"/>
             </a:ext>
           </a:extLst>
         </p:spPr>
@@ -5842,6 +6089,9 @@
   <p:clrMapOvr>
     <a:masterClrMapping/>
   </p:clrMapOvr>
+  <p:transition spd="med">
+    <p:fade/>
+  </p:transition>
 </p:sld>
 </file>
 
@@ -6431,7 +6681,7 @@
           </a:prstGeom>
           <a:extLst>
             <a:ext uri="{C572A759-6A51-4108-AA02-DFA0A04FC94B}">
-              <ma14:wrappingTextBoxFlag xmlns="" xmlns:ma14="http://schemas.microsoft.com/office/mac/drawingml/2011/main" val="0"/>
+              <ma14:wrappingTextBoxFlag xmlns:ma14="http://schemas.microsoft.com/office/mac/drawingml/2011/main" xmlns="" val="0"/>
             </a:ext>
           </a:extLst>
         </p:spPr>
@@ -6461,6 +6711,9 @@
   <p:clrMapOvr>
     <a:masterClrMapping/>
   </p:clrMapOvr>
+  <p:transition spd="med">
+    <p:push dir="u"/>
+  </p:transition>
 </p:sld>
 </file>
 
@@ -7378,7 +7631,7 @@
           </a:prstGeom>
           <a:extLst>
             <a:ext uri="{C572A759-6A51-4108-AA02-DFA0A04FC94B}">
-              <ma14:wrappingTextBoxFlag xmlns="" xmlns:ma14="http://schemas.microsoft.com/office/mac/drawingml/2011/main" val="0"/>
+              <ma14:wrappingTextBoxFlag xmlns:ma14="http://schemas.microsoft.com/office/mac/drawingml/2011/main" xmlns="" val="0"/>
             </a:ext>
           </a:extLst>
         </p:spPr>
@@ -7408,6 +7661,9 @@
   <p:clrMapOvr>
     <a:masterClrMapping/>
   </p:clrMapOvr>
+  <p:transition spd="med">
+    <p:fade/>
+  </p:transition>
 </p:sld>
 </file>
 
@@ -8481,7 +8737,7 @@
           </a:prstGeom>
           <a:extLst>
             <a:ext uri="{C572A759-6A51-4108-AA02-DFA0A04FC94B}">
-              <ma14:wrappingTextBoxFlag xmlns="" xmlns:ma14="http://schemas.microsoft.com/office/mac/drawingml/2011/main" val="0"/>
+              <ma14:wrappingTextBoxFlag xmlns:ma14="http://schemas.microsoft.com/office/mac/drawingml/2011/main" xmlns="" val="0"/>
             </a:ext>
           </a:extLst>
         </p:spPr>
@@ -8511,6 +8767,9 @@
   <p:clrMapOvr>
     <a:masterClrMapping/>
   </p:clrMapOvr>
+  <p:transition spd="med">
+    <p:fade/>
+  </p:transition>
 </p:sld>
 </file>
 
@@ -9133,7 +9392,7 @@
           </a:prstGeom>
           <a:extLst>
             <a:ext uri="{C572A759-6A51-4108-AA02-DFA0A04FC94B}">
-              <ma14:wrappingTextBoxFlag xmlns="" xmlns:ma14="http://schemas.microsoft.com/office/mac/drawingml/2011/main" val="0"/>
+              <ma14:wrappingTextBoxFlag xmlns:ma14="http://schemas.microsoft.com/office/mac/drawingml/2011/main" xmlns="" val="0"/>
             </a:ext>
           </a:extLst>
         </p:spPr>
@@ -9163,6 +9422,9 @@
   <p:clrMapOvr>
     <a:masterClrMapping/>
   </p:clrMapOvr>
+  <p:transition spd="med">
+    <p:fade/>
+  </p:transition>
 </p:sld>
 </file>
 
@@ -9953,7 +10215,7 @@
           </a:prstGeom>
           <a:extLst>
             <a:ext uri="{C572A759-6A51-4108-AA02-DFA0A04FC94B}">
-              <ma14:wrappingTextBoxFlag xmlns="" xmlns:ma14="http://schemas.microsoft.com/office/mac/drawingml/2011/main" val="0"/>
+              <ma14:wrappingTextBoxFlag xmlns:ma14="http://schemas.microsoft.com/office/mac/drawingml/2011/main" xmlns="" val="0"/>
             </a:ext>
           </a:extLst>
         </p:spPr>
@@ -9983,6 +10245,9 @@
   <p:clrMapOvr>
     <a:masterClrMapping/>
   </p:clrMapOvr>
+  <p:transition spd="med">
+    <p:fade/>
+  </p:transition>
 </p:sld>
 </file>
 
@@ -11030,7 +11295,7 @@
           </a:prstGeom>
           <a:extLst>
             <a:ext uri="{C572A759-6A51-4108-AA02-DFA0A04FC94B}">
-              <ma14:wrappingTextBoxFlag xmlns="" xmlns:ma14="http://schemas.microsoft.com/office/mac/drawingml/2011/main" val="0"/>
+              <ma14:wrappingTextBoxFlag xmlns:ma14="http://schemas.microsoft.com/office/mac/drawingml/2011/main" xmlns="" val="0"/>
             </a:ext>
           </a:extLst>
         </p:spPr>
@@ -11060,6 +11325,9 @@
   <p:clrMapOvr>
     <a:masterClrMapping/>
   </p:clrMapOvr>
+  <p:transition spd="med">
+    <p:push dir="u"/>
+  </p:transition>
 </p:sld>
 </file>
 
@@ -11675,7 +11943,7 @@
           </a:prstGeom>
           <a:extLst>
             <a:ext uri="{C572A759-6A51-4108-AA02-DFA0A04FC94B}">
-              <ma14:wrappingTextBoxFlag xmlns="" xmlns:ma14="http://schemas.microsoft.com/office/mac/drawingml/2011/main" val="0"/>
+              <ma14:wrappingTextBoxFlag xmlns:ma14="http://schemas.microsoft.com/office/mac/drawingml/2011/main" xmlns="" val="0"/>
             </a:ext>
           </a:extLst>
         </p:spPr>
@@ -11705,6 +11973,9 @@
   <p:clrMapOvr>
     <a:masterClrMapping/>
   </p:clrMapOvr>
+  <p:transition spd="med">
+    <p:fade/>
+  </p:transition>
 </p:sld>
 </file>
 

</xml_diff>